<commit_message>
Week 2: what the bag throws away - loss demo for bag-of-words and bag-of-pixels
Notebook demo, two runnable halves: identical word-bags with opposite
meanings ('the critics loved it, the public did not' vs. its reversal, plus
the negation pair), and a drawn composition beside its shuffled pixels -
same average color, brightness, and histogram, only one a picture. Order,
negation, and who-did-what are the text casualties; composition the image
one. Framed as the model's defining trade, named as part of the method,
with Week 5's embeddings as the answer to exactly this loss.

Deck gains a matching key-points slide; the hand bag-of-words block in the
lesson plan and site flow closes with the demonstration.
</commit_message>
<xml_diff>
--- a/slides/pptx/week-02.pptx
+++ b/slides/pptx/week-02.pptx
@@ -17,9 +17,10 @@
     <p:sldId id="265" r:id="rId11"/>
     <p:sldId id="266" r:id="rId12"/>
     <p:sldId id="267" r:id="rId13"/>
+    <p:sldId id="268" r:id="rId14"/>
   </p:sldIdLst>
   <p:notesMasterIdLst>
-    <p:notesMasterId r:id="rId14"/>
+    <p:notesMasterId r:id="rId15"/>
   </p:notesMasterIdLst>
   <p:sldSz cx="12191695" cy="6858000"/>
   <p:notesSz cx="6858000" cy="12191695"/>
@@ -819,6 +820,94 @@
 </p:notes>
 </file>
 
+<file path=ppt/notesSlides/notesSlide13.xml><?xml version="1.0" encoding="utf-8"?>
+<p:notes xmlns:a="http://schemas.openxmlformats.org/drawingml/2006/main" xmlns:r="http://schemas.openxmlformats.org/officeDocument/2006/relationships" xmlns:p="http://schemas.openxmlformats.org/presentationml/2006/main">
+  <p:cSld>
+    <p:spTree>
+      <p:nvGrpSpPr>
+        <p:cNvPr id="1" name=""/>
+        <p:cNvGrpSpPr/>
+        <p:nvPr/>
+      </p:nvGrpSpPr>
+      <p:grpSpPr>
+        <a:xfrm>
+          <a:off x="0" y="0"/>
+          <a:ext cx="0" cy="0"/>
+          <a:chOff x="0" y="0"/>
+          <a:chExt cx="0" cy="0"/>
+        </a:xfrm>
+      </p:grpSpPr>
+      <p:sp>
+        <p:nvSpPr>
+          <p:cNvPr id="2" name="Slide Image Placeholder 1"/>
+          <p:cNvSpPr>
+            <a:spLocks noGrp="1" noRot="1" noChangeAspect="1"/>
+          </p:cNvSpPr>
+          <p:nvPr>
+            <p:ph type="sldImg"/>
+          </p:nvPr>
+        </p:nvSpPr>
+        <p:spPr/>
+      </p:sp>
+      <p:sp>
+        <p:nvSpPr>
+          <p:cNvPr id="3" name="Notes Placeholder 2"/>
+          <p:cNvSpPr>
+            <a:spLocks noGrp="1"/>
+          </p:cNvSpPr>
+          <p:nvPr>
+            <p:ph type="body" idx="1"/>
+          </p:nvPr>
+        </p:nvSpPr>
+        <p:spPr/>
+        <p:txBody>
+          <a:bodyPr/>
+          <a:lstStyle/>
+          <a:p>
+            <a:r>
+              <a:rPr lang="en-US" dirty="0"/>
+              <a:t/>
+            </a:r>
+            <a:endParaRPr lang="en-US" dirty="0"/>
+          </a:p>
+        </p:txBody>
+      </p:sp>
+      <p:sp>
+        <p:nvSpPr>
+          <p:cNvPr id="4" name="Slide Number Placeholder 3"/>
+          <p:cNvSpPr>
+            <a:spLocks noGrp="1"/>
+          </p:cNvSpPr>
+          <p:nvPr>
+            <p:ph type="sldNum" sz="quarter" idx="10"/>
+          </p:nvPr>
+        </p:nvSpPr>
+        <p:spPr/>
+        <p:txBody>
+          <a:bodyPr/>
+          <a:lstStyle/>
+          <a:p>
+            <a:fld id="{F7021451-1387-4CA6-816F-3879F97B5CBC}" type="slidenum">
+              <a:rPr lang="en-US"/>
+              <a:t>13</a:t>
+            </a:fld>
+            <a:endParaRPr lang="en-US"/>
+          </a:p>
+        </p:txBody>
+      </p:sp>
+    </p:spTree>
+    <p:extLst>
+      <p:ext uri="{BB962C8B-B14F-4D97-AF65-F5344CB8AC3E}">
+        <p14:creationId xmlns:p14="http://schemas.microsoft.com/office/powerpoint/2010/main" val="1024086991"/>
+      </p:ext>
+    </p:extLst>
+  </p:cSld>
+  <p:clrMapOvr>
+    <a:masterClrMapping/>
+  </p:clrMapOvr>
+</p:notes>
+</file>
+
 <file path=ppt/notesSlides/notesSlide2.xml><?xml version="1.0" encoding="utf-8"?>
 <p:notes xmlns:a="http://schemas.openxmlformats.org/drawingml/2006/main" xmlns:r="http://schemas.openxmlformats.org/officeDocument/2006/relationships" xmlns:p="http://schemas.openxmlformats.org/presentationml/2006/main">
   <p:cSld>
@@ -2438,7 +2527,7 @@
                 <a:ea typeface="Cambria" pitchFamily="34" charset="-122"/>
                 <a:cs typeface="Cambria" pitchFamily="34" charset="-120"/>
               </a:rPr>
-              <a:t>Reading &amp; homework</a:t>
+              <a:t>The session</a:t>
             </a:r>
             <a:endParaRPr lang="en-US" sz="3000" dirty="0"/>
           </a:p>
@@ -2452,11 +2541,13 @@
         </p:nvSpPr>
         <p:spPr>
           <a:xfrm>
-            <a:off x="640080" y="1673352"/>
-            <a:ext cx="219456" cy="219456"/>
-          </a:xfrm>
-          <a:prstGeom prst="ellipse">
-            <a:avLst/>
+            <a:off x="640080" y="1572768"/>
+            <a:ext cx="868680" cy="338328"/>
+          </a:xfrm>
+          <a:prstGeom prst="roundRect">
+            <a:avLst>
+              <a:gd name="adj" fmla="val 16216"/>
+            </a:avLst>
           </a:prstGeom>
           <a:solidFill>
             <a:srgbClr val="7A3B2E"/>
@@ -2472,8 +2563,8 @@
         </p:nvSpPr>
         <p:spPr>
           <a:xfrm>
-            <a:off x="1051560" y="1600200"/>
-            <a:ext cx="10424160" cy="365760"/>
+            <a:off x="640080" y="1572768"/>
+            <a:ext cx="868680" cy="338328"/>
           </a:xfrm>
           <a:prstGeom prst="rect">
             <a:avLst/>
@@ -2485,21 +2576,21 @@
           <a:bodyPr wrap="square" rtlCol="0" anchor="ctr"/>
           <a:lstStyle/>
           <a:p>
-            <a:pPr indent="0" marL="0">
-              <a:buNone/>
-            </a:pPr>
-            <a:r>
-              <a:rPr lang="en-US" sz="1500" b="1" dirty="0">
-                <a:solidFill>
-                  <a:srgbClr val="7A3B2E"/>
+            <a:pPr algn="ctr" indent="0" marL="0">
+              <a:buNone/>
+            </a:pPr>
+            <a:r>
+              <a:rPr lang="en-US" sz="1100" b="1" dirty="0">
+                <a:solidFill>
+                  <a:srgbClr val="FFFFFF"/>
                 </a:solidFill>
                 <a:latin typeface="Calibri" pitchFamily="34" charset="0"/>
                 <a:ea typeface="Calibri" pitchFamily="34" charset="-122"/>
                 <a:cs typeface="Calibri" pitchFamily="34" charset="-120"/>
               </a:rPr>
-              <a:t>Reading</a:t>
-            </a:r>
-            <a:endParaRPr lang="en-US" sz="1500" dirty="0"/>
+              <a:t>0:00</a:t>
+            </a:r>
+            <a:endParaRPr lang="en-US" sz="1100" dirty="0"/>
           </a:p>
         </p:txBody>
       </p:sp>
@@ -2511,17 +2602,17 @@
         </p:nvSpPr>
         <p:spPr>
           <a:xfrm>
-            <a:off x="1051560" y="1984248"/>
-            <a:ext cx="10424160" cy="731520"/>
-          </a:xfrm>
-          <a:prstGeom prst="rect">
-            <a:avLst/>
-          </a:prstGeom>
-          <a:noFill/>
-          <a:ln/>
-        </p:spPr>
-        <p:txBody>
-          <a:bodyPr wrap="square" rtlCol="0" anchor="t">
+            <a:off x="1691640" y="1554480"/>
+            <a:ext cx="9646920" cy="448056"/>
+          </a:xfrm>
+          <a:prstGeom prst="rect">
+            <a:avLst/>
+          </a:prstGeom>
+          <a:noFill/>
+          <a:ln/>
+        </p:spPr>
+        <p:txBody>
+          <a:bodyPr wrap="square" rtlCol="0" anchor="ctr">
             <a:spAutoFit/>
           </a:bodyPr>
           <a:lstStyle/>
@@ -2530,7 +2621,7 @@
               <a:buNone/>
             </a:pPr>
             <a:r>
-              <a:rPr lang="en-US" sz="1400" dirty="0">
+              <a:rPr lang="en-US" sz="1100" dirty="0">
                 <a:solidFill>
                   <a:srgbClr val="1A1A1A"/>
                 </a:solidFill>
@@ -2538,9 +2629,9 @@
                 <a:ea typeface="Calibri" pitchFamily="34" charset="-122"/>
                 <a:cs typeface="Calibri" pitchFamily="34" charset="-120"/>
               </a:rPr>
-              <a:t>Wolfram, What Is ChatGPT Doing (opening sections only)</a:t>
-            </a:r>
-            <a:endParaRPr lang="en-US" sz="1400" dirty="0"/>
+              <a:t>Warm-up retrieval.</a:t>
+            </a:r>
+            <a:endParaRPr lang="en-US" sz="1100" dirty="0"/>
           </a:p>
         </p:txBody>
       </p:sp>
@@ -2552,14 +2643,16 @@
         </p:nvSpPr>
         <p:spPr>
           <a:xfrm>
-            <a:off x="640080" y="2633472"/>
-            <a:ext cx="219456" cy="219456"/>
-          </a:xfrm>
-          <a:prstGeom prst="ellipse">
-            <a:avLst/>
-          </a:prstGeom>
-          <a:solidFill>
-            <a:srgbClr val="3F6F5F"/>
+            <a:off x="640080" y="2020824"/>
+            <a:ext cx="868680" cy="338328"/>
+          </a:xfrm>
+          <a:prstGeom prst="roundRect">
+            <a:avLst>
+              <a:gd name="adj" fmla="val 16216"/>
+            </a:avLst>
+          </a:prstGeom>
+          <a:solidFill>
+            <a:srgbClr val="7A3B2E"/>
           </a:solidFill>
           <a:ln/>
         </p:spPr>
@@ -2572,8 +2665,8 @@
         </p:nvSpPr>
         <p:spPr>
           <a:xfrm>
-            <a:off x="1051560" y="2560320"/>
-            <a:ext cx="10424160" cy="365760"/>
+            <a:off x="640080" y="2020824"/>
+            <a:ext cx="868680" cy="338328"/>
           </a:xfrm>
           <a:prstGeom prst="rect">
             <a:avLst/>
@@ -2585,21 +2678,21 @@
           <a:bodyPr wrap="square" rtlCol="0" anchor="ctr"/>
           <a:lstStyle/>
           <a:p>
-            <a:pPr indent="0" marL="0">
-              <a:buNone/>
-            </a:pPr>
-            <a:r>
-              <a:rPr lang="en-US" sz="1500" b="1" dirty="0">
-                <a:solidFill>
-                  <a:srgbClr val="3F6F5F"/>
+            <a:pPr algn="ctr" indent="0" marL="0">
+              <a:buNone/>
+            </a:pPr>
+            <a:r>
+              <a:rPr lang="en-US" sz="1100" b="1" dirty="0">
+                <a:solidFill>
+                  <a:srgbClr val="FFFFFF"/>
                 </a:solidFill>
                 <a:latin typeface="Calibri" pitchFamily="34" charset="0"/>
                 <a:ea typeface="Calibri" pitchFamily="34" charset="-122"/>
                 <a:cs typeface="Calibri" pitchFamily="34" charset="-120"/>
               </a:rPr>
-              <a:t>Supplement</a:t>
-            </a:r>
-            <a:endParaRPr lang="en-US" sz="1500" dirty="0"/>
+              <a:t>0:05</a:t>
+            </a:r>
+            <a:endParaRPr lang="en-US" sz="1100" dirty="0"/>
           </a:p>
         </p:txBody>
       </p:sp>
@@ -2611,17 +2704,17 @@
         </p:nvSpPr>
         <p:spPr>
           <a:xfrm>
-            <a:off x="1051560" y="2944368"/>
-            <a:ext cx="10424160" cy="731520"/>
-          </a:xfrm>
-          <a:prstGeom prst="rect">
-            <a:avLst/>
-          </a:prstGeom>
-          <a:noFill/>
-          <a:ln/>
-        </p:spPr>
-        <p:txBody>
-          <a:bodyPr wrap="square" rtlCol="0" anchor="t">
+            <a:off x="1691640" y="2002536"/>
+            <a:ext cx="9646920" cy="448056"/>
+          </a:xfrm>
+          <a:prstGeom prst="rect">
+            <a:avLst/>
+          </a:prstGeom>
+          <a:noFill/>
+          <a:ln/>
+        </p:spPr>
+        <p:txBody>
+          <a:bodyPr wrap="square" rtlCol="0" anchor="ctr">
             <a:spAutoFit/>
           </a:bodyPr>
           <a:lstStyle/>
@@ -2630,7 +2723,7 @@
               <a:buNone/>
             </a:pPr>
             <a:r>
-              <a:rPr lang="en-US" sz="1400" dirty="0">
+              <a:rPr lang="en-US" sz="1100" dirty="0">
                 <a:solidFill>
                   <a:srgbClr val="1A1A1A"/>
                 </a:solidFill>
@@ -2638,9 +2731,9 @@
                 <a:ea typeface="Calibri" pitchFamily="34" charset="-122"/>
                 <a:cs typeface="Calibri" pitchFamily="34" charset="-120"/>
               </a:rPr>
-              <a:t>Zipf's law, the straight line in every text</a:t>
-            </a:r>
-            <a:endParaRPr lang="en-US" sz="1400" dirty="0"/>
+              <a:t>The trial: claim, objection, re-run-without-fiction rebuttal, "interpret with care." One named choice is the chart: the hockey-stick shape depends on its y-axis and smoothing.</a:t>
+            </a:r>
+            <a:endParaRPr lang="en-US" sz="1100" dirty="0"/>
           </a:p>
         </p:txBody>
       </p:sp>
@@ -2652,14 +2745,16 @@
         </p:nvSpPr>
         <p:spPr>
           <a:xfrm>
-            <a:off x="640080" y="3593592"/>
-            <a:ext cx="219456" cy="219456"/>
-          </a:xfrm>
-          <a:prstGeom prst="ellipse">
-            <a:avLst/>
-          </a:prstGeom>
-          <a:solidFill>
-            <a:srgbClr val="B9852F"/>
+            <a:off x="640080" y="2468880"/>
+            <a:ext cx="868680" cy="338328"/>
+          </a:xfrm>
+          <a:prstGeom prst="roundRect">
+            <a:avLst>
+              <a:gd name="adj" fmla="val 16216"/>
+            </a:avLst>
+          </a:prstGeom>
+          <a:solidFill>
+            <a:srgbClr val="7A3B2E"/>
           </a:solidFill>
           <a:ln/>
         </p:spPr>
@@ -2672,8 +2767,8 @@
         </p:nvSpPr>
         <p:spPr>
           <a:xfrm>
-            <a:off x="1051560" y="3520440"/>
-            <a:ext cx="10424160" cy="365760"/>
+            <a:off x="640080" y="2468880"/>
+            <a:ext cx="868680" cy="338328"/>
           </a:xfrm>
           <a:prstGeom prst="rect">
             <a:avLst/>
@@ -2685,21 +2780,21 @@
           <a:bodyPr wrap="square" rtlCol="0" anchor="ctr"/>
           <a:lstStyle/>
           <a:p>
-            <a:pPr indent="0" marL="0">
-              <a:buNone/>
-            </a:pPr>
-            <a:r>
-              <a:rPr lang="en-US" sz="1500" b="1" dirty="0">
-                <a:solidFill>
-                  <a:srgbClr val="B9852F"/>
+            <a:pPr algn="ctr" indent="0" marL="0">
+              <a:buNone/>
+            </a:pPr>
+            <a:r>
+              <a:rPr lang="en-US" sz="1100" b="1" dirty="0">
+                <a:solidFill>
+                  <a:srgbClr val="FFFFFF"/>
                 </a:solidFill>
                 <a:latin typeface="Calibri" pitchFamily="34" charset="0"/>
                 <a:ea typeface="Calibri" pitchFamily="34" charset="-122"/>
                 <a:cs typeface="Calibri" pitchFamily="34" charset="-120"/>
               </a:rPr>
-              <a:t>Deeper (optional)</a:t>
-            </a:r>
-            <a:endParaRPr lang="en-US" sz="1500" dirty="0"/>
+              <a:t>0:25</a:t>
+            </a:r>
+            <a:endParaRPr lang="en-US" sz="1100" dirty="0"/>
           </a:p>
         </p:txBody>
       </p:sp>
@@ -2711,17 +2806,17 @@
         </p:nvSpPr>
         <p:spPr>
           <a:xfrm>
-            <a:off x="1051560" y="3904488"/>
-            <a:ext cx="10424160" cy="731520"/>
-          </a:xfrm>
-          <a:prstGeom prst="rect">
-            <a:avLst/>
-          </a:prstGeom>
-          <a:noFill/>
-          <a:ln/>
-        </p:spPr>
-        <p:txBody>
-          <a:bodyPr wrap="square" rtlCol="0" anchor="t">
+            <a:off x="1691640" y="2450592"/>
+            <a:ext cx="9646920" cy="448056"/>
+          </a:xfrm>
+          <a:prstGeom prst="rect">
+            <a:avLst/>
+          </a:prstGeom>
+          <a:noFill/>
+          <a:ln/>
+        </p:spPr>
+        <p:txBody>
+          <a:bodyPr wrap="square" rtlCol="0" anchor="ctr">
             <a:spAutoFit/>
           </a:bodyPr>
           <a:lstStyle/>
@@ -2730,7 +2825,7 @@
               <a:buNone/>
             </a:pPr>
             <a:r>
-              <a:rPr lang="en-US" sz="1400" dirty="0">
+              <a:rPr lang="en-US" sz="1100" dirty="0">
                 <a:solidFill>
                   <a:srgbClr val="1A1A1A"/>
                 </a:solidFill>
@@ -2738,9 +2833,9 @@
                 <a:ea typeface="Calibri" pitchFamily="34" charset="-122"/>
                 <a:cs typeface="Calibri" pitchFamily="34" charset="-120"/>
               </a:rPr>
-              <a:t>Grimmer &amp;amp; Stewart, Text as Data (2013), §1–4: all quantitative models of language are wrong, but some are useful</a:t>
-            </a:r>
-            <a:endParaRPr lang="en-US" sz="1400" dirty="0"/>
+              <a:t>A brief demonstration before the complications: the words one artist uses far more than everyone else, a signature vocabulary measured against a pop baseline.</a:t>
+            </a:r>
+            <a:endParaRPr lang="en-US" sz="1100" dirty="0"/>
           </a:p>
         </p:txBody>
       </p:sp>
@@ -2752,14 +2847,16 @@
         </p:nvSpPr>
         <p:spPr>
           <a:xfrm>
-            <a:off x="640080" y="4553712"/>
-            <a:ext cx="219456" cy="219456"/>
-          </a:xfrm>
-          <a:prstGeom prst="ellipse">
-            <a:avLst/>
-          </a:prstGeom>
-          <a:solidFill>
-            <a:srgbClr val="3F6F5F"/>
+            <a:off x="640080" y="2916936"/>
+            <a:ext cx="868680" cy="338328"/>
+          </a:xfrm>
+          <a:prstGeom prst="roundRect">
+            <a:avLst>
+              <a:gd name="adj" fmla="val 16216"/>
+            </a:avLst>
+          </a:prstGeom>
+          <a:solidFill>
+            <a:srgbClr val="7A3B2E"/>
           </a:solidFill>
           <a:ln/>
         </p:spPr>
@@ -2772,8 +2869,8 @@
         </p:nvSpPr>
         <p:spPr>
           <a:xfrm>
-            <a:off x="1051560" y="4480560"/>
-            <a:ext cx="10424160" cy="365760"/>
+            <a:off x="640080" y="2916936"/>
+            <a:ext cx="868680" cy="338328"/>
           </a:xfrm>
           <a:prstGeom prst="rect">
             <a:avLst/>
@@ -2785,21 +2882,21 @@
           <a:bodyPr wrap="square" rtlCol="0" anchor="ctr"/>
           <a:lstStyle/>
           <a:p>
-            <a:pPr indent="0" marL="0">
-              <a:buNone/>
-            </a:pPr>
-            <a:r>
-              <a:rPr lang="en-US" sz="1500" b="1" dirty="0">
-                <a:solidFill>
-                  <a:srgbClr val="3F6F5F"/>
+            <a:pPr algn="ctr" indent="0" marL="0">
+              <a:buNone/>
+            </a:pPr>
+            <a:r>
+              <a:rPr lang="en-US" sz="1100" b="1" dirty="0">
+                <a:solidFill>
+                  <a:srgbClr val="FFFFFF"/>
                 </a:solidFill>
                 <a:latin typeface="Calibri" pitchFamily="34" charset="0"/>
                 <a:ea typeface="Calibri" pitchFamily="34" charset="-122"/>
                 <a:cs typeface="Calibri" pitchFamily="34" charset="-120"/>
               </a:rPr>
-              <a:t>Sketch</a:t>
-            </a:r>
-            <a:endParaRPr lang="en-US" sz="1500" dirty="0"/>
+              <a:t>0:30</a:t>
+            </a:r>
+            <a:endParaRPr lang="en-US" sz="1100" dirty="0"/>
           </a:p>
         </p:txBody>
       </p:sp>
@@ -2811,17 +2908,17 @@
         </p:nvSpPr>
         <p:spPr>
           <a:xfrm>
-            <a:off x="1051560" y="4864608"/>
-            <a:ext cx="10424160" cy="731520"/>
-          </a:xfrm>
-          <a:prstGeom prst="rect">
-            <a:avLst/>
-          </a:prstGeom>
-          <a:noFill/>
-          <a:ln/>
-        </p:spPr>
-        <p:txBody>
-          <a:bodyPr wrap="square" rtlCol="0" anchor="t">
+            <a:off x="1691640" y="2898648"/>
+            <a:ext cx="9646920" cy="448056"/>
+          </a:xfrm>
+          <a:prstGeom prst="rect">
+            <a:avLst/>
+          </a:prstGeom>
+          <a:noFill/>
+          <a:ln/>
+        </p:spPr>
+        <p:txBody>
+          <a:bodyPr wrap="square" rtlCol="0" anchor="ctr">
             <a:spAutoFit/>
           </a:bodyPr>
           <a:lstStyle/>
@@ -2830,7 +2927,7 @@
               <a:buNone/>
             </a:pPr>
             <a:r>
-              <a:rPr lang="en-US" sz="1400" dirty="0">
+              <a:rPr lang="en-US" sz="1100" dirty="0">
                 <a:solidFill>
                   <a:srgbClr val="1A1A1A"/>
                 </a:solidFill>
@@ -2838,9 +2935,9 @@
                 <a:ea typeface="Calibri" pitchFamily="34" charset="-122"/>
                 <a:cs typeface="Calibri" pitchFamily="34" charset="-120"/>
               </a:rPr>
-              <a:t>Count something in a text you care about; one chart; one sentence naming a choice. If the count compares two things, shuffle-test the gap.</a:t>
-            </a:r>
-            <a:endParaRPr lang="en-US" sz="1400" dirty="0"/>
+              <a:t>Hand-built bag-of-words: two authors, highlighters, argue about merging run/running. Counting requires defining. Close with the loss demonstration: two sentences with identical bags and opposite meanings, and a picture beside its shuffled pixels, so the trade the bag makes is on the table before anything scales up.</a:t>
+            </a:r>
+            <a:endParaRPr lang="en-US" sz="1100" dirty="0"/>
           </a:p>
         </p:txBody>
       </p:sp>
@@ -2852,11 +2949,13 @@
         </p:nvSpPr>
         <p:spPr>
           <a:xfrm>
-            <a:off x="640080" y="5513832"/>
-            <a:ext cx="219456" cy="219456"/>
-          </a:xfrm>
-          <a:prstGeom prst="ellipse">
-            <a:avLst/>
+            <a:off x="640080" y="3364992"/>
+            <a:ext cx="868680" cy="338328"/>
+          </a:xfrm>
+          <a:prstGeom prst="roundRect">
+            <a:avLst>
+              <a:gd name="adj" fmla="val 16216"/>
+            </a:avLst>
           </a:prstGeom>
           <a:solidFill>
             <a:srgbClr val="7A3B2E"/>
@@ -2872,8 +2971,8 @@
         </p:nvSpPr>
         <p:spPr>
           <a:xfrm>
-            <a:off x="1051560" y="5440680"/>
-            <a:ext cx="10424160" cy="365760"/>
+            <a:off x="640080" y="3364992"/>
+            <a:ext cx="868680" cy="338328"/>
           </a:xfrm>
           <a:prstGeom prst="rect">
             <a:avLst/>
@@ -2885,21 +2984,21 @@
           <a:bodyPr wrap="square" rtlCol="0" anchor="ctr"/>
           <a:lstStyle/>
           <a:p>
-            <a:pPr indent="0" marL="0">
-              <a:buNone/>
-            </a:pPr>
-            <a:r>
-              <a:rPr lang="en-US" sz="1500" b="1" dirty="0">
-                <a:solidFill>
-                  <a:srgbClr val="7A3B2E"/>
+            <a:pPr algn="ctr" indent="0" marL="0">
+              <a:buNone/>
+            </a:pPr>
+            <a:r>
+              <a:rPr lang="en-US" sz="1100" b="1" dirty="0">
+                <a:solidFill>
+                  <a:srgbClr val="FFFFFF"/>
                 </a:solidFill>
                 <a:latin typeface="Calibri" pitchFamily="34" charset="0"/>
                 <a:ea typeface="Calibri" pitchFamily="34" charset="-122"/>
                 <a:cs typeface="Calibri" pitchFamily="34" charset="-120"/>
               </a:rPr>
-              <a:t>Check (AI closed)</a:t>
-            </a:r>
-            <a:endParaRPr lang="en-US" sz="1500" dirty="0"/>
+              <a:t>0:55</a:t>
+            </a:r>
+            <a:endParaRPr lang="en-US" sz="1100" dirty="0"/>
           </a:p>
         </p:txBody>
       </p:sp>
@@ -2911,17 +3010,17 @@
         </p:nvSpPr>
         <p:spPr>
           <a:xfrm>
-            <a:off x="1051560" y="5824728"/>
-            <a:ext cx="10424160" cy="731520"/>
-          </a:xfrm>
-          <a:prstGeom prst="rect">
-            <a:avLst/>
-          </a:prstGeom>
-          <a:noFill/>
-          <a:ln/>
-        </p:spPr>
-        <p:txBody>
-          <a:bodyPr wrap="square" rtlCol="0" anchor="t">
+            <a:off x="1691640" y="3346704"/>
+            <a:ext cx="9646920" cy="448056"/>
+          </a:xfrm>
+          <a:prstGeom prst="rect">
+            <a:avLst/>
+          </a:prstGeom>
+          <a:noFill/>
+          <a:ln/>
+        </p:spPr>
+        <p:txBody>
+          <a:bodyPr wrap="square" rtlCol="0" anchor="ctr">
             <a:spAutoFit/>
           </a:bodyPr>
           <a:lstStyle/>
@@ -2930,7 +3029,7 @@
               <a:buNone/>
             </a:pPr>
             <a:r>
-              <a:rPr lang="en-US" sz="1400" dirty="0">
+              <a:rPr lang="en-US" sz="1100" dirty="0">
                 <a:solidFill>
                   <a:srgbClr val="1A1A1A"/>
                 </a:solidFill>
@@ -2938,9 +3037,519 @@
                 <a:ea typeface="Calibri" pitchFamily="34" charset="-122"/>
                 <a:cs typeface="Calibri" pitchFamily="34" charset="-120"/>
               </a:rPr>
-              <a:t>Explain it: why two tokenizers split a sentence differently, and what your stemming choice changed. (Competencies 3, 5.)</a:t>
-            </a:r>
-            <a:endParaRPr lang="en-US" sz="1400" dirty="0"/>
+              <a:t>What counts as a word? Paste a sentence into two tokenizer playgrounds and watch it shatter differently. Models see tokens, not words.</a:t>
+            </a:r>
+            <a:endParaRPr lang="en-US" sz="1100" dirty="0"/>
+          </a:p>
+        </p:txBody>
+      </p:sp>
+      <p:sp>
+        <p:nvSpPr>
+          <p:cNvPr id="18" name="Shape 16"/>
+          <p:cNvSpPr/>
+          <p:nvPr/>
+        </p:nvSpPr>
+        <p:spPr>
+          <a:xfrm>
+            <a:off x="640080" y="3813048"/>
+            <a:ext cx="868680" cy="338328"/>
+          </a:xfrm>
+          <a:prstGeom prst="roundRect">
+            <a:avLst>
+              <a:gd name="adj" fmla="val 16216"/>
+            </a:avLst>
+          </a:prstGeom>
+          <a:solidFill>
+            <a:srgbClr val="7A3B2E"/>
+          </a:solidFill>
+          <a:ln/>
+        </p:spPr>
+      </p:sp>
+      <p:sp>
+        <p:nvSpPr>
+          <p:cNvPr id="19" name="Text 17"/>
+          <p:cNvSpPr/>
+          <p:nvPr/>
+        </p:nvSpPr>
+        <p:spPr>
+          <a:xfrm>
+            <a:off x="640080" y="3813048"/>
+            <a:ext cx="868680" cy="338328"/>
+          </a:xfrm>
+          <a:prstGeom prst="rect">
+            <a:avLst/>
+          </a:prstGeom>
+          <a:noFill/>
+          <a:ln/>
+        </p:spPr>
+        <p:txBody>
+          <a:bodyPr wrap="square" rtlCol="0" anchor="ctr"/>
+          <a:lstStyle/>
+          <a:p>
+            <a:pPr algn="ctr" indent="0" marL="0">
+              <a:buNone/>
+            </a:pPr>
+            <a:r>
+              <a:rPr lang="en-US" sz="1100" b="1" dirty="0">
+                <a:solidFill>
+                  <a:srgbClr val="FFFFFF"/>
+                </a:solidFill>
+                <a:latin typeface="Calibri" pitchFamily="34" charset="0"/>
+                <a:ea typeface="Calibri" pitchFamily="34" charset="-122"/>
+                <a:cs typeface="Calibri" pitchFamily="34" charset="-120"/>
+              </a:rPr>
+              <a:t>1:05</a:t>
+            </a:r>
+            <a:endParaRPr lang="en-US" sz="1100" dirty="0"/>
+          </a:p>
+        </p:txBody>
+      </p:sp>
+      <p:sp>
+        <p:nvSpPr>
+          <p:cNvPr id="20" name="Text 18"/>
+          <p:cNvSpPr/>
+          <p:nvPr/>
+        </p:nvSpPr>
+        <p:spPr>
+          <a:xfrm>
+            <a:off x="1691640" y="3794760"/>
+            <a:ext cx="9646920" cy="448056"/>
+          </a:xfrm>
+          <a:prstGeom prst="rect">
+            <a:avLst/>
+          </a:prstGeom>
+          <a:noFill/>
+          <a:ln/>
+        </p:spPr>
+        <p:txBody>
+          <a:bodyPr wrap="square" rtlCol="0" anchor="ctr">
+            <a:spAutoFit/>
+          </a:bodyPr>
+          <a:lstStyle/>
+          <a:p>
+            <a:pPr indent="0" marL="0">
+              <a:buNone/>
+            </a:pPr>
+            <a:r>
+              <a:rPr lang="en-US" sz="1100" dirty="0">
+                <a:solidFill>
+                  <a:srgbClr val="1A1A1A"/>
+                </a:solidFill>
+                <a:latin typeface="Calibri" pitchFamily="34" charset="0"/>
+                <a:ea typeface="Calibri" pitchFamily="34" charset="-122"/>
+                <a:cs typeface="Calibri" pitchFamily="34" charset="-120"/>
+              </a:rPr>
+              <a:t>Break</a:t>
+            </a:r>
+            <a:endParaRPr lang="en-US" sz="1100" dirty="0"/>
+          </a:p>
+        </p:txBody>
+      </p:sp>
+      <p:sp>
+        <p:nvSpPr>
+          <p:cNvPr id="21" name="Shape 19"/>
+          <p:cNvSpPr/>
+          <p:nvPr/>
+        </p:nvSpPr>
+        <p:spPr>
+          <a:xfrm>
+            <a:off x="640080" y="4261104"/>
+            <a:ext cx="868680" cy="338328"/>
+          </a:xfrm>
+          <a:prstGeom prst="roundRect">
+            <a:avLst>
+              <a:gd name="adj" fmla="val 16216"/>
+            </a:avLst>
+          </a:prstGeom>
+          <a:solidFill>
+            <a:srgbClr val="7A3B2E"/>
+          </a:solidFill>
+          <a:ln/>
+        </p:spPr>
+      </p:sp>
+      <p:sp>
+        <p:nvSpPr>
+          <p:cNvPr id="22" name="Text 20"/>
+          <p:cNvSpPr/>
+          <p:nvPr/>
+        </p:nvSpPr>
+        <p:spPr>
+          <a:xfrm>
+            <a:off x="640080" y="4261104"/>
+            <a:ext cx="868680" cy="338328"/>
+          </a:xfrm>
+          <a:prstGeom prst="rect">
+            <a:avLst/>
+          </a:prstGeom>
+          <a:noFill/>
+          <a:ln/>
+        </p:spPr>
+        <p:txBody>
+          <a:bodyPr wrap="square" rtlCol="0" anchor="ctr"/>
+          <a:lstStyle/>
+          <a:p>
+            <a:pPr algn="ctr" indent="0" marL="0">
+              <a:buNone/>
+            </a:pPr>
+            <a:r>
+              <a:rPr lang="en-US" sz="1100" b="1" dirty="0">
+                <a:solidFill>
+                  <a:srgbClr val="FFFFFF"/>
+                </a:solidFill>
+                <a:latin typeface="Calibri" pitchFamily="34" charset="0"/>
+                <a:ea typeface="Calibri" pitchFamily="34" charset="-122"/>
+                <a:cs typeface="Calibri" pitchFamily="34" charset="-120"/>
+              </a:rPr>
+              <a:t>1:15</a:t>
+            </a:r>
+            <a:endParaRPr lang="en-US" sz="1100" dirty="0"/>
+          </a:p>
+        </p:txBody>
+      </p:sp>
+      <p:sp>
+        <p:nvSpPr>
+          <p:cNvPr id="23" name="Text 21"/>
+          <p:cNvSpPr/>
+          <p:nvPr/>
+        </p:nvSpPr>
+        <p:spPr>
+          <a:xfrm>
+            <a:off x="1691640" y="4242816"/>
+            <a:ext cx="9646920" cy="448056"/>
+          </a:xfrm>
+          <a:prstGeom prst="rect">
+            <a:avLst/>
+          </a:prstGeom>
+          <a:noFill/>
+          <a:ln/>
+        </p:spPr>
+        <p:txBody>
+          <a:bodyPr wrap="square" rtlCol="0" anchor="ctr">
+            <a:spAutoFit/>
+          </a:bodyPr>
+          <a:lstStyle/>
+          <a:p>
+            <a:pPr indent="0" marL="0">
+              <a:buNone/>
+            </a:pPr>
+            <a:r>
+              <a:rPr lang="en-US" sz="1100" dirty="0">
+                <a:solidFill>
+                  <a:srgbClr val="1A1A1A"/>
+                </a:solidFill>
+                <a:latin typeface="Calibri" pitchFamily="34" charset="0"/>
+                <a:ea typeface="Calibri" pitchFamily="34" charset="-122"/>
+                <a:cs typeface="Calibri" pitchFamily="34" charset="-120"/>
+              </a:rPr>
+              <a:t>tf-idf: the AI scales your hand count; stop-words dominate, which motivates "common here, rare overall."</a:t>
+            </a:r>
+            <a:endParaRPr lang="en-US" sz="1100" dirty="0"/>
+          </a:p>
+        </p:txBody>
+      </p:sp>
+      <p:sp>
+        <p:nvSpPr>
+          <p:cNvPr id="24" name="Shape 22"/>
+          <p:cNvSpPr/>
+          <p:nvPr/>
+        </p:nvSpPr>
+        <p:spPr>
+          <a:xfrm>
+            <a:off x="640080" y="4709160"/>
+            <a:ext cx="868680" cy="338328"/>
+          </a:xfrm>
+          <a:prstGeom prst="roundRect">
+            <a:avLst>
+              <a:gd name="adj" fmla="val 16216"/>
+            </a:avLst>
+          </a:prstGeom>
+          <a:solidFill>
+            <a:srgbClr val="7A3B2E"/>
+          </a:solidFill>
+          <a:ln/>
+        </p:spPr>
+      </p:sp>
+      <p:sp>
+        <p:nvSpPr>
+          <p:cNvPr id="25" name="Text 23"/>
+          <p:cNvSpPr/>
+          <p:nvPr/>
+        </p:nvSpPr>
+        <p:spPr>
+          <a:xfrm>
+            <a:off x="640080" y="4709160"/>
+            <a:ext cx="868680" cy="338328"/>
+          </a:xfrm>
+          <a:prstGeom prst="rect">
+            <a:avLst/>
+          </a:prstGeom>
+          <a:noFill/>
+          <a:ln/>
+        </p:spPr>
+        <p:txBody>
+          <a:bodyPr wrap="square" rtlCol="0" anchor="ctr"/>
+          <a:lstStyle/>
+          <a:p>
+            <a:pPr algn="ctr" indent="0" marL="0">
+              <a:buNone/>
+            </a:pPr>
+            <a:r>
+              <a:rPr lang="en-US" sz="1100" b="1" dirty="0">
+                <a:solidFill>
+                  <a:srgbClr val="FFFFFF"/>
+                </a:solidFill>
+                <a:latin typeface="Calibri" pitchFamily="34" charset="0"/>
+                <a:ea typeface="Calibri" pitchFamily="34" charset="-122"/>
+                <a:cs typeface="Calibri" pitchFamily="34" charset="-120"/>
+              </a:rPr>
+              <a:t>1:30</a:t>
+            </a:r>
+            <a:endParaRPr lang="en-US" sz="1100" dirty="0"/>
+          </a:p>
+        </p:txBody>
+      </p:sp>
+      <p:sp>
+        <p:nvSpPr>
+          <p:cNvPr id="26" name="Text 24"/>
+          <p:cNvSpPr/>
+          <p:nvPr/>
+        </p:nvSpPr>
+        <p:spPr>
+          <a:xfrm>
+            <a:off x="1691640" y="4690872"/>
+            <a:ext cx="9646920" cy="448056"/>
+          </a:xfrm>
+          <a:prstGeom prst="rect">
+            <a:avLst/>
+          </a:prstGeom>
+          <a:noFill/>
+          <a:ln/>
+        </p:spPr>
+        <p:txBody>
+          <a:bodyPr wrap="square" rtlCol="0" anchor="ctr">
+            <a:spAutoFit/>
+          </a:bodyPr>
+          <a:lstStyle/>
+          <a:p>
+            <a:pPr indent="0" marL="0">
+              <a:buNone/>
+            </a:pPr>
+            <a:r>
+              <a:rPr lang="en-US" sz="1100" dirty="0">
+                <a:solidFill>
+                  <a:srgbClr val="1A1A1A"/>
+                </a:solidFill>
+                <a:latin typeface="Calibri" pitchFamily="34" charset="0"/>
+                <a:ea typeface="Calibri" pitchFamily="34" charset="-122"/>
+                <a:cs typeface="Calibri" pitchFamily="34" charset="-120"/>
+              </a:rPr>
+              <a:t>Keyness, the She Giggles, He Gallops move: a log-odds ratio between two corpora finds the words one voice uses far more than a baseline, exactly the method behind Week 1's featured piece. The corpus pair is a choice too: artist vs. pop, lyrics vs. subreddit vs. novel.</a:t>
+            </a:r>
+            <a:endParaRPr lang="en-US" sz="1100" dirty="0"/>
+          </a:p>
+        </p:txBody>
+      </p:sp>
+      <p:sp>
+        <p:nvSpPr>
+          <p:cNvPr id="27" name="Shape 25"/>
+          <p:cNvSpPr/>
+          <p:nvPr/>
+        </p:nvSpPr>
+        <p:spPr>
+          <a:xfrm>
+            <a:off x="640080" y="5157216"/>
+            <a:ext cx="868680" cy="338328"/>
+          </a:xfrm>
+          <a:prstGeom prst="roundRect">
+            <a:avLst>
+              <a:gd name="adj" fmla="val 16216"/>
+            </a:avLst>
+          </a:prstGeom>
+          <a:solidFill>
+            <a:srgbClr val="7A3B2E"/>
+          </a:solidFill>
+          <a:ln/>
+        </p:spPr>
+      </p:sp>
+      <p:sp>
+        <p:nvSpPr>
+          <p:cNvPr id="28" name="Text 26"/>
+          <p:cNvSpPr/>
+          <p:nvPr/>
+        </p:nvSpPr>
+        <p:spPr>
+          <a:xfrm>
+            <a:off x="640080" y="5157216"/>
+            <a:ext cx="868680" cy="338328"/>
+          </a:xfrm>
+          <a:prstGeom prst="rect">
+            <a:avLst/>
+          </a:prstGeom>
+          <a:noFill/>
+          <a:ln/>
+        </p:spPr>
+        <p:txBody>
+          <a:bodyPr wrap="square" rtlCol="0" anchor="ctr"/>
+          <a:lstStyle/>
+          <a:p>
+            <a:pPr algn="ctr" indent="0" marL="0">
+              <a:buNone/>
+            </a:pPr>
+            <a:r>
+              <a:rPr lang="en-US" sz="1100" b="1" dirty="0">
+                <a:solidFill>
+                  <a:srgbClr val="FFFFFF"/>
+                </a:solidFill>
+                <a:latin typeface="Calibri" pitchFamily="34" charset="0"/>
+                <a:ea typeface="Calibri" pitchFamily="34" charset="-122"/>
+                <a:cs typeface="Calibri" pitchFamily="34" charset="-120"/>
+              </a:rPr>
+              <a:t>1:42</a:t>
+            </a:r>
+            <a:endParaRPr lang="en-US" sz="1100" dirty="0"/>
+          </a:p>
+        </p:txBody>
+      </p:sp>
+      <p:sp>
+        <p:nvSpPr>
+          <p:cNvPr id="29" name="Text 27"/>
+          <p:cNvSpPr/>
+          <p:nvPr/>
+        </p:nvSpPr>
+        <p:spPr>
+          <a:xfrm>
+            <a:off x="1691640" y="5138928"/>
+            <a:ext cx="9646920" cy="448056"/>
+          </a:xfrm>
+          <a:prstGeom prst="rect">
+            <a:avLst/>
+          </a:prstGeom>
+          <a:noFill/>
+          <a:ln/>
+        </p:spPr>
+        <p:txBody>
+          <a:bodyPr wrap="square" rtlCol="0" anchor="ctr">
+            <a:spAutoFit/>
+          </a:bodyPr>
+          <a:lstStyle/>
+          <a:p>
+            <a:pPr indent="0" marL="0">
+              <a:buNone/>
+            </a:pPr>
+            <a:r>
+              <a:rPr lang="en-US" sz="1100" dirty="0">
+                <a:solidFill>
+                  <a:srgbClr val="1A1A1A"/>
+                </a:solidFill>
+                <a:latin typeface="Calibri" pitchFamily="34" charset="0"/>
+                <a:ea typeface="Calibri" pitchFamily="34" charset="-122"/>
+                <a:cs typeface="Calibri" pitchFamily="34" charset="-120"/>
+              </a:rPr>
+              <a:t>Is the difference real? The shuffle test: shuffle the labels and recount, one thousand times. If chance alone frequently produces a gap this large, the difference should not be trusted; if it almost never does, the finding stands. A difference can be real and still small.</a:t>
+            </a:r>
+            <a:endParaRPr lang="en-US" sz="1100" dirty="0"/>
+          </a:p>
+        </p:txBody>
+      </p:sp>
+      <p:sp>
+        <p:nvSpPr>
+          <p:cNvPr id="30" name="Shape 28"/>
+          <p:cNvSpPr/>
+          <p:nvPr/>
+        </p:nvSpPr>
+        <p:spPr>
+          <a:xfrm>
+            <a:off x="640080" y="5605272"/>
+            <a:ext cx="868680" cy="338328"/>
+          </a:xfrm>
+          <a:prstGeom prst="roundRect">
+            <a:avLst>
+              <a:gd name="adj" fmla="val 16216"/>
+            </a:avLst>
+          </a:prstGeom>
+          <a:solidFill>
+            <a:srgbClr val="7A3B2E"/>
+          </a:solidFill>
+          <a:ln/>
+        </p:spPr>
+      </p:sp>
+      <p:sp>
+        <p:nvSpPr>
+          <p:cNvPr id="31" name="Text 29"/>
+          <p:cNvSpPr/>
+          <p:nvPr/>
+        </p:nvSpPr>
+        <p:spPr>
+          <a:xfrm>
+            <a:off x="640080" y="5605272"/>
+            <a:ext cx="868680" cy="338328"/>
+          </a:xfrm>
+          <a:prstGeom prst="rect">
+            <a:avLst/>
+          </a:prstGeom>
+          <a:noFill/>
+          <a:ln/>
+        </p:spPr>
+        <p:txBody>
+          <a:bodyPr wrap="square" rtlCol="0" anchor="ctr"/>
+          <a:lstStyle/>
+          <a:p>
+            <a:pPr algn="ctr" indent="0" marL="0">
+              <a:buNone/>
+            </a:pPr>
+            <a:r>
+              <a:rPr lang="en-US" sz="1100" b="1" dirty="0">
+                <a:solidFill>
+                  <a:srgbClr val="FFFFFF"/>
+                </a:solidFill>
+                <a:latin typeface="Calibri" pitchFamily="34" charset="0"/>
+                <a:ea typeface="Calibri" pitchFamily="34" charset="-122"/>
+                <a:cs typeface="Calibri" pitchFamily="34" charset="-120"/>
+              </a:rPr>
+              <a:t>1:50</a:t>
+            </a:r>
+            <a:endParaRPr lang="en-US" sz="1100" dirty="0"/>
+          </a:p>
+        </p:txBody>
+      </p:sp>
+      <p:sp>
+        <p:nvSpPr>
+          <p:cNvPr id="32" name="Text 30"/>
+          <p:cNvSpPr/>
+          <p:nvPr/>
+        </p:nvSpPr>
+        <p:spPr>
+          <a:xfrm>
+            <a:off x="1691640" y="5586984"/>
+            <a:ext cx="9646920" cy="448056"/>
+          </a:xfrm>
+          <a:prstGeom prst="rect">
+            <a:avLst/>
+          </a:prstGeom>
+          <a:noFill/>
+          <a:ln/>
+        </p:spPr>
+        <p:txBody>
+          <a:bodyPr wrap="square" rtlCol="0" anchor="ctr">
+            <a:spAutoFit/>
+          </a:bodyPr>
+          <a:lstStyle/>
+          <a:p>
+            <a:pPr indent="0" marL="0">
+              <a:buNone/>
+            </a:pPr>
+            <a:r>
+              <a:rPr lang="en-US" sz="1100" dirty="0">
+                <a:solidFill>
+                  <a:srgbClr val="1A1A1A"/>
+                </a:solidFill>
+                <a:latin typeface="Calibri" pitchFamily="34" charset="0"/>
+                <a:ea typeface="Calibri" pitchFamily="34" charset="-122"/>
+                <a:cs typeface="Calibri" pitchFamily="34" charset="-120"/>
+              </a:rPr>
+              <a:t>Gemini-free check and check-out.</a:t>
+            </a:r>
+            <a:endParaRPr lang="en-US" sz="1100" dirty="0"/>
           </a:p>
         </p:txBody>
       </p:sp>
@@ -2985,7 +3594,7 @@
         <p:spPr>
           <a:xfrm>
             <a:off x="640080" y="640080"/>
-            <a:ext cx="10058400" cy="320040"/>
+            <a:ext cx="10058400" cy="731520"/>
           </a:xfrm>
           <a:prstGeom prst="rect">
             <a:avLst/>
@@ -3001,7 +3610,66 @@
               <a:buNone/>
             </a:pPr>
             <a:r>
-              <a:rPr lang="en-US" sz="1300" b="1" spc="300" kern="0" dirty="0">
+              <a:rPr lang="en-US" sz="3000" b="1" dirty="0">
+                <a:solidFill>
+                  <a:srgbClr val="1A1A1A"/>
+                </a:solidFill>
+                <a:latin typeface="Cambria" pitchFamily="34" charset="0"/>
+                <a:ea typeface="Cambria" pitchFamily="34" charset="-122"/>
+                <a:cs typeface="Cambria" pitchFamily="34" charset="-120"/>
+              </a:rPr>
+              <a:t>Reading &amp; homework</a:t>
+            </a:r>
+            <a:endParaRPr lang="en-US" sz="3000" dirty="0"/>
+          </a:p>
+        </p:txBody>
+      </p:sp>
+      <p:sp>
+        <p:nvSpPr>
+          <p:cNvPr id="3" name="Shape 1"/>
+          <p:cNvSpPr/>
+          <p:nvPr/>
+        </p:nvSpPr>
+        <p:spPr>
+          <a:xfrm>
+            <a:off x="640080" y="1673352"/>
+            <a:ext cx="219456" cy="219456"/>
+          </a:xfrm>
+          <a:prstGeom prst="ellipse">
+            <a:avLst/>
+          </a:prstGeom>
+          <a:solidFill>
+            <a:srgbClr val="7A3B2E"/>
+          </a:solidFill>
+          <a:ln/>
+        </p:spPr>
+      </p:sp>
+      <p:sp>
+        <p:nvSpPr>
+          <p:cNvPr id="4" name="Text 2"/>
+          <p:cNvSpPr/>
+          <p:nvPr/>
+        </p:nvSpPr>
+        <p:spPr>
+          <a:xfrm>
+            <a:off x="1051560" y="1600200"/>
+            <a:ext cx="10424160" cy="365760"/>
+          </a:xfrm>
+          <a:prstGeom prst="rect">
+            <a:avLst/>
+          </a:prstGeom>
+          <a:noFill/>
+          <a:ln/>
+        </p:spPr>
+        <p:txBody>
+          <a:bodyPr wrap="square" rtlCol="0" anchor="ctr"/>
+          <a:lstStyle/>
+          <a:p>
+            <a:pPr indent="0" marL="0">
+              <a:buNone/>
+            </a:pPr>
+            <a:r>
+              <a:rPr lang="en-US" sz="1500" b="1" dirty="0">
                 <a:solidFill>
                   <a:srgbClr val="7A3B2E"/>
                 </a:solidFill>
@@ -3009,72 +3677,11 @@
                 <a:ea typeface="Calibri" pitchFamily="34" charset="-122"/>
                 <a:cs typeface="Calibri" pitchFamily="34" charset="-120"/>
               </a:rPr>
-              <a:t>HOW THIS WEEK CONNECTS</a:t>
-            </a:r>
-            <a:endParaRPr lang="en-US" sz="1300" dirty="0"/>
-          </a:p>
-        </p:txBody>
-      </p:sp>
-      <p:sp>
-        <p:nvSpPr>
-          <p:cNvPr id="3" name="Text 1"/>
-          <p:cNvSpPr/>
-          <p:nvPr/>
-        </p:nvSpPr>
-        <p:spPr>
-          <a:xfrm>
-            <a:off x="640080" y="987552"/>
-            <a:ext cx="10058400" cy="640080"/>
-          </a:xfrm>
-          <a:prstGeom prst="rect">
-            <a:avLst/>
-          </a:prstGeom>
-          <a:noFill/>
-          <a:ln/>
-        </p:spPr>
-        <p:txBody>
-          <a:bodyPr wrap="square" rtlCol="0" anchor="ctr"/>
-          <a:lstStyle/>
-          <a:p>
-            <a:pPr indent="0" marL="0">
-              <a:buNone/>
-            </a:pPr>
-            <a:r>
-              <a:rPr lang="en-US" sz="2800" b="1" dirty="0">
-                <a:solidFill>
-                  <a:srgbClr val="1A1A1A"/>
-                </a:solidFill>
-                <a:latin typeface="Cambria" pitchFamily="34" charset="0"/>
-                <a:ea typeface="Cambria" pitchFamily="34" charset="-122"/>
-                <a:cs typeface="Cambria" pitchFamily="34" charset="-120"/>
-              </a:rPr>
-              <a:t>The course's through-lines</a:t>
-            </a:r>
-            <a:endParaRPr lang="en-US" sz="2800" dirty="0"/>
-          </a:p>
-        </p:txBody>
-      </p:sp>
-      <p:sp>
-        <p:nvSpPr>
-          <p:cNvPr id="4" name="Shape 2"/>
-          <p:cNvSpPr/>
-          <p:nvPr/>
-        </p:nvSpPr>
-        <p:spPr>
-          <a:xfrm>
-            <a:off x="640080" y="2057400"/>
-            <a:ext cx="457200" cy="457200"/>
-          </a:xfrm>
-          <a:prstGeom prst="roundRect">
-            <a:avLst>
-              <a:gd name="adj" fmla="val 16000"/>
-            </a:avLst>
-          </a:prstGeom>
-          <a:solidFill>
-            <a:srgbClr val="7A3B2E"/>
-          </a:solidFill>
-          <a:ln/>
-        </p:spPr>
+              <a:t>Reading</a:t>
+            </a:r>
+            <a:endParaRPr lang="en-US" sz="1500" dirty="0"/>
+          </a:p>
+        </p:txBody>
       </p:sp>
       <p:sp>
         <p:nvSpPr>
@@ -3084,86 +3691,8 @@
         </p:nvSpPr>
         <p:spPr>
           <a:xfrm>
-            <a:off x="640080" y="2057400"/>
-            <a:ext cx="457200" cy="457200"/>
-          </a:xfrm>
-          <a:prstGeom prst="rect">
-            <a:avLst/>
-          </a:prstGeom>
-          <a:noFill/>
-          <a:ln/>
-        </p:spPr>
-        <p:txBody>
-          <a:bodyPr wrap="square" rtlCol="0" anchor="ctr"/>
-          <a:lstStyle/>
-          <a:p>
-            <a:pPr algn="ctr" indent="0" marL="0">
-              <a:buNone/>
-            </a:pPr>
-            <a:r>
-              <a:rPr lang="en-US" sz="2000" b="1" dirty="0">
-                <a:solidFill>
-                  <a:srgbClr val="FFFFFF"/>
-                </a:solidFill>
-                <a:latin typeface="Cambria" pitchFamily="34" charset="0"/>
-                <a:ea typeface="Cambria" pitchFamily="34" charset="-122"/>
-                <a:cs typeface="Cambria" pitchFamily="34" charset="-120"/>
-              </a:rPr>
-              <a:t>1</a:t>
-            </a:r>
-            <a:endParaRPr lang="en-US" sz="2000" dirty="0"/>
-          </a:p>
-        </p:txBody>
-      </p:sp>
-      <p:sp>
-        <p:nvSpPr>
-          <p:cNvPr id="6" name="Text 4"/>
-          <p:cNvSpPr/>
-          <p:nvPr/>
-        </p:nvSpPr>
-        <p:spPr>
-          <a:xfrm>
-            <a:off x="1371600" y="2020824"/>
-            <a:ext cx="10332720" cy="411480"/>
-          </a:xfrm>
-          <a:prstGeom prst="rect">
-            <a:avLst/>
-          </a:prstGeom>
-          <a:noFill/>
-          <a:ln/>
-        </p:spPr>
-        <p:txBody>
-          <a:bodyPr wrap="square" rtlCol="0" anchor="ctr"/>
-          <a:lstStyle/>
-          <a:p>
-            <a:pPr indent="0" marL="0">
-              <a:buNone/>
-            </a:pPr>
-            <a:r>
-              <a:rPr lang="en-US" sz="1900" b="1" dirty="0">
-                <a:solidFill>
-                  <a:srgbClr val="7A3B2E"/>
-                </a:solidFill>
-                <a:latin typeface="Cambria" pitchFamily="34" charset="0"/>
-                <a:ea typeface="Cambria" pitchFamily="34" charset="-122"/>
-                <a:cs typeface="Cambria" pitchFamily="34" charset="-120"/>
-              </a:rPr>
-              <a:t>Beyond counting</a:t>
-            </a:r>
-            <a:endParaRPr lang="en-US" sz="1900" dirty="0"/>
-          </a:p>
-        </p:txBody>
-      </p:sp>
-      <p:sp>
-        <p:nvSpPr>
-          <p:cNvPr id="7" name="Text 5"/>
-          <p:cNvSpPr/>
-          <p:nvPr/>
-        </p:nvSpPr>
-        <p:spPr>
-          <a:xfrm>
-            <a:off x="1371600" y="2441448"/>
-            <a:ext cx="10332720" cy="914400"/>
+            <a:off x="1051560" y="1984248"/>
+            <a:ext cx="10424160" cy="731520"/>
           </a:xfrm>
           <a:prstGeom prst="rect">
             <a:avLst/>
@@ -3178,13 +3707,10 @@
           <a:lstStyle/>
           <a:p>
             <a:pPr indent="0" marL="0">
-              <a:lnSpc>
-                <a:spcPct val="112000"/>
-              </a:lnSpc>
-              <a:buNone/>
-            </a:pPr>
-            <a:r>
-              <a:rPr lang="en-US" sz="1450" dirty="0">
+              <a:buNone/>
+            </a:pPr>
+            <a:r>
+              <a:rPr lang="en-US" sz="1400" dirty="0">
                 <a:solidFill>
                   <a:srgbClr val="1A1A1A"/>
                 </a:solidFill>
@@ -3192,27 +3718,25 @@
                 <a:ea typeface="Calibri" pitchFamily="34" charset="-122"/>
                 <a:cs typeface="Calibri" pitchFamily="34" charset="-120"/>
               </a:rPr>
-              <a:t>Counting is the simplest tool and has no notion of meaning. Week 5 addresses that limit.</a:t>
-            </a:r>
-            <a:endParaRPr lang="en-US" sz="1450" dirty="0"/>
-          </a:p>
-        </p:txBody>
-      </p:sp>
-      <p:sp>
-        <p:nvSpPr>
-          <p:cNvPr id="8" name="Shape 6"/>
-          <p:cNvSpPr/>
-          <p:nvPr/>
-        </p:nvSpPr>
-        <p:spPr>
-          <a:xfrm>
-            <a:off x="640080" y="3520440"/>
-            <a:ext cx="457200" cy="457200"/>
-          </a:xfrm>
-          <a:prstGeom prst="roundRect">
-            <a:avLst>
-              <a:gd name="adj" fmla="val 16000"/>
-            </a:avLst>
+              <a:t>Wolfram, What Is ChatGPT Doing (opening sections only)</a:t>
+            </a:r>
+            <a:endParaRPr lang="en-US" sz="1400" dirty="0"/>
+          </a:p>
+        </p:txBody>
+      </p:sp>
+      <p:sp>
+        <p:nvSpPr>
+          <p:cNvPr id="6" name="Shape 4"/>
+          <p:cNvSpPr/>
+          <p:nvPr/>
+        </p:nvSpPr>
+        <p:spPr>
+          <a:xfrm>
+            <a:off x="640080" y="2633472"/>
+            <a:ext cx="219456" cy="219456"/>
+          </a:xfrm>
+          <a:prstGeom prst="ellipse">
+            <a:avLst/>
           </a:prstGeom>
           <a:solidFill>
             <a:srgbClr val="3F6F5F"/>
@@ -3222,14 +3746,14 @@
       </p:sp>
       <p:sp>
         <p:nvSpPr>
-          <p:cNvPr id="9" name="Text 7"/>
-          <p:cNvSpPr/>
-          <p:nvPr/>
-        </p:nvSpPr>
-        <p:spPr>
-          <a:xfrm>
-            <a:off x="640080" y="3520440"/>
-            <a:ext cx="457200" cy="457200"/>
+          <p:cNvPr id="7" name="Text 5"/>
+          <p:cNvSpPr/>
+          <p:nvPr/>
+        </p:nvSpPr>
+        <p:spPr>
+          <a:xfrm>
+            <a:off x="1051560" y="2560320"/>
+            <a:ext cx="10424160" cy="365760"/>
           </a:xfrm>
           <a:prstGeom prst="rect">
             <a:avLst/>
@@ -3241,73 +3765,34 @@
           <a:bodyPr wrap="square" rtlCol="0" anchor="ctr"/>
           <a:lstStyle/>
           <a:p>
-            <a:pPr algn="ctr" indent="0" marL="0">
-              <a:buNone/>
-            </a:pPr>
-            <a:r>
-              <a:rPr lang="en-US" sz="2000" b="1" dirty="0">
-                <a:solidFill>
-                  <a:srgbClr val="FFFFFF"/>
-                </a:solidFill>
-                <a:latin typeface="Cambria" pitchFamily="34" charset="0"/>
-                <a:ea typeface="Cambria" pitchFamily="34" charset="-122"/>
-                <a:cs typeface="Cambria" pitchFamily="34" charset="-120"/>
-              </a:rPr>
-              <a:t>2</a:t>
-            </a:r>
-            <a:endParaRPr lang="en-US" sz="2000" dirty="0"/>
-          </a:p>
-        </p:txBody>
-      </p:sp>
-      <p:sp>
-        <p:nvSpPr>
-          <p:cNvPr id="10" name="Text 8"/>
-          <p:cNvSpPr/>
-          <p:nvPr/>
-        </p:nvSpPr>
-        <p:spPr>
-          <a:xfrm>
-            <a:off x="1371600" y="3483864"/>
-            <a:ext cx="10332720" cy="411480"/>
-          </a:xfrm>
-          <a:prstGeom prst="rect">
-            <a:avLst/>
-          </a:prstGeom>
-          <a:noFill/>
-          <a:ln/>
-        </p:spPr>
-        <p:txBody>
-          <a:bodyPr wrap="square" rtlCol="0" anchor="ctr"/>
-          <a:lstStyle/>
-          <a:p>
             <a:pPr indent="0" marL="0">
               <a:buNone/>
             </a:pPr>
             <a:r>
-              <a:rPr lang="en-US" sz="1900" b="1" dirty="0">
+              <a:rPr lang="en-US" sz="1500" b="1" dirty="0">
                 <a:solidFill>
                   <a:srgbClr val="3F6F5F"/>
                 </a:solidFill>
-                <a:latin typeface="Cambria" pitchFamily="34" charset="0"/>
-                <a:ea typeface="Cambria" pitchFamily="34" charset="-122"/>
-                <a:cs typeface="Cambria" pitchFamily="34" charset="-120"/>
-              </a:rPr>
-              <a:t>Every count is a choice</a:t>
-            </a:r>
-            <a:endParaRPr lang="en-US" sz="1900" dirty="0"/>
-          </a:p>
-        </p:txBody>
-      </p:sp>
-      <p:sp>
-        <p:nvSpPr>
-          <p:cNvPr id="11" name="Text 9"/>
-          <p:cNvSpPr/>
-          <p:nvPr/>
-        </p:nvSpPr>
-        <p:spPr>
-          <a:xfrm>
-            <a:off x="1371600" y="3904488"/>
-            <a:ext cx="10332720" cy="914400"/>
+                <a:latin typeface="Calibri" pitchFamily="34" charset="0"/>
+                <a:ea typeface="Calibri" pitchFamily="34" charset="-122"/>
+                <a:cs typeface="Calibri" pitchFamily="34" charset="-120"/>
+              </a:rPr>
+              <a:t>Supplement</a:t>
+            </a:r>
+            <a:endParaRPr lang="en-US" sz="1500" dirty="0"/>
+          </a:p>
+        </p:txBody>
+      </p:sp>
+      <p:sp>
+        <p:nvSpPr>
+          <p:cNvPr id="8" name="Text 6"/>
+          <p:cNvSpPr/>
+          <p:nvPr/>
+        </p:nvSpPr>
+        <p:spPr>
+          <a:xfrm>
+            <a:off x="1051560" y="2944368"/>
+            <a:ext cx="10424160" cy="731520"/>
           </a:xfrm>
           <a:prstGeom prst="rect">
             <a:avLst/>
@@ -3322,13 +3807,10 @@
           <a:lstStyle/>
           <a:p>
             <a:pPr indent="0" marL="0">
-              <a:lnSpc>
-                <a:spcPct val="112000"/>
-              </a:lnSpc>
-              <a:buNone/>
-            </a:pPr>
-            <a:r>
-              <a:rPr lang="en-US" sz="1450" dirty="0">
+              <a:buNone/>
+            </a:pPr>
+            <a:r>
+              <a:rPr lang="en-US" sz="1400" dirty="0">
                 <a:solidFill>
                   <a:srgbClr val="1A1A1A"/>
                 </a:solidFill>
@@ -3336,27 +3818,25 @@
                 <a:ea typeface="Calibri" pitchFamily="34" charset="-122"/>
                 <a:cs typeface="Calibri" pitchFamily="34" charset="-120"/>
               </a:rPr>
-              <a:t>Tokens, stemming, the corpus, the chart's axis, each hides a decision you made.</a:t>
-            </a:r>
-            <a:endParaRPr lang="en-US" sz="1450" dirty="0"/>
-          </a:p>
-        </p:txBody>
-      </p:sp>
-      <p:sp>
-        <p:nvSpPr>
-          <p:cNvPr id="12" name="Shape 10"/>
-          <p:cNvSpPr/>
-          <p:nvPr/>
-        </p:nvSpPr>
-        <p:spPr>
-          <a:xfrm>
-            <a:off x="640080" y="4983480"/>
-            <a:ext cx="457200" cy="457200"/>
-          </a:xfrm>
-          <a:prstGeom prst="roundRect">
-            <a:avLst>
-              <a:gd name="adj" fmla="val 16000"/>
-            </a:avLst>
+              <a:t>Zipf's law, the straight line in every text</a:t>
+            </a:r>
+            <a:endParaRPr lang="en-US" sz="1400" dirty="0"/>
+          </a:p>
+        </p:txBody>
+      </p:sp>
+      <p:sp>
+        <p:nvSpPr>
+          <p:cNvPr id="9" name="Shape 7"/>
+          <p:cNvSpPr/>
+          <p:nvPr/>
+        </p:nvSpPr>
+        <p:spPr>
+          <a:xfrm>
+            <a:off x="640080" y="3593592"/>
+            <a:ext cx="219456" cy="219456"/>
+          </a:xfrm>
+          <a:prstGeom prst="ellipse">
+            <a:avLst/>
           </a:prstGeom>
           <a:solidFill>
             <a:srgbClr val="B9852F"/>
@@ -3366,14 +3846,14 @@
       </p:sp>
       <p:sp>
         <p:nvSpPr>
-          <p:cNvPr id="13" name="Text 11"/>
-          <p:cNvSpPr/>
-          <p:nvPr/>
-        </p:nvSpPr>
-        <p:spPr>
-          <a:xfrm>
-            <a:off x="640080" y="4983480"/>
-            <a:ext cx="457200" cy="457200"/>
+          <p:cNvPr id="10" name="Text 8"/>
+          <p:cNvSpPr/>
+          <p:nvPr/>
+        </p:nvSpPr>
+        <p:spPr>
+          <a:xfrm>
+            <a:off x="1051560" y="3520440"/>
+            <a:ext cx="10424160" cy="365760"/>
           </a:xfrm>
           <a:prstGeom prst="rect">
             <a:avLst/>
@@ -3385,73 +3865,34 @@
           <a:bodyPr wrap="square" rtlCol="0" anchor="ctr"/>
           <a:lstStyle/>
           <a:p>
-            <a:pPr algn="ctr" indent="0" marL="0">
-              <a:buNone/>
-            </a:pPr>
-            <a:r>
-              <a:rPr lang="en-US" sz="2000" b="1" dirty="0">
-                <a:solidFill>
-                  <a:srgbClr val="FFFFFF"/>
-                </a:solidFill>
-                <a:latin typeface="Cambria" pitchFamily="34" charset="0"/>
-                <a:ea typeface="Cambria" pitchFamily="34" charset="-122"/>
-                <a:cs typeface="Cambria" pitchFamily="34" charset="-120"/>
-              </a:rPr>
-              <a:t>3</a:t>
-            </a:r>
-            <a:endParaRPr lang="en-US" sz="2000" dirty="0"/>
-          </a:p>
-        </p:txBody>
-      </p:sp>
-      <p:sp>
-        <p:nvSpPr>
-          <p:cNvPr id="14" name="Text 12"/>
-          <p:cNvSpPr/>
-          <p:nvPr/>
-        </p:nvSpPr>
-        <p:spPr>
-          <a:xfrm>
-            <a:off x="1371600" y="4946904"/>
-            <a:ext cx="10332720" cy="411480"/>
-          </a:xfrm>
-          <a:prstGeom prst="rect">
-            <a:avLst/>
-          </a:prstGeom>
-          <a:noFill/>
-          <a:ln/>
-        </p:spPr>
-        <p:txBody>
-          <a:bodyPr wrap="square" rtlCol="0" anchor="ctr"/>
-          <a:lstStyle/>
-          <a:p>
             <a:pPr indent="0" marL="0">
               <a:buNone/>
             </a:pPr>
             <a:r>
-              <a:rPr lang="en-US" sz="1900" b="1" dirty="0">
+              <a:rPr lang="en-US" sz="1500" b="1" dirty="0">
                 <a:solidFill>
                   <a:srgbClr val="B9852F"/>
                 </a:solidFill>
-                <a:latin typeface="Cambria" pitchFamily="34" charset="0"/>
-                <a:ea typeface="Cambria" pitchFamily="34" charset="-122"/>
-                <a:cs typeface="Cambria" pitchFamily="34" charset="-120"/>
-              </a:rPr>
-              <a:t>Is the difference real?</a:t>
-            </a:r>
-            <a:endParaRPr lang="en-US" sz="1900" dirty="0"/>
-          </a:p>
-        </p:txBody>
-      </p:sp>
-      <p:sp>
-        <p:nvSpPr>
-          <p:cNvPr id="15" name="Text 13"/>
-          <p:cNvSpPr/>
-          <p:nvPr/>
-        </p:nvSpPr>
-        <p:spPr>
-          <a:xfrm>
-            <a:off x="1371600" y="5367528"/>
-            <a:ext cx="10332720" cy="914400"/>
+                <a:latin typeface="Calibri" pitchFamily="34" charset="0"/>
+                <a:ea typeface="Calibri" pitchFamily="34" charset="-122"/>
+                <a:cs typeface="Calibri" pitchFamily="34" charset="-120"/>
+              </a:rPr>
+              <a:t>Deeper (optional)</a:t>
+            </a:r>
+            <a:endParaRPr lang="en-US" sz="1500" dirty="0"/>
+          </a:p>
+        </p:txBody>
+      </p:sp>
+      <p:sp>
+        <p:nvSpPr>
+          <p:cNvPr id="11" name="Text 9"/>
+          <p:cNvSpPr/>
+          <p:nvPr/>
+        </p:nvSpPr>
+        <p:spPr>
+          <a:xfrm>
+            <a:off x="1051560" y="3904488"/>
+            <a:ext cx="10424160" cy="731520"/>
           </a:xfrm>
           <a:prstGeom prst="rect">
             <a:avLst/>
@@ -3466,13 +3907,10 @@
           <a:lstStyle/>
           <a:p>
             <a:pPr indent="0" marL="0">
-              <a:lnSpc>
-                <a:spcPct val="112000"/>
-              </a:lnSpc>
-              <a:buNone/>
-            </a:pPr>
-            <a:r>
-              <a:rPr lang="en-US" sz="1450" dirty="0">
+              <a:buNone/>
+            </a:pPr>
+            <a:r>
+              <a:rPr lang="en-US" sz="1400" dirty="0">
                 <a:solidFill>
                   <a:srgbClr val="1A1A1A"/>
                 </a:solidFill>
@@ -3480,9 +3918,209 @@
                 <a:ea typeface="Calibri" pitchFamily="34" charset="-122"/>
                 <a:cs typeface="Calibri" pitchFamily="34" charset="-120"/>
               </a:rPr>
-              <a:t>Shuffle the labels and count again, one thousand times; if chance often matches your gap, do not trust it.</a:t>
-            </a:r>
-            <a:endParaRPr lang="en-US" sz="1450" dirty="0"/>
+              <a:t>Grimmer &amp;amp; Stewart, Text as Data (2013), §1–4: all quantitative models of language are wrong, but some are useful</a:t>
+            </a:r>
+            <a:endParaRPr lang="en-US" sz="1400" dirty="0"/>
+          </a:p>
+        </p:txBody>
+      </p:sp>
+      <p:sp>
+        <p:nvSpPr>
+          <p:cNvPr id="12" name="Shape 10"/>
+          <p:cNvSpPr/>
+          <p:nvPr/>
+        </p:nvSpPr>
+        <p:spPr>
+          <a:xfrm>
+            <a:off x="640080" y="4553712"/>
+            <a:ext cx="219456" cy="219456"/>
+          </a:xfrm>
+          <a:prstGeom prst="ellipse">
+            <a:avLst/>
+          </a:prstGeom>
+          <a:solidFill>
+            <a:srgbClr val="3F6F5F"/>
+          </a:solidFill>
+          <a:ln/>
+        </p:spPr>
+      </p:sp>
+      <p:sp>
+        <p:nvSpPr>
+          <p:cNvPr id="13" name="Text 11"/>
+          <p:cNvSpPr/>
+          <p:nvPr/>
+        </p:nvSpPr>
+        <p:spPr>
+          <a:xfrm>
+            <a:off x="1051560" y="4480560"/>
+            <a:ext cx="10424160" cy="365760"/>
+          </a:xfrm>
+          <a:prstGeom prst="rect">
+            <a:avLst/>
+          </a:prstGeom>
+          <a:noFill/>
+          <a:ln/>
+        </p:spPr>
+        <p:txBody>
+          <a:bodyPr wrap="square" rtlCol="0" anchor="ctr"/>
+          <a:lstStyle/>
+          <a:p>
+            <a:pPr indent="0" marL="0">
+              <a:buNone/>
+            </a:pPr>
+            <a:r>
+              <a:rPr lang="en-US" sz="1500" b="1" dirty="0">
+                <a:solidFill>
+                  <a:srgbClr val="3F6F5F"/>
+                </a:solidFill>
+                <a:latin typeface="Calibri" pitchFamily="34" charset="0"/>
+                <a:ea typeface="Calibri" pitchFamily="34" charset="-122"/>
+                <a:cs typeface="Calibri" pitchFamily="34" charset="-120"/>
+              </a:rPr>
+              <a:t>Sketch</a:t>
+            </a:r>
+            <a:endParaRPr lang="en-US" sz="1500" dirty="0"/>
+          </a:p>
+        </p:txBody>
+      </p:sp>
+      <p:sp>
+        <p:nvSpPr>
+          <p:cNvPr id="14" name="Text 12"/>
+          <p:cNvSpPr/>
+          <p:nvPr/>
+        </p:nvSpPr>
+        <p:spPr>
+          <a:xfrm>
+            <a:off x="1051560" y="4864608"/>
+            <a:ext cx="10424160" cy="731520"/>
+          </a:xfrm>
+          <a:prstGeom prst="rect">
+            <a:avLst/>
+          </a:prstGeom>
+          <a:noFill/>
+          <a:ln/>
+        </p:spPr>
+        <p:txBody>
+          <a:bodyPr wrap="square" rtlCol="0" anchor="t">
+            <a:spAutoFit/>
+          </a:bodyPr>
+          <a:lstStyle/>
+          <a:p>
+            <a:pPr indent="0" marL="0">
+              <a:buNone/>
+            </a:pPr>
+            <a:r>
+              <a:rPr lang="en-US" sz="1400" dirty="0">
+                <a:solidFill>
+                  <a:srgbClr val="1A1A1A"/>
+                </a:solidFill>
+                <a:latin typeface="Calibri" pitchFamily="34" charset="0"/>
+                <a:ea typeface="Calibri" pitchFamily="34" charset="-122"/>
+                <a:cs typeface="Calibri" pitchFamily="34" charset="-120"/>
+              </a:rPr>
+              <a:t>Count something in a text you care about; one chart; one sentence naming a choice. If the count compares two things, shuffle-test the gap.</a:t>
+            </a:r>
+            <a:endParaRPr lang="en-US" sz="1400" dirty="0"/>
+          </a:p>
+        </p:txBody>
+      </p:sp>
+      <p:sp>
+        <p:nvSpPr>
+          <p:cNvPr id="15" name="Shape 13"/>
+          <p:cNvSpPr/>
+          <p:nvPr/>
+        </p:nvSpPr>
+        <p:spPr>
+          <a:xfrm>
+            <a:off x="640080" y="5513832"/>
+            <a:ext cx="219456" cy="219456"/>
+          </a:xfrm>
+          <a:prstGeom prst="ellipse">
+            <a:avLst/>
+          </a:prstGeom>
+          <a:solidFill>
+            <a:srgbClr val="7A3B2E"/>
+          </a:solidFill>
+          <a:ln/>
+        </p:spPr>
+      </p:sp>
+      <p:sp>
+        <p:nvSpPr>
+          <p:cNvPr id="16" name="Text 14"/>
+          <p:cNvSpPr/>
+          <p:nvPr/>
+        </p:nvSpPr>
+        <p:spPr>
+          <a:xfrm>
+            <a:off x="1051560" y="5440680"/>
+            <a:ext cx="10424160" cy="365760"/>
+          </a:xfrm>
+          <a:prstGeom prst="rect">
+            <a:avLst/>
+          </a:prstGeom>
+          <a:noFill/>
+          <a:ln/>
+        </p:spPr>
+        <p:txBody>
+          <a:bodyPr wrap="square" rtlCol="0" anchor="ctr"/>
+          <a:lstStyle/>
+          <a:p>
+            <a:pPr indent="0" marL="0">
+              <a:buNone/>
+            </a:pPr>
+            <a:r>
+              <a:rPr lang="en-US" sz="1500" b="1" dirty="0">
+                <a:solidFill>
+                  <a:srgbClr val="7A3B2E"/>
+                </a:solidFill>
+                <a:latin typeface="Calibri" pitchFamily="34" charset="0"/>
+                <a:ea typeface="Calibri" pitchFamily="34" charset="-122"/>
+                <a:cs typeface="Calibri" pitchFamily="34" charset="-120"/>
+              </a:rPr>
+              <a:t>Check (AI closed)</a:t>
+            </a:r>
+            <a:endParaRPr lang="en-US" sz="1500" dirty="0"/>
+          </a:p>
+        </p:txBody>
+      </p:sp>
+      <p:sp>
+        <p:nvSpPr>
+          <p:cNvPr id="17" name="Text 15"/>
+          <p:cNvSpPr/>
+          <p:nvPr/>
+        </p:nvSpPr>
+        <p:spPr>
+          <a:xfrm>
+            <a:off x="1051560" y="5824728"/>
+            <a:ext cx="10424160" cy="731520"/>
+          </a:xfrm>
+          <a:prstGeom prst="rect">
+            <a:avLst/>
+          </a:prstGeom>
+          <a:noFill/>
+          <a:ln/>
+        </p:spPr>
+        <p:txBody>
+          <a:bodyPr wrap="square" rtlCol="0" anchor="t">
+            <a:spAutoFit/>
+          </a:bodyPr>
+          <a:lstStyle/>
+          <a:p>
+            <a:pPr indent="0" marL="0">
+              <a:buNone/>
+            </a:pPr>
+            <a:r>
+              <a:rPr lang="en-US" sz="1400" dirty="0">
+                <a:solidFill>
+                  <a:srgbClr val="1A1A1A"/>
+                </a:solidFill>
+                <a:latin typeface="Calibri" pitchFamily="34" charset="0"/>
+                <a:ea typeface="Calibri" pitchFamily="34" charset="-122"/>
+                <a:cs typeface="Calibri" pitchFamily="34" charset="-120"/>
+              </a:rPr>
+              <a:t>Explain it: why two tokenizers split a sentence differently, and what your stemming choice changed. (Competencies 3, 5.)</a:t>
+            </a:r>
+            <a:endParaRPr lang="en-US" sz="1400" dirty="0"/>
           </a:p>
         </p:txBody>
       </p:sp>
@@ -3497,6 +4135,548 @@
 <file path=ppt/slides/slide12.xml><?xml version="1.0" encoding="utf-8"?>
 <p:sld xmlns:a="http://schemas.openxmlformats.org/drawingml/2006/main" xmlns:r="http://schemas.openxmlformats.org/officeDocument/2006/relationships" xmlns:p="http://schemas.openxmlformats.org/presentationml/2006/main">
   <p:cSld name="Slide 12">
+    <p:bg>
+      <p:bgPr>
+        <a:solidFill>
+          <a:srgbClr val="FFFFFF"/>
+        </a:solidFill>
+      </p:bgPr>
+    </p:bg>
+    <p:spTree>
+      <p:nvGrpSpPr>
+        <p:cNvPr id="1" name=""/>
+        <p:cNvGrpSpPr/>
+        <p:nvPr/>
+      </p:nvGrpSpPr>
+      <p:grpSpPr>
+        <a:xfrm>
+          <a:off x="0" y="0"/>
+          <a:ext cx="0" cy="0"/>
+          <a:chOff x="0" y="0"/>
+          <a:chExt cx="0" cy="0"/>
+        </a:xfrm>
+      </p:grpSpPr>
+      <p:sp>
+        <p:nvSpPr>
+          <p:cNvPr id="2" name="Text 0"/>
+          <p:cNvSpPr/>
+          <p:nvPr/>
+        </p:nvSpPr>
+        <p:spPr>
+          <a:xfrm>
+            <a:off x="640080" y="640080"/>
+            <a:ext cx="10058400" cy="320040"/>
+          </a:xfrm>
+          <a:prstGeom prst="rect">
+            <a:avLst/>
+          </a:prstGeom>
+          <a:noFill/>
+          <a:ln/>
+        </p:spPr>
+        <p:txBody>
+          <a:bodyPr wrap="square" rtlCol="0" anchor="ctr"/>
+          <a:lstStyle/>
+          <a:p>
+            <a:pPr indent="0" marL="0">
+              <a:buNone/>
+            </a:pPr>
+            <a:r>
+              <a:rPr lang="en-US" sz="1300" b="1" spc="300" kern="0" dirty="0">
+                <a:solidFill>
+                  <a:srgbClr val="7A3B2E"/>
+                </a:solidFill>
+                <a:latin typeface="Calibri" pitchFamily="34" charset="0"/>
+                <a:ea typeface="Calibri" pitchFamily="34" charset="-122"/>
+                <a:cs typeface="Calibri" pitchFamily="34" charset="-120"/>
+              </a:rPr>
+              <a:t>HOW THIS WEEK CONNECTS</a:t>
+            </a:r>
+            <a:endParaRPr lang="en-US" sz="1300" dirty="0"/>
+          </a:p>
+        </p:txBody>
+      </p:sp>
+      <p:sp>
+        <p:nvSpPr>
+          <p:cNvPr id="3" name="Text 1"/>
+          <p:cNvSpPr/>
+          <p:nvPr/>
+        </p:nvSpPr>
+        <p:spPr>
+          <a:xfrm>
+            <a:off x="640080" y="987552"/>
+            <a:ext cx="10058400" cy="640080"/>
+          </a:xfrm>
+          <a:prstGeom prst="rect">
+            <a:avLst/>
+          </a:prstGeom>
+          <a:noFill/>
+          <a:ln/>
+        </p:spPr>
+        <p:txBody>
+          <a:bodyPr wrap="square" rtlCol="0" anchor="ctr"/>
+          <a:lstStyle/>
+          <a:p>
+            <a:pPr indent="0" marL="0">
+              <a:buNone/>
+            </a:pPr>
+            <a:r>
+              <a:rPr lang="en-US" sz="2800" b="1" dirty="0">
+                <a:solidFill>
+                  <a:srgbClr val="1A1A1A"/>
+                </a:solidFill>
+                <a:latin typeface="Cambria" pitchFamily="34" charset="0"/>
+                <a:ea typeface="Cambria" pitchFamily="34" charset="-122"/>
+                <a:cs typeface="Cambria" pitchFamily="34" charset="-120"/>
+              </a:rPr>
+              <a:t>The course's through-lines</a:t>
+            </a:r>
+            <a:endParaRPr lang="en-US" sz="2800" dirty="0"/>
+          </a:p>
+        </p:txBody>
+      </p:sp>
+      <p:sp>
+        <p:nvSpPr>
+          <p:cNvPr id="4" name="Shape 2"/>
+          <p:cNvSpPr/>
+          <p:nvPr/>
+        </p:nvSpPr>
+        <p:spPr>
+          <a:xfrm>
+            <a:off x="640080" y="2057400"/>
+            <a:ext cx="457200" cy="457200"/>
+          </a:xfrm>
+          <a:prstGeom prst="roundRect">
+            <a:avLst>
+              <a:gd name="adj" fmla="val 16000"/>
+            </a:avLst>
+          </a:prstGeom>
+          <a:solidFill>
+            <a:srgbClr val="7A3B2E"/>
+          </a:solidFill>
+          <a:ln/>
+        </p:spPr>
+      </p:sp>
+      <p:sp>
+        <p:nvSpPr>
+          <p:cNvPr id="5" name="Text 3"/>
+          <p:cNvSpPr/>
+          <p:nvPr/>
+        </p:nvSpPr>
+        <p:spPr>
+          <a:xfrm>
+            <a:off x="640080" y="2057400"/>
+            <a:ext cx="457200" cy="457200"/>
+          </a:xfrm>
+          <a:prstGeom prst="rect">
+            <a:avLst/>
+          </a:prstGeom>
+          <a:noFill/>
+          <a:ln/>
+        </p:spPr>
+        <p:txBody>
+          <a:bodyPr wrap="square" rtlCol="0" anchor="ctr"/>
+          <a:lstStyle/>
+          <a:p>
+            <a:pPr algn="ctr" indent="0" marL="0">
+              <a:buNone/>
+            </a:pPr>
+            <a:r>
+              <a:rPr lang="en-US" sz="2000" b="1" dirty="0">
+                <a:solidFill>
+                  <a:srgbClr val="FFFFFF"/>
+                </a:solidFill>
+                <a:latin typeface="Cambria" pitchFamily="34" charset="0"/>
+                <a:ea typeface="Cambria" pitchFamily="34" charset="-122"/>
+                <a:cs typeface="Cambria" pitchFamily="34" charset="-120"/>
+              </a:rPr>
+              <a:t>1</a:t>
+            </a:r>
+            <a:endParaRPr lang="en-US" sz="2000" dirty="0"/>
+          </a:p>
+        </p:txBody>
+      </p:sp>
+      <p:sp>
+        <p:nvSpPr>
+          <p:cNvPr id="6" name="Text 4"/>
+          <p:cNvSpPr/>
+          <p:nvPr/>
+        </p:nvSpPr>
+        <p:spPr>
+          <a:xfrm>
+            <a:off x="1371600" y="2020824"/>
+            <a:ext cx="10332720" cy="411480"/>
+          </a:xfrm>
+          <a:prstGeom prst="rect">
+            <a:avLst/>
+          </a:prstGeom>
+          <a:noFill/>
+          <a:ln/>
+        </p:spPr>
+        <p:txBody>
+          <a:bodyPr wrap="square" rtlCol="0" anchor="ctr"/>
+          <a:lstStyle/>
+          <a:p>
+            <a:pPr indent="0" marL="0">
+              <a:buNone/>
+            </a:pPr>
+            <a:r>
+              <a:rPr lang="en-US" sz="1900" b="1" dirty="0">
+                <a:solidFill>
+                  <a:srgbClr val="7A3B2E"/>
+                </a:solidFill>
+                <a:latin typeface="Cambria" pitchFamily="34" charset="0"/>
+                <a:ea typeface="Cambria" pitchFamily="34" charset="-122"/>
+                <a:cs typeface="Cambria" pitchFamily="34" charset="-120"/>
+              </a:rPr>
+              <a:t>Beyond counting</a:t>
+            </a:r>
+            <a:endParaRPr lang="en-US" sz="1900" dirty="0"/>
+          </a:p>
+        </p:txBody>
+      </p:sp>
+      <p:sp>
+        <p:nvSpPr>
+          <p:cNvPr id="7" name="Text 5"/>
+          <p:cNvSpPr/>
+          <p:nvPr/>
+        </p:nvSpPr>
+        <p:spPr>
+          <a:xfrm>
+            <a:off x="1371600" y="2441448"/>
+            <a:ext cx="10332720" cy="914400"/>
+          </a:xfrm>
+          <a:prstGeom prst="rect">
+            <a:avLst/>
+          </a:prstGeom>
+          <a:noFill/>
+          <a:ln/>
+        </p:spPr>
+        <p:txBody>
+          <a:bodyPr wrap="square" rtlCol="0" anchor="t">
+            <a:spAutoFit/>
+          </a:bodyPr>
+          <a:lstStyle/>
+          <a:p>
+            <a:pPr indent="0" marL="0">
+              <a:lnSpc>
+                <a:spcPct val="112000"/>
+              </a:lnSpc>
+              <a:buNone/>
+            </a:pPr>
+            <a:r>
+              <a:rPr lang="en-US" sz="1450" dirty="0">
+                <a:solidFill>
+                  <a:srgbClr val="1A1A1A"/>
+                </a:solidFill>
+                <a:latin typeface="Calibri" pitchFamily="34" charset="0"/>
+                <a:ea typeface="Calibri" pitchFamily="34" charset="-122"/>
+                <a:cs typeface="Calibri" pitchFamily="34" charset="-120"/>
+              </a:rPr>
+              <a:t>Counting is the simplest tool and has no notion of meaning. Week 5 addresses that limit.</a:t>
+            </a:r>
+            <a:endParaRPr lang="en-US" sz="1450" dirty="0"/>
+          </a:p>
+        </p:txBody>
+      </p:sp>
+      <p:sp>
+        <p:nvSpPr>
+          <p:cNvPr id="8" name="Shape 6"/>
+          <p:cNvSpPr/>
+          <p:nvPr/>
+        </p:nvSpPr>
+        <p:spPr>
+          <a:xfrm>
+            <a:off x="640080" y="3520440"/>
+            <a:ext cx="457200" cy="457200"/>
+          </a:xfrm>
+          <a:prstGeom prst="roundRect">
+            <a:avLst>
+              <a:gd name="adj" fmla="val 16000"/>
+            </a:avLst>
+          </a:prstGeom>
+          <a:solidFill>
+            <a:srgbClr val="3F6F5F"/>
+          </a:solidFill>
+          <a:ln/>
+        </p:spPr>
+      </p:sp>
+      <p:sp>
+        <p:nvSpPr>
+          <p:cNvPr id="9" name="Text 7"/>
+          <p:cNvSpPr/>
+          <p:nvPr/>
+        </p:nvSpPr>
+        <p:spPr>
+          <a:xfrm>
+            <a:off x="640080" y="3520440"/>
+            <a:ext cx="457200" cy="457200"/>
+          </a:xfrm>
+          <a:prstGeom prst="rect">
+            <a:avLst/>
+          </a:prstGeom>
+          <a:noFill/>
+          <a:ln/>
+        </p:spPr>
+        <p:txBody>
+          <a:bodyPr wrap="square" rtlCol="0" anchor="ctr"/>
+          <a:lstStyle/>
+          <a:p>
+            <a:pPr algn="ctr" indent="0" marL="0">
+              <a:buNone/>
+            </a:pPr>
+            <a:r>
+              <a:rPr lang="en-US" sz="2000" b="1" dirty="0">
+                <a:solidFill>
+                  <a:srgbClr val="FFFFFF"/>
+                </a:solidFill>
+                <a:latin typeface="Cambria" pitchFamily="34" charset="0"/>
+                <a:ea typeface="Cambria" pitchFamily="34" charset="-122"/>
+                <a:cs typeface="Cambria" pitchFamily="34" charset="-120"/>
+              </a:rPr>
+              <a:t>2</a:t>
+            </a:r>
+            <a:endParaRPr lang="en-US" sz="2000" dirty="0"/>
+          </a:p>
+        </p:txBody>
+      </p:sp>
+      <p:sp>
+        <p:nvSpPr>
+          <p:cNvPr id="10" name="Text 8"/>
+          <p:cNvSpPr/>
+          <p:nvPr/>
+        </p:nvSpPr>
+        <p:spPr>
+          <a:xfrm>
+            <a:off x="1371600" y="3483864"/>
+            <a:ext cx="10332720" cy="411480"/>
+          </a:xfrm>
+          <a:prstGeom prst="rect">
+            <a:avLst/>
+          </a:prstGeom>
+          <a:noFill/>
+          <a:ln/>
+        </p:spPr>
+        <p:txBody>
+          <a:bodyPr wrap="square" rtlCol="0" anchor="ctr"/>
+          <a:lstStyle/>
+          <a:p>
+            <a:pPr indent="0" marL="0">
+              <a:buNone/>
+            </a:pPr>
+            <a:r>
+              <a:rPr lang="en-US" sz="1900" b="1" dirty="0">
+                <a:solidFill>
+                  <a:srgbClr val="3F6F5F"/>
+                </a:solidFill>
+                <a:latin typeface="Cambria" pitchFamily="34" charset="0"/>
+                <a:ea typeface="Cambria" pitchFamily="34" charset="-122"/>
+                <a:cs typeface="Cambria" pitchFamily="34" charset="-120"/>
+              </a:rPr>
+              <a:t>Every count is a choice</a:t>
+            </a:r>
+            <a:endParaRPr lang="en-US" sz="1900" dirty="0"/>
+          </a:p>
+        </p:txBody>
+      </p:sp>
+      <p:sp>
+        <p:nvSpPr>
+          <p:cNvPr id="11" name="Text 9"/>
+          <p:cNvSpPr/>
+          <p:nvPr/>
+        </p:nvSpPr>
+        <p:spPr>
+          <a:xfrm>
+            <a:off x="1371600" y="3904488"/>
+            <a:ext cx="10332720" cy="914400"/>
+          </a:xfrm>
+          <a:prstGeom prst="rect">
+            <a:avLst/>
+          </a:prstGeom>
+          <a:noFill/>
+          <a:ln/>
+        </p:spPr>
+        <p:txBody>
+          <a:bodyPr wrap="square" rtlCol="0" anchor="t">
+            <a:spAutoFit/>
+          </a:bodyPr>
+          <a:lstStyle/>
+          <a:p>
+            <a:pPr indent="0" marL="0">
+              <a:lnSpc>
+                <a:spcPct val="112000"/>
+              </a:lnSpc>
+              <a:buNone/>
+            </a:pPr>
+            <a:r>
+              <a:rPr lang="en-US" sz="1450" dirty="0">
+                <a:solidFill>
+                  <a:srgbClr val="1A1A1A"/>
+                </a:solidFill>
+                <a:latin typeface="Calibri" pitchFamily="34" charset="0"/>
+                <a:ea typeface="Calibri" pitchFamily="34" charset="-122"/>
+                <a:cs typeface="Calibri" pitchFamily="34" charset="-120"/>
+              </a:rPr>
+              <a:t>Tokens, stemming, the corpus, the chart's axis, each hides a decision you made.</a:t>
+            </a:r>
+            <a:endParaRPr lang="en-US" sz="1450" dirty="0"/>
+          </a:p>
+        </p:txBody>
+      </p:sp>
+      <p:sp>
+        <p:nvSpPr>
+          <p:cNvPr id="12" name="Shape 10"/>
+          <p:cNvSpPr/>
+          <p:nvPr/>
+        </p:nvSpPr>
+        <p:spPr>
+          <a:xfrm>
+            <a:off x="640080" y="4983480"/>
+            <a:ext cx="457200" cy="457200"/>
+          </a:xfrm>
+          <a:prstGeom prst="roundRect">
+            <a:avLst>
+              <a:gd name="adj" fmla="val 16000"/>
+            </a:avLst>
+          </a:prstGeom>
+          <a:solidFill>
+            <a:srgbClr val="B9852F"/>
+          </a:solidFill>
+          <a:ln/>
+        </p:spPr>
+      </p:sp>
+      <p:sp>
+        <p:nvSpPr>
+          <p:cNvPr id="13" name="Text 11"/>
+          <p:cNvSpPr/>
+          <p:nvPr/>
+        </p:nvSpPr>
+        <p:spPr>
+          <a:xfrm>
+            <a:off x="640080" y="4983480"/>
+            <a:ext cx="457200" cy="457200"/>
+          </a:xfrm>
+          <a:prstGeom prst="rect">
+            <a:avLst/>
+          </a:prstGeom>
+          <a:noFill/>
+          <a:ln/>
+        </p:spPr>
+        <p:txBody>
+          <a:bodyPr wrap="square" rtlCol="0" anchor="ctr"/>
+          <a:lstStyle/>
+          <a:p>
+            <a:pPr algn="ctr" indent="0" marL="0">
+              <a:buNone/>
+            </a:pPr>
+            <a:r>
+              <a:rPr lang="en-US" sz="2000" b="1" dirty="0">
+                <a:solidFill>
+                  <a:srgbClr val="FFFFFF"/>
+                </a:solidFill>
+                <a:latin typeface="Cambria" pitchFamily="34" charset="0"/>
+                <a:ea typeface="Cambria" pitchFamily="34" charset="-122"/>
+                <a:cs typeface="Cambria" pitchFamily="34" charset="-120"/>
+              </a:rPr>
+              <a:t>3</a:t>
+            </a:r>
+            <a:endParaRPr lang="en-US" sz="2000" dirty="0"/>
+          </a:p>
+        </p:txBody>
+      </p:sp>
+      <p:sp>
+        <p:nvSpPr>
+          <p:cNvPr id="14" name="Text 12"/>
+          <p:cNvSpPr/>
+          <p:nvPr/>
+        </p:nvSpPr>
+        <p:spPr>
+          <a:xfrm>
+            <a:off x="1371600" y="4946904"/>
+            <a:ext cx="10332720" cy="411480"/>
+          </a:xfrm>
+          <a:prstGeom prst="rect">
+            <a:avLst/>
+          </a:prstGeom>
+          <a:noFill/>
+          <a:ln/>
+        </p:spPr>
+        <p:txBody>
+          <a:bodyPr wrap="square" rtlCol="0" anchor="ctr"/>
+          <a:lstStyle/>
+          <a:p>
+            <a:pPr indent="0" marL="0">
+              <a:buNone/>
+            </a:pPr>
+            <a:r>
+              <a:rPr lang="en-US" sz="1900" b="1" dirty="0">
+                <a:solidFill>
+                  <a:srgbClr val="B9852F"/>
+                </a:solidFill>
+                <a:latin typeface="Cambria" pitchFamily="34" charset="0"/>
+                <a:ea typeface="Cambria" pitchFamily="34" charset="-122"/>
+                <a:cs typeface="Cambria" pitchFamily="34" charset="-120"/>
+              </a:rPr>
+              <a:t>Is the difference real?</a:t>
+            </a:r>
+            <a:endParaRPr lang="en-US" sz="1900" dirty="0"/>
+          </a:p>
+        </p:txBody>
+      </p:sp>
+      <p:sp>
+        <p:nvSpPr>
+          <p:cNvPr id="15" name="Text 13"/>
+          <p:cNvSpPr/>
+          <p:nvPr/>
+        </p:nvSpPr>
+        <p:spPr>
+          <a:xfrm>
+            <a:off x="1371600" y="5367528"/>
+            <a:ext cx="10332720" cy="914400"/>
+          </a:xfrm>
+          <a:prstGeom prst="rect">
+            <a:avLst/>
+          </a:prstGeom>
+          <a:noFill/>
+          <a:ln/>
+        </p:spPr>
+        <p:txBody>
+          <a:bodyPr wrap="square" rtlCol="0" anchor="t">
+            <a:spAutoFit/>
+          </a:bodyPr>
+          <a:lstStyle/>
+          <a:p>
+            <a:pPr indent="0" marL="0">
+              <a:lnSpc>
+                <a:spcPct val="112000"/>
+              </a:lnSpc>
+              <a:buNone/>
+            </a:pPr>
+            <a:r>
+              <a:rPr lang="en-US" sz="1450" dirty="0">
+                <a:solidFill>
+                  <a:srgbClr val="1A1A1A"/>
+                </a:solidFill>
+                <a:latin typeface="Calibri" pitchFamily="34" charset="0"/>
+                <a:ea typeface="Calibri" pitchFamily="34" charset="-122"/>
+                <a:cs typeface="Calibri" pitchFamily="34" charset="-120"/>
+              </a:rPr>
+              <a:t>Shuffle the labels and count again, one thousand times; if chance often matches your gap, do not trust it.</a:t>
+            </a:r>
+            <a:endParaRPr lang="en-US" sz="1450" dirty="0"/>
+          </a:p>
+        </p:txBody>
+      </p:sp>
+    </p:spTree>
+  </p:cSld>
+  <p:clrMapOvr>
+    <a:masterClrMapping/>
+  </p:clrMapOvr>
+</p:sld>
+</file>
+
+<file path=ppt/slides/slide13.xml><?xml version="1.0" encoding="utf-8"?>
+<p:sld xmlns:a="http://schemas.openxmlformats.org/drawingml/2006/main" xmlns:r="http://schemas.openxmlformats.org/officeDocument/2006/relationships" xmlns:p="http://schemas.openxmlformats.org/presentationml/2006/main">
+  <p:cSld name="Slide 13">
     <p:bg>
       <p:bgPr>
         <a:solidFill>
@@ -5232,7 +6412,7 @@
                 <a:ea typeface="Cambria" pitchFamily="34" charset="-122"/>
                 <a:cs typeface="Cambria" pitchFamily="34" charset="-120"/>
               </a:rPr>
-              <a:t>Keyness: what makes a voice distinctive</a:t>
+              <a:t>What the bag throws away</a:t>
             </a:r>
             <a:endParaRPr lang="en-US" sz="3000" dirty="0"/>
           </a:p>
@@ -5267,7 +6447,7 @@
         <p:spPr>
           <a:xfrm>
             <a:off x="1097280" y="2240280"/>
-            <a:ext cx="10607040" cy="1017270"/>
+            <a:ext cx="10607040" cy="813816"/>
           </a:xfrm>
           <a:prstGeom prst="rect">
             <a:avLst/>
@@ -5288,7 +6468,7 @@
               <a:buNone/>
             </a:pPr>
             <a:r>
-              <a:rPr lang="en-US" sz="1650" dirty="0">
+              <a:rPr lang="en-US" sz="1500" dirty="0">
                 <a:solidFill>
                   <a:srgbClr val="1A1A1A"/>
                 </a:solidFill>
@@ -5296,9 +6476,9 @@
                 <a:ea typeface="Calibri" pitchFamily="34" charset="-122"/>
                 <a:cs typeface="Calibri" pitchFamily="34" charset="-120"/>
               </a:rPr>
-              <a:t>For every word: how much likelier is it in corpus A than corpus B? A log-odds ratio, smoothed so rare words don't explode.</a:t>
-            </a:r>
-            <a:endParaRPr lang="en-US" sz="1650" dirty="0"/>
+              <a:t>A bag-of-words keeps the vocabulary and discards the order: "the critics loved it, the public did not" and "the public loved it, the critics did not" are the same bag.</a:t>
+            </a:r>
+            <a:endParaRPr lang="en-US" sz="1500" dirty="0"/>
           </a:p>
         </p:txBody>
       </p:sp>
@@ -5310,7 +6490,7 @@
         </p:nvSpPr>
         <p:spPr>
           <a:xfrm>
-            <a:off x="640080" y="3348990"/>
+            <a:off x="640080" y="3145536"/>
             <a:ext cx="201168" cy="201168"/>
           </a:xfrm>
           <a:prstGeom prst="ellipse">
@@ -5330,8 +6510,8 @@
         </p:nvSpPr>
         <p:spPr>
           <a:xfrm>
-            <a:off x="1097280" y="3257550"/>
-            <a:ext cx="10607040" cy="1017270"/>
+            <a:off x="1097280" y="3054096"/>
+            <a:ext cx="10607040" cy="813816"/>
           </a:xfrm>
           <a:prstGeom prst="rect">
             <a:avLst/>
@@ -5352,7 +6532,7 @@
               <a:buNone/>
             </a:pPr>
             <a:r>
-              <a:rPr lang="en-US" sz="1650" dirty="0">
+              <a:rPr lang="en-US" sz="1500" dirty="0">
                 <a:solidFill>
                   <a:srgbClr val="1A1A1A"/>
                 </a:solidFill>
@@ -5360,9 +6540,9 @@
                 <a:ea typeface="Calibri" pitchFamily="34" charset="-122"/>
                 <a:cs typeface="Calibri" pitchFamily="34" charset="-120"/>
               </a:rPr>
-              <a:t>Strongly positive = distinctively A. Strongly negative = distinctively B. The middle is shared language.</a:t>
-            </a:r>
-            <a:endParaRPr lang="en-US" sz="1650" dirty="0"/>
+              <a:t>Negation goes with it: "not good, actually bad" and "not bad, actually good" count identically.</a:t>
+            </a:r>
+            <a:endParaRPr lang="en-US" sz="1500" dirty="0"/>
           </a:p>
         </p:txBody>
       </p:sp>
@@ -5374,7 +6554,7 @@
         </p:nvSpPr>
         <p:spPr>
           <a:xfrm>
-            <a:off x="640080" y="4366260"/>
+            <a:off x="640080" y="3959352"/>
             <a:ext cx="201168" cy="201168"/>
           </a:xfrm>
           <a:prstGeom prst="ellipse">
@@ -5394,8 +6574,8 @@
         </p:nvSpPr>
         <p:spPr>
           <a:xfrm>
-            <a:off x="1097280" y="4274820"/>
-            <a:ext cx="10607040" cy="1017270"/>
+            <a:off x="1097280" y="3867912"/>
+            <a:ext cx="10607040" cy="813816"/>
           </a:xfrm>
           <a:prstGeom prst="rect">
             <a:avLst/>
@@ -5416,7 +6596,7 @@
               <a:buNone/>
             </a:pPr>
             <a:r>
-              <a:rPr lang="en-US" sz="1650" dirty="0">
+              <a:rPr lang="en-US" sz="1500" dirty="0">
                 <a:solidFill>
                   <a:srgbClr val="1A1A1A"/>
                 </a:solidFill>
@@ -5424,9 +6604,9 @@
                 <a:ea typeface="Calibri" pitchFamily="34" charset="-122"/>
                 <a:cs typeface="Calibri" pitchFamily="34" charset="-120"/>
               </a:rPr>
-              <a:t>She Giggles, He Gallops is exactly this method: verbs after "she" vs. "he" in 2,000 screenplays. Women snuggle, giggle, squeal; men gallop, strap, shoot.</a:t>
-            </a:r>
-            <a:endParaRPr lang="en-US" sz="1650" dirty="0"/>
+              <a:t>The bag-of-pixels loses the same way: a portrait and its shuffled pixels share the average color, the brightness, and the histogram. Composition is to images what word order is to sentences.</a:t>
+            </a:r>
+            <a:endParaRPr lang="en-US" sz="1500" dirty="0"/>
           </a:p>
         </p:txBody>
       </p:sp>
@@ -5438,7 +6618,7 @@
         </p:nvSpPr>
         <p:spPr>
           <a:xfrm>
-            <a:off x="640080" y="5383530"/>
+            <a:off x="640080" y="4773168"/>
             <a:ext cx="201168" cy="201168"/>
           </a:xfrm>
           <a:prstGeom prst="ellipse">
@@ -5458,8 +6638,8 @@
         </p:nvSpPr>
         <p:spPr>
           <a:xfrm>
-            <a:off x="1097280" y="5292090"/>
-            <a:ext cx="10607040" cy="1017270"/>
+            <a:off x="1097280" y="4681728"/>
+            <a:ext cx="10607040" cy="813816"/>
           </a:xfrm>
           <a:prstGeom prst="rect">
             <a:avLst/>
@@ -5480,7 +6660,7 @@
               <a:buNone/>
             </a:pPr>
             <a:r>
-              <a:rPr lang="en-US" sz="1650" dirty="0">
+              <a:rPr lang="en-US" sz="1500" dirty="0">
                 <a:solidFill>
                   <a:srgbClr val="1A1A1A"/>
                 </a:solidFill>
@@ -5488,9 +6668,73 @@
                 <a:ea typeface="Calibri" pitchFamily="34" charset="-122"/>
                 <a:cs typeface="Calibri" pitchFamily="34" charset="-120"/>
               </a:rPr>
-              <a:t>The corpus pair is a choice: this artist against pop, this subreddit against a novel. Different pair, different "distinctive."</a:t>
-            </a:r>
-            <a:endParaRPr lang="en-US" sz="1650" dirty="0"/>
+              <a:t>Every count this week carries that loss. It is a trade made for scale, and naming it is part of the method.</a:t>
+            </a:r>
+            <a:endParaRPr lang="en-US" sz="1500" dirty="0"/>
+          </a:p>
+        </p:txBody>
+      </p:sp>
+      <p:sp>
+        <p:nvSpPr>
+          <p:cNvPr id="13" name="Shape 11"/>
+          <p:cNvSpPr/>
+          <p:nvPr/>
+        </p:nvSpPr>
+        <p:spPr>
+          <a:xfrm>
+            <a:off x="640080" y="5586984"/>
+            <a:ext cx="201168" cy="201168"/>
+          </a:xfrm>
+          <a:prstGeom prst="ellipse">
+            <a:avLst/>
+          </a:prstGeom>
+          <a:solidFill>
+            <a:srgbClr val="3F6F5F"/>
+          </a:solidFill>
+          <a:ln/>
+        </p:spPr>
+      </p:sp>
+      <p:sp>
+        <p:nvSpPr>
+          <p:cNvPr id="14" name="Text 12"/>
+          <p:cNvSpPr/>
+          <p:nvPr/>
+        </p:nvSpPr>
+        <p:spPr>
+          <a:xfrm>
+            <a:off x="1097280" y="5495544"/>
+            <a:ext cx="10607040" cy="813816"/>
+          </a:xfrm>
+          <a:prstGeom prst="rect">
+            <a:avLst/>
+          </a:prstGeom>
+          <a:noFill/>
+          <a:ln/>
+        </p:spPr>
+        <p:txBody>
+          <a:bodyPr wrap="square" rtlCol="0" anchor="t">
+            <a:spAutoFit/>
+          </a:bodyPr>
+          <a:lstStyle/>
+          <a:p>
+            <a:pPr indent="0" marL="0">
+              <a:lnSpc>
+                <a:spcPct val="112000"/>
+              </a:lnSpc>
+              <a:buNone/>
+            </a:pPr>
+            <a:r>
+              <a:rPr lang="en-US" sz="1500" dirty="0">
+                <a:solidFill>
+                  <a:srgbClr val="1A1A1A"/>
+                </a:solidFill>
+                <a:latin typeface="Calibri" pitchFamily="34" charset="0"/>
+                <a:ea typeface="Calibri" pitchFamily="34" charset="-122"/>
+                <a:cs typeface="Calibri" pitchFamily="34" charset="-120"/>
+              </a:rPr>
+              <a:t>Week 5's embeddings exist to recover some of what the bag cannot hold: words represented by the company they keep.</a:t>
+            </a:r>
+            <a:endParaRPr lang="en-US" sz="1500" dirty="0"/>
           </a:p>
         </p:txBody>
       </p:sp>
@@ -5620,7 +6864,7 @@
                 <a:ea typeface="Cambria" pitchFamily="34" charset="-122"/>
                 <a:cs typeface="Cambria" pitchFamily="34" charset="-120"/>
               </a:rPr>
-              <a:t>The shuffle test: is the gap real?</a:t>
+              <a:t>Keyness: what makes a voice distinctive</a:t>
             </a:r>
             <a:endParaRPr lang="en-US" sz="3000" dirty="0"/>
           </a:p>
@@ -5684,7 +6928,7 @@
                 <a:ea typeface="Calibri" pitchFamily="34" charset="-122"/>
                 <a:cs typeface="Calibri" pitchFamily="34" charset="-120"/>
               </a:rPr>
-              <a:t>The question: could randomly dealt labels produce a gap this large?</a:t>
+              <a:t>For every word: how much likelier is it in corpus A than corpus B? A log-odds ratio, smoothed so rare words don't explode.</a:t>
             </a:r>
             <a:endParaRPr lang="en-US" sz="1650" dirty="0"/>
           </a:p>
@@ -5748,7 +6992,7 @@
                 <a:ea typeface="Calibri" pitchFamily="34" charset="-122"/>
                 <a:cs typeface="Calibri" pitchFamily="34" charset="-120"/>
               </a:rPr>
-              <a:t>Shuffle the labels, recount, 1,000 times. Mark where the real gap lands in that pile.</a:t>
+              <a:t>Strongly positive = distinctively A. Strongly negative = distinctively B. The middle is shared language.</a:t>
             </a:r>
             <a:endParaRPr lang="en-US" sz="1650" dirty="0"/>
           </a:p>
@@ -5812,7 +7056,7 @@
                 <a:ea typeface="Calibri" pitchFamily="34" charset="-122"/>
                 <a:cs typeface="Calibri" pitchFamily="34" charset="-120"/>
               </a:rPr>
-              <a:t>Chance rarely matches it: a finding. Chance matches it often: a coincidence.</a:t>
+              <a:t>She Giggles, He Gallops is exactly this method: verbs after "she" vs. "he" in 2,000 screenplays. Women snuggle, giggle, squeal; men gallop, strap, shoot.</a:t>
             </a:r>
             <a:endParaRPr lang="en-US" sz="1650" dirty="0"/>
           </a:p>
@@ -5876,7 +7120,7 @@
                 <a:ea typeface="Calibri" pitchFamily="34" charset="-122"/>
                 <a:cs typeface="Calibri" pitchFamily="34" charset="-120"/>
               </a:rPr>
-              <a:t>It says "probably not chance." It never says "big enough to matter." Effect size is your argument to make.</a:t>
+              <a:t>The corpus pair is a choice: this artist against pop, this subreddit against a novel. Different pair, different "distinctive."</a:t>
             </a:r>
             <a:endParaRPr lang="en-US" sz="1650" dirty="0"/>
           </a:p>
@@ -5916,14 +7160,34 @@
       </p:grpSpPr>
       <p:sp>
         <p:nvSpPr>
-          <p:cNvPr id="2" name="Text 0"/>
-          <p:cNvSpPr/>
-          <p:nvPr/>
-        </p:nvSpPr>
-        <p:spPr>
-          <a:xfrm>
-            <a:off x="640080" y="731520"/>
-            <a:ext cx="10058400" cy="731520"/>
+          <p:cNvPr id="2" name="Shape 0"/>
+          <p:cNvSpPr/>
+          <p:nvPr/>
+        </p:nvSpPr>
+        <p:spPr>
+          <a:xfrm>
+            <a:off x="0" y="0"/>
+            <a:ext cx="164592" cy="6858000"/>
+          </a:xfrm>
+          <a:prstGeom prst="rect">
+            <a:avLst/>
+          </a:prstGeom>
+          <a:solidFill>
+            <a:srgbClr val="3F6F5F"/>
+          </a:solidFill>
+          <a:ln/>
+        </p:spPr>
+      </p:sp>
+      <p:sp>
+        <p:nvSpPr>
+          <p:cNvPr id="3" name="Text 1"/>
+          <p:cNvSpPr/>
+          <p:nvPr/>
+        </p:nvSpPr>
+        <p:spPr>
+          <a:xfrm>
+            <a:off x="640080" y="640080"/>
+            <a:ext cx="10058400" cy="320040"/>
           </a:xfrm>
           <a:prstGeom prst="rect">
             <a:avLst/>
@@ -5933,6 +7197,47 @@
         </p:spPr>
         <p:txBody>
           <a:bodyPr wrap="square" rtlCol="0" anchor="ctr"/>
+          <a:lstStyle/>
+          <a:p>
+            <a:pPr indent="0" marL="0">
+              <a:buNone/>
+            </a:pPr>
+            <a:r>
+              <a:rPr lang="en-US" sz="1200" b="1" spc="300" kern="0" dirty="0">
+                <a:solidFill>
+                  <a:srgbClr val="3F6F5F"/>
+                </a:solidFill>
+                <a:latin typeface="Calibri" pitchFamily="34" charset="0"/>
+                <a:ea typeface="Calibri" pitchFamily="34" charset="-122"/>
+                <a:cs typeface="Calibri" pitchFamily="34" charset="-120"/>
+              </a:rPr>
+              <a:t>WEEK 2 · KEY POINTS</a:t>
+            </a:r>
+            <a:endParaRPr lang="en-US" sz="1200" dirty="0"/>
+          </a:p>
+        </p:txBody>
+      </p:sp>
+      <p:sp>
+        <p:nvSpPr>
+          <p:cNvPr id="4" name="Text 2"/>
+          <p:cNvSpPr/>
+          <p:nvPr/>
+        </p:nvSpPr>
+        <p:spPr>
+          <a:xfrm>
+            <a:off x="640080" y="1005840"/>
+            <a:ext cx="10881360" cy="914400"/>
+          </a:xfrm>
+          <a:prstGeom prst="rect">
+            <a:avLst/>
+          </a:prstGeom>
+          <a:noFill/>
+          <a:ln/>
+        </p:spPr>
+        <p:txBody>
+          <a:bodyPr wrap="square" rtlCol="0" anchor="t">
+            <a:spAutoFit/>
+          </a:bodyPr>
           <a:lstStyle/>
           <a:p>
             <a:pPr indent="0" marL="0">
@@ -5947,7 +7252,7 @@
                 <a:ea typeface="Cambria" pitchFamily="34" charset="-122"/>
                 <a:cs typeface="Cambria" pitchFamily="34" charset="-120"/>
               </a:rPr>
-              <a:t>Three modes today</a:t>
+              <a:t>The shuffle test: is the gap real?</a:t>
             </a:r>
             <a:endParaRPr lang="en-US" sz="3000" dirty="0"/>
           </a:p>
@@ -5955,134 +7260,98 @@
       </p:sp>
       <p:sp>
         <p:nvSpPr>
-          <p:cNvPr id="3" name="Text 1"/>
-          <p:cNvSpPr/>
-          <p:nvPr/>
-        </p:nvSpPr>
-        <p:spPr>
-          <a:xfrm>
-            <a:off x="640080" y="1417320"/>
-            <a:ext cx="10058400" cy="365760"/>
-          </a:xfrm>
-          <a:prstGeom prst="rect">
-            <a:avLst/>
-          </a:prstGeom>
-          <a:noFill/>
-          <a:ln/>
-        </p:spPr>
-        <p:txBody>
-          <a:bodyPr wrap="square" rtlCol="0" anchor="ctr"/>
+          <p:cNvPr id="5" name="Shape 3"/>
+          <p:cNvSpPr/>
+          <p:nvPr/>
+        </p:nvSpPr>
+        <p:spPr>
+          <a:xfrm>
+            <a:off x="640080" y="2331720"/>
+            <a:ext cx="201168" cy="201168"/>
+          </a:xfrm>
+          <a:prstGeom prst="ellipse">
+            <a:avLst/>
+          </a:prstGeom>
+          <a:solidFill>
+            <a:srgbClr val="7A3B2E"/>
+          </a:solidFill>
+          <a:ln/>
+        </p:spPr>
+      </p:sp>
+      <p:sp>
+        <p:nvSpPr>
+          <p:cNvPr id="6" name="Text 4"/>
+          <p:cNvSpPr/>
+          <p:nvPr/>
+        </p:nvSpPr>
+        <p:spPr>
+          <a:xfrm>
+            <a:off x="1097280" y="2240280"/>
+            <a:ext cx="10607040" cy="1017270"/>
+          </a:xfrm>
+          <a:prstGeom prst="rect">
+            <a:avLst/>
+          </a:prstGeom>
+          <a:noFill/>
+          <a:ln/>
+        </p:spPr>
+        <p:txBody>
+          <a:bodyPr wrap="square" rtlCol="0" anchor="t">
+            <a:spAutoFit/>
+          </a:bodyPr>
           <a:lstStyle/>
           <a:p>
             <a:pPr indent="0" marL="0">
-              <a:buNone/>
-            </a:pPr>
-            <a:r>
-              <a:rPr lang="en-US" sz="1400" i="1" dirty="0">
-                <a:solidFill>
-                  <a:srgbClr val="6B6B63"/>
+              <a:lnSpc>
+                <a:spcPct val="112000"/>
+              </a:lnSpc>
+              <a:buNone/>
+            </a:pPr>
+            <a:r>
+              <a:rPr lang="en-US" sz="1650" dirty="0">
+                <a:solidFill>
+                  <a:srgbClr val="1A1A1A"/>
                 </a:solidFill>
                 <a:latin typeface="Calibri" pitchFamily="34" charset="0"/>
                 <a:ea typeface="Calibri" pitchFamily="34" charset="-122"/>
                 <a:cs typeface="Calibri" pitchFamily="34" charset="-120"/>
               </a:rPr>
-              <a:t>about a third of the session each</a:t>
-            </a:r>
-            <a:endParaRPr lang="en-US" sz="1400" dirty="0"/>
-          </a:p>
-        </p:txBody>
-      </p:sp>
-      <p:sp>
-        <p:nvSpPr>
-          <p:cNvPr id="4" name="Shape 2"/>
-          <p:cNvSpPr/>
-          <p:nvPr/>
-        </p:nvSpPr>
-        <p:spPr>
-          <a:xfrm>
-            <a:off x="640080" y="2194560"/>
-            <a:ext cx="3383280" cy="3291840"/>
-          </a:xfrm>
-          <a:prstGeom prst="roundRect">
-            <a:avLst>
-              <a:gd name="adj" fmla="val 3333"/>
-            </a:avLst>
-          </a:prstGeom>
-          <a:solidFill>
-            <a:srgbClr val="F4EEE8"/>
-          </a:solidFill>
-          <a:ln/>
-        </p:spPr>
-      </p:sp>
-      <p:sp>
-        <p:nvSpPr>
-          <p:cNvPr id="5" name="Shape 3"/>
-          <p:cNvSpPr/>
-          <p:nvPr/>
-        </p:nvSpPr>
-        <p:spPr>
-          <a:xfrm>
-            <a:off x="1051560" y="2606040"/>
-            <a:ext cx="548640" cy="548640"/>
+              <a:t>The question: could randomly dealt labels produce a gap this large?</a:t>
+            </a:r>
+            <a:endParaRPr lang="en-US" sz="1650" dirty="0"/>
+          </a:p>
+        </p:txBody>
+      </p:sp>
+      <p:sp>
+        <p:nvSpPr>
+          <p:cNvPr id="7" name="Shape 5"/>
+          <p:cNvSpPr/>
+          <p:nvPr/>
+        </p:nvSpPr>
+        <p:spPr>
+          <a:xfrm>
+            <a:off x="640080" y="3348990"/>
+            <a:ext cx="201168" cy="201168"/>
           </a:xfrm>
           <a:prstGeom prst="ellipse">
             <a:avLst/>
           </a:prstGeom>
           <a:solidFill>
-            <a:srgbClr val="7A3B2E"/>
-          </a:solidFill>
-          <a:ln/>
-        </p:spPr>
-      </p:sp>
-      <p:sp>
-        <p:nvSpPr>
-          <p:cNvPr id="6" name="Text 4"/>
-          <p:cNvSpPr/>
-          <p:nvPr/>
-        </p:nvSpPr>
-        <p:spPr>
-          <a:xfrm>
-            <a:off x="1005840" y="3383280"/>
-            <a:ext cx="2651760" cy="548640"/>
-          </a:xfrm>
-          <a:prstGeom prst="rect">
-            <a:avLst/>
-          </a:prstGeom>
-          <a:noFill/>
-          <a:ln/>
-        </p:spPr>
-        <p:txBody>
-          <a:bodyPr wrap="square" rtlCol="0" anchor="ctr"/>
-          <a:lstStyle/>
-          <a:p>
-            <a:pPr indent="0" marL="0">
-              <a:buNone/>
-            </a:pPr>
-            <a:r>
-              <a:rPr lang="en-US" sz="2100" b="1" dirty="0">
-                <a:solidFill>
-                  <a:srgbClr val="1A1A1A"/>
-                </a:solidFill>
-                <a:latin typeface="Cambria" pitchFamily="34" charset="0"/>
-                <a:ea typeface="Cambria" pitchFamily="34" charset="-122"/>
-                <a:cs typeface="Cambria" pitchFamily="34" charset="-120"/>
-              </a:rPr>
-              <a:t>Lecture / demo</a:t>
-            </a:r>
-            <a:endParaRPr lang="en-US" sz="2100" dirty="0"/>
-          </a:p>
-        </p:txBody>
-      </p:sp>
-      <p:sp>
-        <p:nvSpPr>
-          <p:cNvPr id="7" name="Text 5"/>
-          <p:cNvSpPr/>
-          <p:nvPr/>
-        </p:nvSpPr>
-        <p:spPr>
-          <a:xfrm>
-            <a:off x="1005840" y="3977640"/>
-            <a:ext cx="2651760" cy="1371600"/>
+            <a:srgbClr val="3F6F5F"/>
+          </a:solidFill>
+          <a:ln/>
+        </p:spPr>
+      </p:sp>
+      <p:sp>
+        <p:nvSpPr>
+          <p:cNvPr id="8" name="Text 6"/>
+          <p:cNvSpPr/>
+          <p:nvPr/>
+        </p:nvSpPr>
+        <p:spPr>
+          <a:xfrm>
+            <a:off x="1097280" y="3257550"/>
+            <a:ext cx="10607040" cy="1017270"/>
           </a:xfrm>
           <a:prstGeom prst="rect">
             <a:avLst/>
@@ -6098,12 +7367,12 @@
           <a:p>
             <a:pPr indent="0" marL="0">
               <a:lnSpc>
-                <a:spcPct val="115000"/>
+                <a:spcPct val="112000"/>
               </a:lnSpc>
               <a:buNone/>
             </a:pPr>
             <a:r>
-              <a:rPr lang="en-US" sz="1500" dirty="0">
+              <a:rPr lang="en-US" sz="1650" dirty="0">
                 <a:solidFill>
                   <a:srgbClr val="1A1A1A"/>
                 </a:solidFill>
@@ -6111,33 +7380,11 @@
                 <a:ea typeface="Calibri" pitchFamily="34" charset="-122"/>
                 <a:cs typeface="Calibri" pitchFamily="34" charset="-120"/>
               </a:rPr>
-              <a:t>Advanced counting: baselines, keyness, and the shuffle test</a:t>
-            </a:r>
-            <a:endParaRPr lang="en-US" sz="1500" dirty="0"/>
-          </a:p>
-        </p:txBody>
-      </p:sp>
-      <p:sp>
-        <p:nvSpPr>
-          <p:cNvPr id="8" name="Shape 6"/>
-          <p:cNvSpPr/>
-          <p:nvPr/>
-        </p:nvSpPr>
-        <p:spPr>
-          <a:xfrm>
-            <a:off x="4526280" y="2194560"/>
-            <a:ext cx="3383280" cy="3291840"/>
-          </a:xfrm>
-          <a:prstGeom prst="roundRect">
-            <a:avLst>
-              <a:gd name="adj" fmla="val 3333"/>
-            </a:avLst>
-          </a:prstGeom>
-          <a:solidFill>
-            <a:srgbClr val="F4EEE8"/>
-          </a:solidFill>
-          <a:ln/>
-        </p:spPr>
+              <a:t>Shuffle the labels, recount, 1,000 times. Mark where the real gap lands in that pile.</a:t>
+            </a:r>
+            <a:endParaRPr lang="en-US" sz="1650" dirty="0"/>
+          </a:p>
+        </p:txBody>
       </p:sp>
       <p:sp>
         <p:nvSpPr>
@@ -6147,14 +7394,14 @@
         </p:nvSpPr>
         <p:spPr>
           <a:xfrm>
-            <a:off x="4937760" y="2606040"/>
-            <a:ext cx="548640" cy="548640"/>
+            <a:off x="640080" y="4366260"/>
+            <a:ext cx="201168" cy="201168"/>
           </a:xfrm>
           <a:prstGeom prst="ellipse">
             <a:avLst/>
           </a:prstGeom>
           <a:solidFill>
-            <a:srgbClr val="3F6F5F"/>
+            <a:srgbClr val="B9852F"/>
           </a:solidFill>
           <a:ln/>
         </p:spPr>
@@ -6167,47 +7414,8 @@
         </p:nvSpPr>
         <p:spPr>
           <a:xfrm>
-            <a:off x="4892040" y="3383280"/>
-            <a:ext cx="2651760" cy="548640"/>
-          </a:xfrm>
-          <a:prstGeom prst="rect">
-            <a:avLst/>
-          </a:prstGeom>
-          <a:noFill/>
-          <a:ln/>
-        </p:spPr>
-        <p:txBody>
-          <a:bodyPr wrap="square" rtlCol="0" anchor="ctr"/>
-          <a:lstStyle/>
-          <a:p>
-            <a:pPr indent="0" marL="0">
-              <a:buNone/>
-            </a:pPr>
-            <a:r>
-              <a:rPr lang="en-US" sz="2100" b="1" dirty="0">
-                <a:solidFill>
-                  <a:srgbClr val="1A1A1A"/>
-                </a:solidFill>
-                <a:latin typeface="Cambria" pitchFamily="34" charset="0"/>
-                <a:ea typeface="Cambria" pitchFamily="34" charset="-122"/>
-                <a:cs typeface="Cambria" pitchFamily="34" charset="-120"/>
-              </a:rPr>
-              <a:t>Workshop</a:t>
-            </a:r>
-            <a:endParaRPr lang="en-US" sz="2100" dirty="0"/>
-          </a:p>
-        </p:txBody>
-      </p:sp>
-      <p:sp>
-        <p:nvSpPr>
-          <p:cNvPr id="11" name="Text 9"/>
-          <p:cNvSpPr/>
-          <p:nvPr/>
-        </p:nvSpPr>
-        <p:spPr>
-          <a:xfrm>
-            <a:off x="4892040" y="3977640"/>
-            <a:ext cx="2651760" cy="1371600"/>
+            <a:off x="1097280" y="4274820"/>
+            <a:ext cx="10607040" cy="1017270"/>
           </a:xfrm>
           <a:prstGeom prst="rect">
             <a:avLst/>
@@ -6223,12 +7431,12 @@
           <a:p>
             <a:pPr indent="0" marL="0">
               <a:lnSpc>
-                <a:spcPct val="115000"/>
+                <a:spcPct val="112000"/>
               </a:lnSpc>
               <a:buNone/>
             </a:pPr>
             <a:r>
-              <a:rPr lang="en-US" sz="1500" dirty="0">
+              <a:rPr lang="en-US" sz="1650" dirty="0">
                 <a:solidFill>
                   <a:srgbClr val="1A1A1A"/>
                 </a:solidFill>
@@ -6236,103 +7444,42 @@
                 <a:ea typeface="Calibri" pitchFamily="34" charset="-122"/>
                 <a:cs typeface="Calibri" pitchFamily="34" charset="-120"/>
               </a:rPr>
-              <a:t>Build hands-on on your own data.</a:t>
-            </a:r>
-            <a:endParaRPr lang="en-US" sz="1500" dirty="0"/>
-          </a:p>
-        </p:txBody>
-      </p:sp>
-      <p:sp>
-        <p:nvSpPr>
-          <p:cNvPr id="12" name="Shape 10"/>
-          <p:cNvSpPr/>
-          <p:nvPr/>
-        </p:nvSpPr>
-        <p:spPr>
-          <a:xfrm>
-            <a:off x="8412480" y="2194560"/>
-            <a:ext cx="3383280" cy="3291840"/>
-          </a:xfrm>
-          <a:prstGeom prst="roundRect">
-            <a:avLst>
-              <a:gd name="adj" fmla="val 3333"/>
-            </a:avLst>
-          </a:prstGeom>
-          <a:solidFill>
-            <a:srgbClr val="F4EEE8"/>
-          </a:solidFill>
-          <a:ln/>
-        </p:spPr>
-      </p:sp>
-      <p:sp>
-        <p:nvSpPr>
-          <p:cNvPr id="13" name="Shape 11"/>
-          <p:cNvSpPr/>
-          <p:nvPr/>
-        </p:nvSpPr>
-        <p:spPr>
-          <a:xfrm>
-            <a:off x="8823960" y="2606040"/>
-            <a:ext cx="548640" cy="548640"/>
+              <a:t>Chance rarely matches it: a finding. Chance matches it often: a coincidence.</a:t>
+            </a:r>
+            <a:endParaRPr lang="en-US" sz="1650" dirty="0"/>
+          </a:p>
+        </p:txBody>
+      </p:sp>
+      <p:sp>
+        <p:nvSpPr>
+          <p:cNvPr id="11" name="Shape 9"/>
+          <p:cNvSpPr/>
+          <p:nvPr/>
+        </p:nvSpPr>
+        <p:spPr>
+          <a:xfrm>
+            <a:off x="640080" y="5383530"/>
+            <a:ext cx="201168" cy="201168"/>
           </a:xfrm>
           <a:prstGeom prst="ellipse">
             <a:avLst/>
           </a:prstGeom>
           <a:solidFill>
-            <a:srgbClr val="B9852F"/>
-          </a:solidFill>
-          <a:ln/>
-        </p:spPr>
-      </p:sp>
-      <p:sp>
-        <p:nvSpPr>
-          <p:cNvPr id="14" name="Text 12"/>
-          <p:cNvSpPr/>
-          <p:nvPr/>
-        </p:nvSpPr>
-        <p:spPr>
-          <a:xfrm>
-            <a:off x="8778240" y="3383280"/>
-            <a:ext cx="2651760" cy="548640"/>
-          </a:xfrm>
-          <a:prstGeom prst="rect">
-            <a:avLst/>
-          </a:prstGeom>
-          <a:noFill/>
-          <a:ln/>
-        </p:spPr>
-        <p:txBody>
-          <a:bodyPr wrap="square" rtlCol="0" anchor="ctr"/>
-          <a:lstStyle/>
-          <a:p>
-            <a:pPr indent="0" marL="0">
-              <a:buNone/>
-            </a:pPr>
-            <a:r>
-              <a:rPr lang="en-US" sz="2100" b="1" dirty="0">
-                <a:solidFill>
-                  <a:srgbClr val="1A1A1A"/>
-                </a:solidFill>
-                <a:latin typeface="Cambria" pitchFamily="34" charset="0"/>
-                <a:ea typeface="Cambria" pitchFamily="34" charset="-122"/>
-                <a:cs typeface="Cambria" pitchFamily="34" charset="-120"/>
-              </a:rPr>
-              <a:t>Discussion</a:t>
-            </a:r>
-            <a:endParaRPr lang="en-US" sz="2100" dirty="0"/>
-          </a:p>
-        </p:txBody>
-      </p:sp>
-      <p:sp>
-        <p:nvSpPr>
-          <p:cNvPr id="15" name="Text 13"/>
-          <p:cNvSpPr/>
-          <p:nvPr/>
-        </p:nvSpPr>
-        <p:spPr>
-          <a:xfrm>
-            <a:off x="8778240" y="3977640"/>
-            <a:ext cx="2651760" cy="1371600"/>
+            <a:srgbClr val="7A3B2E"/>
+          </a:solidFill>
+          <a:ln/>
+        </p:spPr>
+      </p:sp>
+      <p:sp>
+        <p:nvSpPr>
+          <p:cNvPr id="12" name="Text 10"/>
+          <p:cNvSpPr/>
+          <p:nvPr/>
+        </p:nvSpPr>
+        <p:spPr>
+          <a:xfrm>
+            <a:off x="1097280" y="5292090"/>
+            <a:ext cx="10607040" cy="1017270"/>
           </a:xfrm>
           <a:prstGeom prst="rect">
             <a:avLst/>
@@ -6348,12 +7495,12 @@
           <a:p>
             <a:pPr indent="0" marL="0">
               <a:lnSpc>
-                <a:spcPct val="115000"/>
+                <a:spcPct val="112000"/>
               </a:lnSpc>
               <a:buNone/>
             </a:pPr>
             <a:r>
-              <a:rPr lang="en-US" sz="1500" dirty="0">
+              <a:rPr lang="en-US" sz="1650" dirty="0">
                 <a:solidFill>
                   <a:srgbClr val="1A1A1A"/>
                 </a:solidFill>
@@ -6361,9 +7508,9 @@
                 <a:ea typeface="Calibri" pitchFamily="34" charset="-122"/>
                 <a:cs typeface="Calibri" pitchFamily="34" charset="-120"/>
               </a:rPr>
-              <a:t>Interrogate the study, debate it, or critique each other's work.</a:t>
-            </a:r>
-            <a:endParaRPr lang="en-US" sz="1500" dirty="0"/>
+              <a:t>It says "probably not chance." It never says "big enough to matter." Effect size is your argument to make.</a:t>
+            </a:r>
+            <a:endParaRPr lang="en-US" sz="1650" dirty="0"/>
           </a:p>
         </p:txBody>
       </p:sp>
@@ -6407,7 +7554,7 @@
         </p:nvSpPr>
         <p:spPr>
           <a:xfrm>
-            <a:off x="640080" y="640080"/>
+            <a:off x="640080" y="731520"/>
             <a:ext cx="10058400" cy="731520"/>
           </a:xfrm>
           <a:prstGeom prst="rect">
@@ -6432,7 +7579,7 @@
                 <a:ea typeface="Cambria" pitchFamily="34" charset="-122"/>
                 <a:cs typeface="Cambria" pitchFamily="34" charset="-120"/>
               </a:rPr>
-              <a:t>The session</a:t>
+              <a:t>Three modes today</a:t>
             </a:r>
             <a:endParaRPr lang="en-US" sz="3000" dirty="0"/>
           </a:p>
@@ -6440,36 +7587,14 @@
       </p:sp>
       <p:sp>
         <p:nvSpPr>
-          <p:cNvPr id="3" name="Shape 1"/>
-          <p:cNvSpPr/>
-          <p:nvPr/>
-        </p:nvSpPr>
-        <p:spPr>
-          <a:xfrm>
-            <a:off x="640080" y="1572768"/>
-            <a:ext cx="868680" cy="338328"/>
-          </a:xfrm>
-          <a:prstGeom prst="roundRect">
-            <a:avLst>
-              <a:gd name="adj" fmla="val 16216"/>
-            </a:avLst>
-          </a:prstGeom>
-          <a:solidFill>
-            <a:srgbClr val="7A3B2E"/>
-          </a:solidFill>
-          <a:ln/>
-        </p:spPr>
-      </p:sp>
-      <p:sp>
-        <p:nvSpPr>
-          <p:cNvPr id="4" name="Text 2"/>
-          <p:cNvSpPr/>
-          <p:nvPr/>
-        </p:nvSpPr>
-        <p:spPr>
-          <a:xfrm>
-            <a:off x="640080" y="1572768"/>
-            <a:ext cx="868680" cy="338328"/>
+          <p:cNvPr id="3" name="Text 1"/>
+          <p:cNvSpPr/>
+          <p:nvPr/>
+        </p:nvSpPr>
+        <p:spPr>
+          <a:xfrm>
+            <a:off x="640080" y="1417320"/>
+            <a:ext cx="10058400" cy="365760"/>
           </a:xfrm>
           <a:prstGeom prst="rect">
             <a:avLst/>
@@ -6481,52 +7606,136 @@
           <a:bodyPr wrap="square" rtlCol="0" anchor="ctr"/>
           <a:lstStyle/>
           <a:p>
-            <a:pPr algn="ctr" indent="0" marL="0">
-              <a:buNone/>
-            </a:pPr>
-            <a:r>
-              <a:rPr lang="en-US" sz="1100" b="1" dirty="0">
-                <a:solidFill>
-                  <a:srgbClr val="FFFFFF"/>
+            <a:pPr indent="0" marL="0">
+              <a:buNone/>
+            </a:pPr>
+            <a:r>
+              <a:rPr lang="en-US" sz="1400" i="1" dirty="0">
+                <a:solidFill>
+                  <a:srgbClr val="6B6B63"/>
                 </a:solidFill>
                 <a:latin typeface="Calibri" pitchFamily="34" charset="0"/>
                 <a:ea typeface="Calibri" pitchFamily="34" charset="-122"/>
                 <a:cs typeface="Calibri" pitchFamily="34" charset="-120"/>
               </a:rPr>
-              <a:t>0:00</a:t>
-            </a:r>
-            <a:endParaRPr lang="en-US" sz="1100" dirty="0"/>
-          </a:p>
-        </p:txBody>
-      </p:sp>
-      <p:sp>
-        <p:nvSpPr>
-          <p:cNvPr id="5" name="Text 3"/>
-          <p:cNvSpPr/>
-          <p:nvPr/>
-        </p:nvSpPr>
-        <p:spPr>
-          <a:xfrm>
-            <a:off x="1691640" y="1554480"/>
-            <a:ext cx="9646920" cy="448056"/>
-          </a:xfrm>
-          <a:prstGeom prst="rect">
-            <a:avLst/>
-          </a:prstGeom>
-          <a:noFill/>
-          <a:ln/>
-        </p:spPr>
-        <p:txBody>
-          <a:bodyPr wrap="square" rtlCol="0" anchor="ctr">
+              <a:t>about a third of the session each</a:t>
+            </a:r>
+            <a:endParaRPr lang="en-US" sz="1400" dirty="0"/>
+          </a:p>
+        </p:txBody>
+      </p:sp>
+      <p:sp>
+        <p:nvSpPr>
+          <p:cNvPr id="4" name="Shape 2"/>
+          <p:cNvSpPr/>
+          <p:nvPr/>
+        </p:nvSpPr>
+        <p:spPr>
+          <a:xfrm>
+            <a:off x="640080" y="2194560"/>
+            <a:ext cx="3383280" cy="3291840"/>
+          </a:xfrm>
+          <a:prstGeom prst="roundRect">
+            <a:avLst>
+              <a:gd name="adj" fmla="val 3333"/>
+            </a:avLst>
+          </a:prstGeom>
+          <a:solidFill>
+            <a:srgbClr val="F4EEE8"/>
+          </a:solidFill>
+          <a:ln/>
+        </p:spPr>
+      </p:sp>
+      <p:sp>
+        <p:nvSpPr>
+          <p:cNvPr id="5" name="Shape 3"/>
+          <p:cNvSpPr/>
+          <p:nvPr/>
+        </p:nvSpPr>
+        <p:spPr>
+          <a:xfrm>
+            <a:off x="1051560" y="2606040"/>
+            <a:ext cx="548640" cy="548640"/>
+          </a:xfrm>
+          <a:prstGeom prst="ellipse">
+            <a:avLst/>
+          </a:prstGeom>
+          <a:solidFill>
+            <a:srgbClr val="7A3B2E"/>
+          </a:solidFill>
+          <a:ln/>
+        </p:spPr>
+      </p:sp>
+      <p:sp>
+        <p:nvSpPr>
+          <p:cNvPr id="6" name="Text 4"/>
+          <p:cNvSpPr/>
+          <p:nvPr/>
+        </p:nvSpPr>
+        <p:spPr>
+          <a:xfrm>
+            <a:off x="1005840" y="3383280"/>
+            <a:ext cx="2651760" cy="548640"/>
+          </a:xfrm>
+          <a:prstGeom prst="rect">
+            <a:avLst/>
+          </a:prstGeom>
+          <a:noFill/>
+          <a:ln/>
+        </p:spPr>
+        <p:txBody>
+          <a:bodyPr wrap="square" rtlCol="0" anchor="ctr"/>
+          <a:lstStyle/>
+          <a:p>
+            <a:pPr indent="0" marL="0">
+              <a:buNone/>
+            </a:pPr>
+            <a:r>
+              <a:rPr lang="en-US" sz="2100" b="1" dirty="0">
+                <a:solidFill>
+                  <a:srgbClr val="1A1A1A"/>
+                </a:solidFill>
+                <a:latin typeface="Cambria" pitchFamily="34" charset="0"/>
+                <a:ea typeface="Cambria" pitchFamily="34" charset="-122"/>
+                <a:cs typeface="Cambria" pitchFamily="34" charset="-120"/>
+              </a:rPr>
+              <a:t>Lecture / demo</a:t>
+            </a:r>
+            <a:endParaRPr lang="en-US" sz="2100" dirty="0"/>
+          </a:p>
+        </p:txBody>
+      </p:sp>
+      <p:sp>
+        <p:nvSpPr>
+          <p:cNvPr id="7" name="Text 5"/>
+          <p:cNvSpPr/>
+          <p:nvPr/>
+        </p:nvSpPr>
+        <p:spPr>
+          <a:xfrm>
+            <a:off x="1005840" y="3977640"/>
+            <a:ext cx="2651760" cy="1371600"/>
+          </a:xfrm>
+          <a:prstGeom prst="rect">
+            <a:avLst/>
+          </a:prstGeom>
+          <a:noFill/>
+          <a:ln/>
+        </p:spPr>
+        <p:txBody>
+          <a:bodyPr wrap="square" rtlCol="0" anchor="t">
             <a:spAutoFit/>
           </a:bodyPr>
           <a:lstStyle/>
           <a:p>
             <a:pPr indent="0" marL="0">
-              <a:buNone/>
-            </a:pPr>
-            <a:r>
-              <a:rPr lang="en-US" sz="1100" dirty="0">
+              <a:lnSpc>
+                <a:spcPct val="115000"/>
+              </a:lnSpc>
+              <a:buNone/>
+            </a:pPr>
+            <a:r>
+              <a:rPr lang="en-US" sz="1500" dirty="0">
                 <a:solidFill>
                   <a:srgbClr val="1A1A1A"/>
                 </a:solidFill>
@@ -6534,44 +7743,64 @@
                 <a:ea typeface="Calibri" pitchFamily="34" charset="-122"/>
                 <a:cs typeface="Calibri" pitchFamily="34" charset="-120"/>
               </a:rPr>
-              <a:t>Warm-up retrieval.</a:t>
-            </a:r>
-            <a:endParaRPr lang="en-US" sz="1100" dirty="0"/>
-          </a:p>
-        </p:txBody>
-      </p:sp>
-      <p:sp>
-        <p:nvSpPr>
-          <p:cNvPr id="6" name="Shape 4"/>
-          <p:cNvSpPr/>
-          <p:nvPr/>
-        </p:nvSpPr>
-        <p:spPr>
-          <a:xfrm>
-            <a:off x="640080" y="2020824"/>
-            <a:ext cx="868680" cy="338328"/>
+              <a:t>Advanced counting: baselines, keyness, and the shuffle test</a:t>
+            </a:r>
+            <a:endParaRPr lang="en-US" sz="1500" dirty="0"/>
+          </a:p>
+        </p:txBody>
+      </p:sp>
+      <p:sp>
+        <p:nvSpPr>
+          <p:cNvPr id="8" name="Shape 6"/>
+          <p:cNvSpPr/>
+          <p:nvPr/>
+        </p:nvSpPr>
+        <p:spPr>
+          <a:xfrm>
+            <a:off x="4526280" y="2194560"/>
+            <a:ext cx="3383280" cy="3291840"/>
           </a:xfrm>
           <a:prstGeom prst="roundRect">
             <a:avLst>
-              <a:gd name="adj" fmla="val 16216"/>
+              <a:gd name="adj" fmla="val 3333"/>
             </a:avLst>
           </a:prstGeom>
           <a:solidFill>
-            <a:srgbClr val="7A3B2E"/>
-          </a:solidFill>
-          <a:ln/>
-        </p:spPr>
-      </p:sp>
-      <p:sp>
-        <p:nvSpPr>
-          <p:cNvPr id="7" name="Text 5"/>
-          <p:cNvSpPr/>
-          <p:nvPr/>
-        </p:nvSpPr>
-        <p:spPr>
-          <a:xfrm>
-            <a:off x="640080" y="2020824"/>
-            <a:ext cx="868680" cy="338328"/>
+            <a:srgbClr val="F4EEE8"/>
+          </a:solidFill>
+          <a:ln/>
+        </p:spPr>
+      </p:sp>
+      <p:sp>
+        <p:nvSpPr>
+          <p:cNvPr id="9" name="Shape 7"/>
+          <p:cNvSpPr/>
+          <p:nvPr/>
+        </p:nvSpPr>
+        <p:spPr>
+          <a:xfrm>
+            <a:off x="4937760" y="2606040"/>
+            <a:ext cx="548640" cy="548640"/>
+          </a:xfrm>
+          <a:prstGeom prst="ellipse">
+            <a:avLst/>
+          </a:prstGeom>
+          <a:solidFill>
+            <a:srgbClr val="3F6F5F"/>
+          </a:solidFill>
+          <a:ln/>
+        </p:spPr>
+      </p:sp>
+      <p:sp>
+        <p:nvSpPr>
+          <p:cNvPr id="10" name="Text 8"/>
+          <p:cNvSpPr/>
+          <p:nvPr/>
+        </p:nvSpPr>
+        <p:spPr>
+          <a:xfrm>
+            <a:off x="4892040" y="3383280"/>
+            <a:ext cx="2651760" cy="548640"/>
           </a:xfrm>
           <a:prstGeom prst="rect">
             <a:avLst/>
@@ -6583,52 +7812,180 @@
           <a:bodyPr wrap="square" rtlCol="0" anchor="ctr"/>
           <a:lstStyle/>
           <a:p>
-            <a:pPr algn="ctr" indent="0" marL="0">
-              <a:buNone/>
-            </a:pPr>
-            <a:r>
-              <a:rPr lang="en-US" sz="1100" b="1" dirty="0">
-                <a:solidFill>
-                  <a:srgbClr val="FFFFFF"/>
+            <a:pPr indent="0" marL="0">
+              <a:buNone/>
+            </a:pPr>
+            <a:r>
+              <a:rPr lang="en-US" sz="2100" b="1" dirty="0">
+                <a:solidFill>
+                  <a:srgbClr val="1A1A1A"/>
+                </a:solidFill>
+                <a:latin typeface="Cambria" pitchFamily="34" charset="0"/>
+                <a:ea typeface="Cambria" pitchFamily="34" charset="-122"/>
+                <a:cs typeface="Cambria" pitchFamily="34" charset="-120"/>
+              </a:rPr>
+              <a:t>Workshop</a:t>
+            </a:r>
+            <a:endParaRPr lang="en-US" sz="2100" dirty="0"/>
+          </a:p>
+        </p:txBody>
+      </p:sp>
+      <p:sp>
+        <p:nvSpPr>
+          <p:cNvPr id="11" name="Text 9"/>
+          <p:cNvSpPr/>
+          <p:nvPr/>
+        </p:nvSpPr>
+        <p:spPr>
+          <a:xfrm>
+            <a:off x="4892040" y="3977640"/>
+            <a:ext cx="2651760" cy="1371600"/>
+          </a:xfrm>
+          <a:prstGeom prst="rect">
+            <a:avLst/>
+          </a:prstGeom>
+          <a:noFill/>
+          <a:ln/>
+        </p:spPr>
+        <p:txBody>
+          <a:bodyPr wrap="square" rtlCol="0" anchor="t">
+            <a:spAutoFit/>
+          </a:bodyPr>
+          <a:lstStyle/>
+          <a:p>
+            <a:pPr indent="0" marL="0">
+              <a:lnSpc>
+                <a:spcPct val="115000"/>
+              </a:lnSpc>
+              <a:buNone/>
+            </a:pPr>
+            <a:r>
+              <a:rPr lang="en-US" sz="1500" dirty="0">
+                <a:solidFill>
+                  <a:srgbClr val="1A1A1A"/>
                 </a:solidFill>
                 <a:latin typeface="Calibri" pitchFamily="34" charset="0"/>
                 <a:ea typeface="Calibri" pitchFamily="34" charset="-122"/>
                 <a:cs typeface="Calibri" pitchFamily="34" charset="-120"/>
               </a:rPr>
-              <a:t>0:05</a:t>
-            </a:r>
-            <a:endParaRPr lang="en-US" sz="1100" dirty="0"/>
-          </a:p>
-        </p:txBody>
-      </p:sp>
-      <p:sp>
-        <p:nvSpPr>
-          <p:cNvPr id="8" name="Text 6"/>
-          <p:cNvSpPr/>
-          <p:nvPr/>
-        </p:nvSpPr>
-        <p:spPr>
-          <a:xfrm>
-            <a:off x="1691640" y="2002536"/>
-            <a:ext cx="9646920" cy="448056"/>
-          </a:xfrm>
-          <a:prstGeom prst="rect">
-            <a:avLst/>
-          </a:prstGeom>
-          <a:noFill/>
-          <a:ln/>
-        </p:spPr>
-        <p:txBody>
-          <a:bodyPr wrap="square" rtlCol="0" anchor="ctr">
+              <a:t>Build hands-on on your own data.</a:t>
+            </a:r>
+            <a:endParaRPr lang="en-US" sz="1500" dirty="0"/>
+          </a:p>
+        </p:txBody>
+      </p:sp>
+      <p:sp>
+        <p:nvSpPr>
+          <p:cNvPr id="12" name="Shape 10"/>
+          <p:cNvSpPr/>
+          <p:nvPr/>
+        </p:nvSpPr>
+        <p:spPr>
+          <a:xfrm>
+            <a:off x="8412480" y="2194560"/>
+            <a:ext cx="3383280" cy="3291840"/>
+          </a:xfrm>
+          <a:prstGeom prst="roundRect">
+            <a:avLst>
+              <a:gd name="adj" fmla="val 3333"/>
+            </a:avLst>
+          </a:prstGeom>
+          <a:solidFill>
+            <a:srgbClr val="F4EEE8"/>
+          </a:solidFill>
+          <a:ln/>
+        </p:spPr>
+      </p:sp>
+      <p:sp>
+        <p:nvSpPr>
+          <p:cNvPr id="13" name="Shape 11"/>
+          <p:cNvSpPr/>
+          <p:nvPr/>
+        </p:nvSpPr>
+        <p:spPr>
+          <a:xfrm>
+            <a:off x="8823960" y="2606040"/>
+            <a:ext cx="548640" cy="548640"/>
+          </a:xfrm>
+          <a:prstGeom prst="ellipse">
+            <a:avLst/>
+          </a:prstGeom>
+          <a:solidFill>
+            <a:srgbClr val="B9852F"/>
+          </a:solidFill>
+          <a:ln/>
+        </p:spPr>
+      </p:sp>
+      <p:sp>
+        <p:nvSpPr>
+          <p:cNvPr id="14" name="Text 12"/>
+          <p:cNvSpPr/>
+          <p:nvPr/>
+        </p:nvSpPr>
+        <p:spPr>
+          <a:xfrm>
+            <a:off x="8778240" y="3383280"/>
+            <a:ext cx="2651760" cy="548640"/>
+          </a:xfrm>
+          <a:prstGeom prst="rect">
+            <a:avLst/>
+          </a:prstGeom>
+          <a:noFill/>
+          <a:ln/>
+        </p:spPr>
+        <p:txBody>
+          <a:bodyPr wrap="square" rtlCol="0" anchor="ctr"/>
+          <a:lstStyle/>
+          <a:p>
+            <a:pPr indent="0" marL="0">
+              <a:buNone/>
+            </a:pPr>
+            <a:r>
+              <a:rPr lang="en-US" sz="2100" b="1" dirty="0">
+                <a:solidFill>
+                  <a:srgbClr val="1A1A1A"/>
+                </a:solidFill>
+                <a:latin typeface="Cambria" pitchFamily="34" charset="0"/>
+                <a:ea typeface="Cambria" pitchFamily="34" charset="-122"/>
+                <a:cs typeface="Cambria" pitchFamily="34" charset="-120"/>
+              </a:rPr>
+              <a:t>Discussion</a:t>
+            </a:r>
+            <a:endParaRPr lang="en-US" sz="2100" dirty="0"/>
+          </a:p>
+        </p:txBody>
+      </p:sp>
+      <p:sp>
+        <p:nvSpPr>
+          <p:cNvPr id="15" name="Text 13"/>
+          <p:cNvSpPr/>
+          <p:nvPr/>
+        </p:nvSpPr>
+        <p:spPr>
+          <a:xfrm>
+            <a:off x="8778240" y="3977640"/>
+            <a:ext cx="2651760" cy="1371600"/>
+          </a:xfrm>
+          <a:prstGeom prst="rect">
+            <a:avLst/>
+          </a:prstGeom>
+          <a:noFill/>
+          <a:ln/>
+        </p:spPr>
+        <p:txBody>
+          <a:bodyPr wrap="square" rtlCol="0" anchor="t">
             <a:spAutoFit/>
           </a:bodyPr>
           <a:lstStyle/>
           <a:p>
             <a:pPr indent="0" marL="0">
-              <a:buNone/>
-            </a:pPr>
-            <a:r>
-              <a:rPr lang="en-US" sz="1100" dirty="0">
+              <a:lnSpc>
+                <a:spcPct val="115000"/>
+              </a:lnSpc>
+              <a:buNone/>
+            </a:pPr>
+            <a:r>
+              <a:rPr lang="en-US" sz="1500" dirty="0">
                 <a:solidFill>
                   <a:srgbClr val="1A1A1A"/>
                 </a:solidFill>
@@ -6636,825 +7993,9 @@
                 <a:ea typeface="Calibri" pitchFamily="34" charset="-122"/>
                 <a:cs typeface="Calibri" pitchFamily="34" charset="-120"/>
               </a:rPr>
-              <a:t>The trial: claim, objection, re-run-without-fiction rebuttal, "interpret with care." One named choice is the chart: the hockey-stick shape depends on its y-axis and smoothing.</a:t>
-            </a:r>
-            <a:endParaRPr lang="en-US" sz="1100" dirty="0"/>
-          </a:p>
-        </p:txBody>
-      </p:sp>
-      <p:sp>
-        <p:nvSpPr>
-          <p:cNvPr id="9" name="Shape 7"/>
-          <p:cNvSpPr/>
-          <p:nvPr/>
-        </p:nvSpPr>
-        <p:spPr>
-          <a:xfrm>
-            <a:off x="640080" y="2468880"/>
-            <a:ext cx="868680" cy="338328"/>
-          </a:xfrm>
-          <a:prstGeom prst="roundRect">
-            <a:avLst>
-              <a:gd name="adj" fmla="val 16216"/>
-            </a:avLst>
-          </a:prstGeom>
-          <a:solidFill>
-            <a:srgbClr val="7A3B2E"/>
-          </a:solidFill>
-          <a:ln/>
-        </p:spPr>
-      </p:sp>
-      <p:sp>
-        <p:nvSpPr>
-          <p:cNvPr id="10" name="Text 8"/>
-          <p:cNvSpPr/>
-          <p:nvPr/>
-        </p:nvSpPr>
-        <p:spPr>
-          <a:xfrm>
-            <a:off x="640080" y="2468880"/>
-            <a:ext cx="868680" cy="338328"/>
-          </a:xfrm>
-          <a:prstGeom prst="rect">
-            <a:avLst/>
-          </a:prstGeom>
-          <a:noFill/>
-          <a:ln/>
-        </p:spPr>
-        <p:txBody>
-          <a:bodyPr wrap="square" rtlCol="0" anchor="ctr"/>
-          <a:lstStyle/>
-          <a:p>
-            <a:pPr algn="ctr" indent="0" marL="0">
-              <a:buNone/>
-            </a:pPr>
-            <a:r>
-              <a:rPr lang="en-US" sz="1100" b="1" dirty="0">
-                <a:solidFill>
-                  <a:srgbClr val="FFFFFF"/>
-                </a:solidFill>
-                <a:latin typeface="Calibri" pitchFamily="34" charset="0"/>
-                <a:ea typeface="Calibri" pitchFamily="34" charset="-122"/>
-                <a:cs typeface="Calibri" pitchFamily="34" charset="-120"/>
-              </a:rPr>
-              <a:t>0:25</a:t>
-            </a:r>
-            <a:endParaRPr lang="en-US" sz="1100" dirty="0"/>
-          </a:p>
-        </p:txBody>
-      </p:sp>
-      <p:sp>
-        <p:nvSpPr>
-          <p:cNvPr id="11" name="Text 9"/>
-          <p:cNvSpPr/>
-          <p:nvPr/>
-        </p:nvSpPr>
-        <p:spPr>
-          <a:xfrm>
-            <a:off x="1691640" y="2450592"/>
-            <a:ext cx="9646920" cy="448056"/>
-          </a:xfrm>
-          <a:prstGeom prst="rect">
-            <a:avLst/>
-          </a:prstGeom>
-          <a:noFill/>
-          <a:ln/>
-        </p:spPr>
-        <p:txBody>
-          <a:bodyPr wrap="square" rtlCol="0" anchor="ctr">
-            <a:spAutoFit/>
-          </a:bodyPr>
-          <a:lstStyle/>
-          <a:p>
-            <a:pPr indent="0" marL="0">
-              <a:buNone/>
-            </a:pPr>
-            <a:r>
-              <a:rPr lang="en-US" sz="1100" dirty="0">
-                <a:solidFill>
-                  <a:srgbClr val="1A1A1A"/>
-                </a:solidFill>
-                <a:latin typeface="Calibri" pitchFamily="34" charset="0"/>
-                <a:ea typeface="Calibri" pitchFamily="34" charset="-122"/>
-                <a:cs typeface="Calibri" pitchFamily="34" charset="-120"/>
-              </a:rPr>
-              <a:t>A brief demonstration before the complications: the words one artist uses far more than everyone else, a signature vocabulary measured against a pop baseline.</a:t>
-            </a:r>
-            <a:endParaRPr lang="en-US" sz="1100" dirty="0"/>
-          </a:p>
-        </p:txBody>
-      </p:sp>
-      <p:sp>
-        <p:nvSpPr>
-          <p:cNvPr id="12" name="Shape 10"/>
-          <p:cNvSpPr/>
-          <p:nvPr/>
-        </p:nvSpPr>
-        <p:spPr>
-          <a:xfrm>
-            <a:off x="640080" y="2916936"/>
-            <a:ext cx="868680" cy="338328"/>
-          </a:xfrm>
-          <a:prstGeom prst="roundRect">
-            <a:avLst>
-              <a:gd name="adj" fmla="val 16216"/>
-            </a:avLst>
-          </a:prstGeom>
-          <a:solidFill>
-            <a:srgbClr val="7A3B2E"/>
-          </a:solidFill>
-          <a:ln/>
-        </p:spPr>
-      </p:sp>
-      <p:sp>
-        <p:nvSpPr>
-          <p:cNvPr id="13" name="Text 11"/>
-          <p:cNvSpPr/>
-          <p:nvPr/>
-        </p:nvSpPr>
-        <p:spPr>
-          <a:xfrm>
-            <a:off x="640080" y="2916936"/>
-            <a:ext cx="868680" cy="338328"/>
-          </a:xfrm>
-          <a:prstGeom prst="rect">
-            <a:avLst/>
-          </a:prstGeom>
-          <a:noFill/>
-          <a:ln/>
-        </p:spPr>
-        <p:txBody>
-          <a:bodyPr wrap="square" rtlCol="0" anchor="ctr"/>
-          <a:lstStyle/>
-          <a:p>
-            <a:pPr algn="ctr" indent="0" marL="0">
-              <a:buNone/>
-            </a:pPr>
-            <a:r>
-              <a:rPr lang="en-US" sz="1100" b="1" dirty="0">
-                <a:solidFill>
-                  <a:srgbClr val="FFFFFF"/>
-                </a:solidFill>
-                <a:latin typeface="Calibri" pitchFamily="34" charset="0"/>
-                <a:ea typeface="Calibri" pitchFamily="34" charset="-122"/>
-                <a:cs typeface="Calibri" pitchFamily="34" charset="-120"/>
-              </a:rPr>
-              <a:t>0:30</a:t>
-            </a:r>
-            <a:endParaRPr lang="en-US" sz="1100" dirty="0"/>
-          </a:p>
-        </p:txBody>
-      </p:sp>
-      <p:sp>
-        <p:nvSpPr>
-          <p:cNvPr id="14" name="Text 12"/>
-          <p:cNvSpPr/>
-          <p:nvPr/>
-        </p:nvSpPr>
-        <p:spPr>
-          <a:xfrm>
-            <a:off x="1691640" y="2898648"/>
-            <a:ext cx="9646920" cy="448056"/>
-          </a:xfrm>
-          <a:prstGeom prst="rect">
-            <a:avLst/>
-          </a:prstGeom>
-          <a:noFill/>
-          <a:ln/>
-        </p:spPr>
-        <p:txBody>
-          <a:bodyPr wrap="square" rtlCol="0" anchor="ctr">
-            <a:spAutoFit/>
-          </a:bodyPr>
-          <a:lstStyle/>
-          <a:p>
-            <a:pPr indent="0" marL="0">
-              <a:buNone/>
-            </a:pPr>
-            <a:r>
-              <a:rPr lang="en-US" sz="1100" dirty="0">
-                <a:solidFill>
-                  <a:srgbClr val="1A1A1A"/>
-                </a:solidFill>
-                <a:latin typeface="Calibri" pitchFamily="34" charset="0"/>
-                <a:ea typeface="Calibri" pitchFamily="34" charset="-122"/>
-                <a:cs typeface="Calibri" pitchFamily="34" charset="-120"/>
-              </a:rPr>
-              <a:t>Hand-built bag-of-words: two authors, highlighters, argue about merging run/running. Counting requires defining.</a:t>
-            </a:r>
-            <a:endParaRPr lang="en-US" sz="1100" dirty="0"/>
-          </a:p>
-        </p:txBody>
-      </p:sp>
-      <p:sp>
-        <p:nvSpPr>
-          <p:cNvPr id="15" name="Shape 13"/>
-          <p:cNvSpPr/>
-          <p:nvPr/>
-        </p:nvSpPr>
-        <p:spPr>
-          <a:xfrm>
-            <a:off x="640080" y="3364992"/>
-            <a:ext cx="868680" cy="338328"/>
-          </a:xfrm>
-          <a:prstGeom prst="roundRect">
-            <a:avLst>
-              <a:gd name="adj" fmla="val 16216"/>
-            </a:avLst>
-          </a:prstGeom>
-          <a:solidFill>
-            <a:srgbClr val="7A3B2E"/>
-          </a:solidFill>
-          <a:ln/>
-        </p:spPr>
-      </p:sp>
-      <p:sp>
-        <p:nvSpPr>
-          <p:cNvPr id="16" name="Text 14"/>
-          <p:cNvSpPr/>
-          <p:nvPr/>
-        </p:nvSpPr>
-        <p:spPr>
-          <a:xfrm>
-            <a:off x="640080" y="3364992"/>
-            <a:ext cx="868680" cy="338328"/>
-          </a:xfrm>
-          <a:prstGeom prst="rect">
-            <a:avLst/>
-          </a:prstGeom>
-          <a:noFill/>
-          <a:ln/>
-        </p:spPr>
-        <p:txBody>
-          <a:bodyPr wrap="square" rtlCol="0" anchor="ctr"/>
-          <a:lstStyle/>
-          <a:p>
-            <a:pPr algn="ctr" indent="0" marL="0">
-              <a:buNone/>
-            </a:pPr>
-            <a:r>
-              <a:rPr lang="en-US" sz="1100" b="1" dirty="0">
-                <a:solidFill>
-                  <a:srgbClr val="FFFFFF"/>
-                </a:solidFill>
-                <a:latin typeface="Calibri" pitchFamily="34" charset="0"/>
-                <a:ea typeface="Calibri" pitchFamily="34" charset="-122"/>
-                <a:cs typeface="Calibri" pitchFamily="34" charset="-120"/>
-              </a:rPr>
-              <a:t>0:55</a:t>
-            </a:r>
-            <a:endParaRPr lang="en-US" sz="1100" dirty="0"/>
-          </a:p>
-        </p:txBody>
-      </p:sp>
-      <p:sp>
-        <p:nvSpPr>
-          <p:cNvPr id="17" name="Text 15"/>
-          <p:cNvSpPr/>
-          <p:nvPr/>
-        </p:nvSpPr>
-        <p:spPr>
-          <a:xfrm>
-            <a:off x="1691640" y="3346704"/>
-            <a:ext cx="9646920" cy="448056"/>
-          </a:xfrm>
-          <a:prstGeom prst="rect">
-            <a:avLst/>
-          </a:prstGeom>
-          <a:noFill/>
-          <a:ln/>
-        </p:spPr>
-        <p:txBody>
-          <a:bodyPr wrap="square" rtlCol="0" anchor="ctr">
-            <a:spAutoFit/>
-          </a:bodyPr>
-          <a:lstStyle/>
-          <a:p>
-            <a:pPr indent="0" marL="0">
-              <a:buNone/>
-            </a:pPr>
-            <a:r>
-              <a:rPr lang="en-US" sz="1100" dirty="0">
-                <a:solidFill>
-                  <a:srgbClr val="1A1A1A"/>
-                </a:solidFill>
-                <a:latin typeface="Calibri" pitchFamily="34" charset="0"/>
-                <a:ea typeface="Calibri" pitchFamily="34" charset="-122"/>
-                <a:cs typeface="Calibri" pitchFamily="34" charset="-120"/>
-              </a:rPr>
-              <a:t>What counts as a word? Paste a sentence into two tokenizer playgrounds and watch it shatter differently. Models see tokens, not words.</a:t>
-            </a:r>
-            <a:endParaRPr lang="en-US" sz="1100" dirty="0"/>
-          </a:p>
-        </p:txBody>
-      </p:sp>
-      <p:sp>
-        <p:nvSpPr>
-          <p:cNvPr id="18" name="Shape 16"/>
-          <p:cNvSpPr/>
-          <p:nvPr/>
-        </p:nvSpPr>
-        <p:spPr>
-          <a:xfrm>
-            <a:off x="640080" y="3813048"/>
-            <a:ext cx="868680" cy="338328"/>
-          </a:xfrm>
-          <a:prstGeom prst="roundRect">
-            <a:avLst>
-              <a:gd name="adj" fmla="val 16216"/>
-            </a:avLst>
-          </a:prstGeom>
-          <a:solidFill>
-            <a:srgbClr val="7A3B2E"/>
-          </a:solidFill>
-          <a:ln/>
-        </p:spPr>
-      </p:sp>
-      <p:sp>
-        <p:nvSpPr>
-          <p:cNvPr id="19" name="Text 17"/>
-          <p:cNvSpPr/>
-          <p:nvPr/>
-        </p:nvSpPr>
-        <p:spPr>
-          <a:xfrm>
-            <a:off x="640080" y="3813048"/>
-            <a:ext cx="868680" cy="338328"/>
-          </a:xfrm>
-          <a:prstGeom prst="rect">
-            <a:avLst/>
-          </a:prstGeom>
-          <a:noFill/>
-          <a:ln/>
-        </p:spPr>
-        <p:txBody>
-          <a:bodyPr wrap="square" rtlCol="0" anchor="ctr"/>
-          <a:lstStyle/>
-          <a:p>
-            <a:pPr algn="ctr" indent="0" marL="0">
-              <a:buNone/>
-            </a:pPr>
-            <a:r>
-              <a:rPr lang="en-US" sz="1100" b="1" dirty="0">
-                <a:solidFill>
-                  <a:srgbClr val="FFFFFF"/>
-                </a:solidFill>
-                <a:latin typeface="Calibri" pitchFamily="34" charset="0"/>
-                <a:ea typeface="Calibri" pitchFamily="34" charset="-122"/>
-                <a:cs typeface="Calibri" pitchFamily="34" charset="-120"/>
-              </a:rPr>
-              <a:t>1:05</a:t>
-            </a:r>
-            <a:endParaRPr lang="en-US" sz="1100" dirty="0"/>
-          </a:p>
-        </p:txBody>
-      </p:sp>
-      <p:sp>
-        <p:nvSpPr>
-          <p:cNvPr id="20" name="Text 18"/>
-          <p:cNvSpPr/>
-          <p:nvPr/>
-        </p:nvSpPr>
-        <p:spPr>
-          <a:xfrm>
-            <a:off x="1691640" y="3794760"/>
-            <a:ext cx="9646920" cy="448056"/>
-          </a:xfrm>
-          <a:prstGeom prst="rect">
-            <a:avLst/>
-          </a:prstGeom>
-          <a:noFill/>
-          <a:ln/>
-        </p:spPr>
-        <p:txBody>
-          <a:bodyPr wrap="square" rtlCol="0" anchor="ctr">
-            <a:spAutoFit/>
-          </a:bodyPr>
-          <a:lstStyle/>
-          <a:p>
-            <a:pPr indent="0" marL="0">
-              <a:buNone/>
-            </a:pPr>
-            <a:r>
-              <a:rPr lang="en-US" sz="1100" dirty="0">
-                <a:solidFill>
-                  <a:srgbClr val="1A1A1A"/>
-                </a:solidFill>
-                <a:latin typeface="Calibri" pitchFamily="34" charset="0"/>
-                <a:ea typeface="Calibri" pitchFamily="34" charset="-122"/>
-                <a:cs typeface="Calibri" pitchFamily="34" charset="-120"/>
-              </a:rPr>
-              <a:t>Break</a:t>
-            </a:r>
-            <a:endParaRPr lang="en-US" sz="1100" dirty="0"/>
-          </a:p>
-        </p:txBody>
-      </p:sp>
-      <p:sp>
-        <p:nvSpPr>
-          <p:cNvPr id="21" name="Shape 19"/>
-          <p:cNvSpPr/>
-          <p:nvPr/>
-        </p:nvSpPr>
-        <p:spPr>
-          <a:xfrm>
-            <a:off x="640080" y="4261104"/>
-            <a:ext cx="868680" cy="338328"/>
-          </a:xfrm>
-          <a:prstGeom prst="roundRect">
-            <a:avLst>
-              <a:gd name="adj" fmla="val 16216"/>
-            </a:avLst>
-          </a:prstGeom>
-          <a:solidFill>
-            <a:srgbClr val="7A3B2E"/>
-          </a:solidFill>
-          <a:ln/>
-        </p:spPr>
-      </p:sp>
-      <p:sp>
-        <p:nvSpPr>
-          <p:cNvPr id="22" name="Text 20"/>
-          <p:cNvSpPr/>
-          <p:nvPr/>
-        </p:nvSpPr>
-        <p:spPr>
-          <a:xfrm>
-            <a:off x="640080" y="4261104"/>
-            <a:ext cx="868680" cy="338328"/>
-          </a:xfrm>
-          <a:prstGeom prst="rect">
-            <a:avLst/>
-          </a:prstGeom>
-          <a:noFill/>
-          <a:ln/>
-        </p:spPr>
-        <p:txBody>
-          <a:bodyPr wrap="square" rtlCol="0" anchor="ctr"/>
-          <a:lstStyle/>
-          <a:p>
-            <a:pPr algn="ctr" indent="0" marL="0">
-              <a:buNone/>
-            </a:pPr>
-            <a:r>
-              <a:rPr lang="en-US" sz="1100" b="1" dirty="0">
-                <a:solidFill>
-                  <a:srgbClr val="FFFFFF"/>
-                </a:solidFill>
-                <a:latin typeface="Calibri" pitchFamily="34" charset="0"/>
-                <a:ea typeface="Calibri" pitchFamily="34" charset="-122"/>
-                <a:cs typeface="Calibri" pitchFamily="34" charset="-120"/>
-              </a:rPr>
-              <a:t>1:15</a:t>
-            </a:r>
-            <a:endParaRPr lang="en-US" sz="1100" dirty="0"/>
-          </a:p>
-        </p:txBody>
-      </p:sp>
-      <p:sp>
-        <p:nvSpPr>
-          <p:cNvPr id="23" name="Text 21"/>
-          <p:cNvSpPr/>
-          <p:nvPr/>
-        </p:nvSpPr>
-        <p:spPr>
-          <a:xfrm>
-            <a:off x="1691640" y="4242816"/>
-            <a:ext cx="9646920" cy="448056"/>
-          </a:xfrm>
-          <a:prstGeom prst="rect">
-            <a:avLst/>
-          </a:prstGeom>
-          <a:noFill/>
-          <a:ln/>
-        </p:spPr>
-        <p:txBody>
-          <a:bodyPr wrap="square" rtlCol="0" anchor="ctr">
-            <a:spAutoFit/>
-          </a:bodyPr>
-          <a:lstStyle/>
-          <a:p>
-            <a:pPr indent="0" marL="0">
-              <a:buNone/>
-            </a:pPr>
-            <a:r>
-              <a:rPr lang="en-US" sz="1100" dirty="0">
-                <a:solidFill>
-                  <a:srgbClr val="1A1A1A"/>
-                </a:solidFill>
-                <a:latin typeface="Calibri" pitchFamily="34" charset="0"/>
-                <a:ea typeface="Calibri" pitchFamily="34" charset="-122"/>
-                <a:cs typeface="Calibri" pitchFamily="34" charset="-120"/>
-              </a:rPr>
-              <a:t>tf-idf: the AI scales your hand count; stop-words dominate, which motivates "common here, rare overall."</a:t>
-            </a:r>
-            <a:endParaRPr lang="en-US" sz="1100" dirty="0"/>
-          </a:p>
-        </p:txBody>
-      </p:sp>
-      <p:sp>
-        <p:nvSpPr>
-          <p:cNvPr id="24" name="Shape 22"/>
-          <p:cNvSpPr/>
-          <p:nvPr/>
-        </p:nvSpPr>
-        <p:spPr>
-          <a:xfrm>
-            <a:off x="640080" y="4709160"/>
-            <a:ext cx="868680" cy="338328"/>
-          </a:xfrm>
-          <a:prstGeom prst="roundRect">
-            <a:avLst>
-              <a:gd name="adj" fmla="val 16216"/>
-            </a:avLst>
-          </a:prstGeom>
-          <a:solidFill>
-            <a:srgbClr val="7A3B2E"/>
-          </a:solidFill>
-          <a:ln/>
-        </p:spPr>
-      </p:sp>
-      <p:sp>
-        <p:nvSpPr>
-          <p:cNvPr id="25" name="Text 23"/>
-          <p:cNvSpPr/>
-          <p:nvPr/>
-        </p:nvSpPr>
-        <p:spPr>
-          <a:xfrm>
-            <a:off x="640080" y="4709160"/>
-            <a:ext cx="868680" cy="338328"/>
-          </a:xfrm>
-          <a:prstGeom prst="rect">
-            <a:avLst/>
-          </a:prstGeom>
-          <a:noFill/>
-          <a:ln/>
-        </p:spPr>
-        <p:txBody>
-          <a:bodyPr wrap="square" rtlCol="0" anchor="ctr"/>
-          <a:lstStyle/>
-          <a:p>
-            <a:pPr algn="ctr" indent="0" marL="0">
-              <a:buNone/>
-            </a:pPr>
-            <a:r>
-              <a:rPr lang="en-US" sz="1100" b="1" dirty="0">
-                <a:solidFill>
-                  <a:srgbClr val="FFFFFF"/>
-                </a:solidFill>
-                <a:latin typeface="Calibri" pitchFamily="34" charset="0"/>
-                <a:ea typeface="Calibri" pitchFamily="34" charset="-122"/>
-                <a:cs typeface="Calibri" pitchFamily="34" charset="-120"/>
-              </a:rPr>
-              <a:t>1:30</a:t>
-            </a:r>
-            <a:endParaRPr lang="en-US" sz="1100" dirty="0"/>
-          </a:p>
-        </p:txBody>
-      </p:sp>
-      <p:sp>
-        <p:nvSpPr>
-          <p:cNvPr id="26" name="Text 24"/>
-          <p:cNvSpPr/>
-          <p:nvPr/>
-        </p:nvSpPr>
-        <p:spPr>
-          <a:xfrm>
-            <a:off x="1691640" y="4690872"/>
-            <a:ext cx="9646920" cy="448056"/>
-          </a:xfrm>
-          <a:prstGeom prst="rect">
-            <a:avLst/>
-          </a:prstGeom>
-          <a:noFill/>
-          <a:ln/>
-        </p:spPr>
-        <p:txBody>
-          <a:bodyPr wrap="square" rtlCol="0" anchor="ctr">
-            <a:spAutoFit/>
-          </a:bodyPr>
-          <a:lstStyle/>
-          <a:p>
-            <a:pPr indent="0" marL="0">
-              <a:buNone/>
-            </a:pPr>
-            <a:r>
-              <a:rPr lang="en-US" sz="1100" dirty="0">
-                <a:solidFill>
-                  <a:srgbClr val="1A1A1A"/>
-                </a:solidFill>
-                <a:latin typeface="Calibri" pitchFamily="34" charset="0"/>
-                <a:ea typeface="Calibri" pitchFamily="34" charset="-122"/>
-                <a:cs typeface="Calibri" pitchFamily="34" charset="-120"/>
-              </a:rPr>
-              <a:t>Keyness, the She Giggles, He Gallops move: a log-odds ratio between two corpora finds the words one voice uses far more than a baseline, exactly the method behind Week 1's featured piece. The corpus pair is a choice too: artist vs. pop, lyrics vs. subreddit vs. novel.</a:t>
-            </a:r>
-            <a:endParaRPr lang="en-US" sz="1100" dirty="0"/>
-          </a:p>
-        </p:txBody>
-      </p:sp>
-      <p:sp>
-        <p:nvSpPr>
-          <p:cNvPr id="27" name="Shape 25"/>
-          <p:cNvSpPr/>
-          <p:nvPr/>
-        </p:nvSpPr>
-        <p:spPr>
-          <a:xfrm>
-            <a:off x="640080" y="5157216"/>
-            <a:ext cx="868680" cy="338328"/>
-          </a:xfrm>
-          <a:prstGeom prst="roundRect">
-            <a:avLst>
-              <a:gd name="adj" fmla="val 16216"/>
-            </a:avLst>
-          </a:prstGeom>
-          <a:solidFill>
-            <a:srgbClr val="7A3B2E"/>
-          </a:solidFill>
-          <a:ln/>
-        </p:spPr>
-      </p:sp>
-      <p:sp>
-        <p:nvSpPr>
-          <p:cNvPr id="28" name="Text 26"/>
-          <p:cNvSpPr/>
-          <p:nvPr/>
-        </p:nvSpPr>
-        <p:spPr>
-          <a:xfrm>
-            <a:off x="640080" y="5157216"/>
-            <a:ext cx="868680" cy="338328"/>
-          </a:xfrm>
-          <a:prstGeom prst="rect">
-            <a:avLst/>
-          </a:prstGeom>
-          <a:noFill/>
-          <a:ln/>
-        </p:spPr>
-        <p:txBody>
-          <a:bodyPr wrap="square" rtlCol="0" anchor="ctr"/>
-          <a:lstStyle/>
-          <a:p>
-            <a:pPr algn="ctr" indent="0" marL="0">
-              <a:buNone/>
-            </a:pPr>
-            <a:r>
-              <a:rPr lang="en-US" sz="1100" b="1" dirty="0">
-                <a:solidFill>
-                  <a:srgbClr val="FFFFFF"/>
-                </a:solidFill>
-                <a:latin typeface="Calibri" pitchFamily="34" charset="0"/>
-                <a:ea typeface="Calibri" pitchFamily="34" charset="-122"/>
-                <a:cs typeface="Calibri" pitchFamily="34" charset="-120"/>
-              </a:rPr>
-              <a:t>1:42</a:t>
-            </a:r>
-            <a:endParaRPr lang="en-US" sz="1100" dirty="0"/>
-          </a:p>
-        </p:txBody>
-      </p:sp>
-      <p:sp>
-        <p:nvSpPr>
-          <p:cNvPr id="29" name="Text 27"/>
-          <p:cNvSpPr/>
-          <p:nvPr/>
-        </p:nvSpPr>
-        <p:spPr>
-          <a:xfrm>
-            <a:off x="1691640" y="5138928"/>
-            <a:ext cx="9646920" cy="448056"/>
-          </a:xfrm>
-          <a:prstGeom prst="rect">
-            <a:avLst/>
-          </a:prstGeom>
-          <a:noFill/>
-          <a:ln/>
-        </p:spPr>
-        <p:txBody>
-          <a:bodyPr wrap="square" rtlCol="0" anchor="ctr">
-            <a:spAutoFit/>
-          </a:bodyPr>
-          <a:lstStyle/>
-          <a:p>
-            <a:pPr indent="0" marL="0">
-              <a:buNone/>
-            </a:pPr>
-            <a:r>
-              <a:rPr lang="en-US" sz="1100" dirty="0">
-                <a:solidFill>
-                  <a:srgbClr val="1A1A1A"/>
-                </a:solidFill>
-                <a:latin typeface="Calibri" pitchFamily="34" charset="0"/>
-                <a:ea typeface="Calibri" pitchFamily="34" charset="-122"/>
-                <a:cs typeface="Calibri" pitchFamily="34" charset="-120"/>
-              </a:rPr>
-              <a:t>Is the difference real? The shuffle test: shuffle the labels and recount, one thousand times. If chance alone frequently produces a gap this large, the difference should not be trusted; if it almost never does, the finding stands. A difference can be real and still small.</a:t>
-            </a:r>
-            <a:endParaRPr lang="en-US" sz="1100" dirty="0"/>
-          </a:p>
-        </p:txBody>
-      </p:sp>
-      <p:sp>
-        <p:nvSpPr>
-          <p:cNvPr id="30" name="Shape 28"/>
-          <p:cNvSpPr/>
-          <p:nvPr/>
-        </p:nvSpPr>
-        <p:spPr>
-          <a:xfrm>
-            <a:off x="640080" y="5605272"/>
-            <a:ext cx="868680" cy="338328"/>
-          </a:xfrm>
-          <a:prstGeom prst="roundRect">
-            <a:avLst>
-              <a:gd name="adj" fmla="val 16216"/>
-            </a:avLst>
-          </a:prstGeom>
-          <a:solidFill>
-            <a:srgbClr val="7A3B2E"/>
-          </a:solidFill>
-          <a:ln/>
-        </p:spPr>
-      </p:sp>
-      <p:sp>
-        <p:nvSpPr>
-          <p:cNvPr id="31" name="Text 29"/>
-          <p:cNvSpPr/>
-          <p:nvPr/>
-        </p:nvSpPr>
-        <p:spPr>
-          <a:xfrm>
-            <a:off x="640080" y="5605272"/>
-            <a:ext cx="868680" cy="338328"/>
-          </a:xfrm>
-          <a:prstGeom prst="rect">
-            <a:avLst/>
-          </a:prstGeom>
-          <a:noFill/>
-          <a:ln/>
-        </p:spPr>
-        <p:txBody>
-          <a:bodyPr wrap="square" rtlCol="0" anchor="ctr"/>
-          <a:lstStyle/>
-          <a:p>
-            <a:pPr algn="ctr" indent="0" marL="0">
-              <a:buNone/>
-            </a:pPr>
-            <a:r>
-              <a:rPr lang="en-US" sz="1100" b="1" dirty="0">
-                <a:solidFill>
-                  <a:srgbClr val="FFFFFF"/>
-                </a:solidFill>
-                <a:latin typeface="Calibri" pitchFamily="34" charset="0"/>
-                <a:ea typeface="Calibri" pitchFamily="34" charset="-122"/>
-                <a:cs typeface="Calibri" pitchFamily="34" charset="-120"/>
-              </a:rPr>
-              <a:t>1:50</a:t>
-            </a:r>
-            <a:endParaRPr lang="en-US" sz="1100" dirty="0"/>
-          </a:p>
-        </p:txBody>
-      </p:sp>
-      <p:sp>
-        <p:nvSpPr>
-          <p:cNvPr id="32" name="Text 30"/>
-          <p:cNvSpPr/>
-          <p:nvPr/>
-        </p:nvSpPr>
-        <p:spPr>
-          <a:xfrm>
-            <a:off x="1691640" y="5586984"/>
-            <a:ext cx="9646920" cy="448056"/>
-          </a:xfrm>
-          <a:prstGeom prst="rect">
-            <a:avLst/>
-          </a:prstGeom>
-          <a:noFill/>
-          <a:ln/>
-        </p:spPr>
-        <p:txBody>
-          <a:bodyPr wrap="square" rtlCol="0" anchor="ctr">
-            <a:spAutoFit/>
-          </a:bodyPr>
-          <a:lstStyle/>
-          <a:p>
-            <a:pPr indent="0" marL="0">
-              <a:buNone/>
-            </a:pPr>
-            <a:r>
-              <a:rPr lang="en-US" sz="1100" dirty="0">
-                <a:solidFill>
-                  <a:srgbClr val="1A1A1A"/>
-                </a:solidFill>
-                <a:latin typeface="Calibri" pitchFamily="34" charset="0"/>
-                <a:ea typeface="Calibri" pitchFamily="34" charset="-122"/>
-                <a:cs typeface="Calibri" pitchFamily="34" charset="-120"/>
-              </a:rPr>
-              <a:t>Gemini-free check and check-out.</a:t>
-            </a:r>
-            <a:endParaRPr lang="en-US" sz="1100" dirty="0"/>
+              <a:t>Interrogate the study, debate it, or critique each other's work.</a:t>
+            </a:r>
+            <a:endParaRPr lang="en-US" sz="1500" dirty="0"/>
           </a:p>
         </p:txBody>
       </p:sp>

</xml_diff>

<commit_message>
Week 2: NLTK stemming/lemmatization/stop list and Zipf's law; fix CRLF corruption in text snapshots (loader normalization + .gitattributes)
</commit_message>
<xml_diff>
--- a/slides/pptx/week-02.pptx
+++ b/slides/pptx/week-02.pptx
@@ -4879,7 +4879,7 @@
         <p:spPr>
           <a:xfrm>
             <a:off x="1097280" y="2240280"/>
-            <a:ext cx="10607040" cy="1017270"/>
+            <a:ext cx="10607040" cy="813816"/>
           </a:xfrm>
           <a:prstGeom prst="rect">
             <a:avLst/>
@@ -4900,7 +4900,7 @@
               <a:buNone/>
             </a:pPr>
             <a:r>
-              <a:rPr lang="en-US" sz="1650" dirty="0">
+              <a:rPr lang="en-US" sz="1500" dirty="0">
                 <a:solidFill>
                   <a:srgbClr val="1A1A1A"/>
                 </a:solidFill>
@@ -4910,7 +4910,7 @@
               </a:rPr>
               <a:t>Two tokenizers shatter the same sentence differently: "don't" becomes one chip, two, or three.</a:t>
             </a:r>
-            <a:endParaRPr lang="en-US" sz="1650" dirty="0"/>
+            <a:endParaRPr lang="en-US" sz="1500" dirty="0"/>
           </a:p>
         </p:txBody>
       </p:sp>
@@ -4922,7 +4922,7 @@
         </p:nvSpPr>
         <p:spPr>
           <a:xfrm>
-            <a:off x="640080" y="3348990"/>
+            <a:off x="640080" y="3145536"/>
             <a:ext cx="201168" cy="201168"/>
           </a:xfrm>
           <a:prstGeom prst="ellipse">
@@ -4942,8 +4942,8 @@
         </p:nvSpPr>
         <p:spPr>
           <a:xfrm>
-            <a:off x="1097280" y="3257550"/>
-            <a:ext cx="10607040" cy="1017270"/>
+            <a:off x="1097280" y="3054096"/>
+            <a:ext cx="10607040" cy="813816"/>
           </a:xfrm>
           <a:prstGeom prst="rect">
             <a:avLst/>
@@ -4964,7 +4964,7 @@
               <a:buNone/>
             </a:pPr>
             <a:r>
-              <a:rPr lang="en-US" sz="1650" dirty="0">
+              <a:rPr lang="en-US" sz="1500" dirty="0">
                 <a:solidFill>
                   <a:srgbClr val="1A1A1A"/>
                 </a:solidFill>
@@ -4974,7 +4974,7 @@
               </a:rPr>
               <a:t>Models never see words. They see tokens, and the split is a design decision.</a:t>
             </a:r>
-            <a:endParaRPr lang="en-US" sz="1650" dirty="0"/>
+            <a:endParaRPr lang="en-US" sz="1500" dirty="0"/>
           </a:p>
         </p:txBody>
       </p:sp>
@@ -4986,7 +4986,7 @@
         </p:nvSpPr>
         <p:spPr>
           <a:xfrm>
-            <a:off x="640080" y="4366260"/>
+            <a:off x="640080" y="3959352"/>
             <a:ext cx="201168" cy="201168"/>
           </a:xfrm>
           <a:prstGeom prst="ellipse">
@@ -5006,8 +5006,8 @@
         </p:nvSpPr>
         <p:spPr>
           <a:xfrm>
-            <a:off x="1097280" y="4274820"/>
-            <a:ext cx="10607040" cy="1017270"/>
+            <a:off x="1097280" y="3867912"/>
+            <a:ext cx="10607040" cy="813816"/>
           </a:xfrm>
           <a:prstGeom prst="rect">
             <a:avLst/>
@@ -5028,7 +5028,7 @@
               <a:buNone/>
             </a:pPr>
             <a:r>
-              <a:rPr lang="en-US" sz="1650" dirty="0">
+              <a:rPr lang="en-US" sz="1500" dirty="0">
                 <a:solidFill>
                   <a:srgbClr val="1A1A1A"/>
                 </a:solidFill>
@@ -5036,9 +5036,9 @@
                 <a:ea typeface="Calibri" pitchFamily="34" charset="-122"/>
                 <a:cs typeface="Calibri" pitchFamily="34" charset="-120"/>
               </a:rPr>
-              <a:t>Your hand-count argument about run/running is the same decision, made with highlighters.</a:t>
-            </a:r>
-            <a:endParaRPr lang="en-US" sz="1650" dirty="0"/>
+              <a:t>Your hand-count argument about run/running is the same decision, made with highlighters. A stemmer makes it by rule (and produces "beauti"); a lemmatizer makes it by dictionary (and reads "was" as a noun unless told otherwise).</a:t>
+            </a:r>
+            <a:endParaRPr lang="en-US" sz="1500" dirty="0"/>
           </a:p>
         </p:txBody>
       </p:sp>
@@ -5050,7 +5050,7 @@
         </p:nvSpPr>
         <p:spPr>
           <a:xfrm>
-            <a:off x="640080" y="5383530"/>
+            <a:off x="640080" y="4773168"/>
             <a:ext cx="201168" cy="201168"/>
           </a:xfrm>
           <a:prstGeom prst="ellipse">
@@ -5070,8 +5070,8 @@
         </p:nvSpPr>
         <p:spPr>
           <a:xfrm>
-            <a:off x="1097280" y="5292090"/>
-            <a:ext cx="10607040" cy="1017270"/>
+            <a:off x="1097280" y="4681728"/>
+            <a:ext cx="10607040" cy="813816"/>
           </a:xfrm>
           <a:prstGeom prst="rect">
             <a:avLst/>
@@ -5092,7 +5092,7 @@
               <a:buNone/>
             </a:pPr>
             <a:r>
-              <a:rPr lang="en-US" sz="1650" dirty="0">
+              <a:rPr lang="en-US" sz="1500" dirty="0">
                 <a:solidFill>
                   <a:srgbClr val="1A1A1A"/>
                 </a:solidFill>
@@ -5100,9 +5100,73 @@
                 <a:ea typeface="Calibri" pitchFamily="34" charset="-122"/>
                 <a:cs typeface="Calibri" pitchFamily="34" charset="-120"/>
               </a:rPr>
+              <a:t>Zipf's law: rank words by frequency and every corpus gives the same curve. The head is the stop list; the tail is too rare to count.</a:t>
+            </a:r>
+            <a:endParaRPr lang="en-US" sz="1500" dirty="0"/>
+          </a:p>
+        </p:txBody>
+      </p:sp>
+      <p:sp>
+        <p:nvSpPr>
+          <p:cNvPr id="13" name="Shape 11"/>
+          <p:cNvSpPr/>
+          <p:nvPr/>
+        </p:nvSpPr>
+        <p:spPr>
+          <a:xfrm>
+            <a:off x="640080" y="5586984"/>
+            <a:ext cx="201168" cy="201168"/>
+          </a:xfrm>
+          <a:prstGeom prst="ellipse">
+            <a:avLst/>
+          </a:prstGeom>
+          <a:solidFill>
+            <a:srgbClr val="3F6F5F"/>
+          </a:solidFill>
+          <a:ln/>
+        </p:spPr>
+      </p:sp>
+      <p:sp>
+        <p:nvSpPr>
+          <p:cNvPr id="14" name="Text 12"/>
+          <p:cNvSpPr/>
+          <p:nvPr/>
+        </p:nvSpPr>
+        <p:spPr>
+          <a:xfrm>
+            <a:off x="1097280" y="5495544"/>
+            <a:ext cx="10607040" cy="813816"/>
+          </a:xfrm>
+          <a:prstGeom prst="rect">
+            <a:avLst/>
+          </a:prstGeom>
+          <a:noFill/>
+          <a:ln/>
+        </p:spPr>
+        <p:txBody>
+          <a:bodyPr wrap="square" rtlCol="0" anchor="t">
+            <a:spAutoFit/>
+          </a:bodyPr>
+          <a:lstStyle/>
+          <a:p>
+            <a:pPr indent="0" marL="0">
+              <a:lnSpc>
+                <a:spcPct val="112000"/>
+              </a:lnSpc>
+              <a:buNone/>
+            </a:pPr>
+            <a:r>
+              <a:rPr lang="en-US" sz="1500" dirty="0">
+                <a:solidFill>
+                  <a:srgbClr val="1A1A1A"/>
+                </a:solidFill>
+                <a:latin typeface="Calibri" pitchFamily="34" charset="0"/>
+                <a:ea typeface="Calibri" pitchFamily="34" charset="-122"/>
+                <a:cs typeface="Calibri" pitchFamily="34" charset="-120"/>
+              </a:rPr>
               <a:t>tf-idf: down-weight what is common everywhere. "Common here, rare overall" is what characterizes a text.</a:t>
             </a:r>
-            <a:endParaRPr lang="en-US" sz="1650" dirty="0"/>
+            <a:endParaRPr lang="en-US" sz="1500" dirty="0"/>
           </a:p>
         </p:txBody>
       </p:sp>
@@ -6942,7 +7006,7 @@
                 <a:ea typeface="Calibri" pitchFamily="34" charset="-122"/>
                 <a:cs typeface="Calibri" pitchFamily="34" charset="-120"/>
               </a:rPr>
-              <a:t>What counts as a word? Paste a sentence into two tokenizer playgrounds and watch it shatter differently. Models see tokens, not words.</a:t>
+              <a:t>What counts as a word? Paste a sentence into two tokenizer playgrounds and watch it shatter differently. Models see tokens, not words. Then the standard tools for the run/running decision: NLTK stemming and lemmatization, a real stop list, and Zipf's law, the curve that explains why stop lists exist.</a:t>
             </a:r>
             <a:endParaRPr lang="en-US" sz="1100" dirty="0"/>
           </a:p>

</xml_diff>

<commit_message>
Week 2 clustering on live Reddit comments (3 subreddits, streaming); fix Week 3 subreddit loader (per-sub configs never existed, now streams parquet shards)
</commit_message>
<xml_diff>
--- a/slides/pptx/week-02.pptx
+++ b/slides/pptx/week-02.pptx
@@ -4769,7 +4769,7 @@
                 <a:ea typeface="Calibri" pitchFamily="34" charset="-122"/>
                 <a:cs typeface="Calibri" pitchFamily="34" charset="-120"/>
               </a:rPr>
-              <a:t>N-grams and statistics, hands-on: bigrams across three corpora, distributions and mean-versus-median on real counts, rates per 1,000 words. Then tf-idf ("common here, rare overall") and k-means clustering: the counts separate verse from prose and split the sonnets in two, a lesson in what clustering actually answers.</a:t>
+              <a:t>N-grams and statistics, hands-on: bigrams across three corpora, distributions and mean-versus-median on real counts, rates per 1,000 words. Then tf-idf ("common here, rare overall") and k-means on 360 live Reddit comments from three subreddits: raw counts give a blob, tf-idf plus 60 dimensions sorts six in seven comments with their community. The representation, not the algorithm, does the work.</a:t>
             </a:r>
             <a:endParaRPr lang="en-US" sz="1100" dirty="0"/>
           </a:p>
@@ -8844,7 +8844,7 @@
                 <a:ea typeface="Cambria" pitchFamily="34" charset="-122"/>
                 <a:cs typeface="Cambria" pitchFamily="34" charset="-120"/>
               </a:rPr>
-              <a:t>Clustering: what do the counts separate?</a:t>
+              <a:t>Clustering: three communities, separable from counts alone</a:t>
             </a:r>
             <a:endParaRPr lang="en-US" sz="3000" dirty="0"/>
           </a:p>
@@ -8908,7 +8908,7 @@
                 <a:ea typeface="Calibri" pitchFamily="34" charset="-122"/>
                 <a:cs typeface="Calibri" pitchFamily="34" charset="-120"/>
               </a:rPr>
-              <a:t>Give k-means the 314 documents as tf-idf vectors and ask for three piles, no labels. It returns: novels in one pile, sonnets split across two.</a:t>
+              <a:t>360 Reddit comments from r/buildapc, r/gardening, and r/relationship_advice, streamed live (analyze-only: counts and findings are published, the text and usernames never are). k-means gets no labels.</a:t>
             </a:r>
             <a:endParaRPr lang="en-US" sz="1650" dirty="0"/>
           </a:p>
@@ -8972,7 +8972,7 @@
                 <a:ea typeface="Calibri" pitchFamily="34" charset="-122"/>
                 <a:cs typeface="Calibri" pitchFamily="34" charset="-120"/>
               </a:rPr>
-              <a:t>It found the loudest differences, verse against prose and a divide inside the sonnets, not the three books you had in mind. Clustering answers its own question.</a:t>
+              <a:t>Raw counts: one blob, the everywhere-words dominate. tf-idf: better, still smeared. tf-idf compressed to 60 dimensions: about six comments in seven land with their community.</a:t>
             </a:r>
             <a:endParaRPr lang="en-US" sz="1650" dirty="0"/>
           </a:p>
@@ -9036,7 +9036,7 @@
                 <a:ea typeface="Calibri" pitchFamily="34" charset="-122"/>
                 <a:cs typeface="Calibri" pitchFamily="34" charset="-120"/>
               </a:rPr>
-              <a:t>The ablation: on raw counts, k-means returns one giant blob. The everywhere-words dominate the geometry; tf-idf is what makes the space navigable.</a:t>
+              <a:t>The algorithm never changed; the representation did. Same data, same k-means, three answers, which previews Week 5's whole move: replace word columns with learned dimensions.</a:t>
             </a:r>
             <a:endParaRPr lang="en-US" sz="1650" dirty="0"/>
           </a:p>
@@ -9100,7 +9100,7 @@
                 <a:ea typeface="Calibri" pitchFamily="34" charset="-122"/>
                 <a:cs typeface="Calibri" pitchFamily="34" charset="-120"/>
               </a:rPr>
-              <a:t>Novels only, two piles: about three in four paragraphs sort by author. Real signal, not a clean one. Name what separated before you claim it.</a:t>
+              <a:t>Read the stragglers: a gardening comment about a partner sorts with relationship_advice. The cluster found vocabulary; vocabulary mostly tracks community. Name what separated before you claim it.</a:t>
             </a:r>
             <a:endParaRPr lang="en-US" sz="1650" dirty="0"/>
           </a:p>

</xml_diff>

<commit_message>
r/sandiego vs r/SanDiegan: Week 3 classifier default pair (Arctic Shift loader, 3-tier fallback); Week 2 hard-version clustering go-further
</commit_message>
<xml_diff>
--- a/slides/pptx/week-02.pptx
+++ b/slides/pptx/week-02.pptx
@@ -8879,7 +8879,7 @@
         <p:spPr>
           <a:xfrm>
             <a:off x="1097280" y="2240280"/>
-            <a:ext cx="10607040" cy="1017270"/>
+            <a:ext cx="10607040" cy="813816"/>
           </a:xfrm>
           <a:prstGeom prst="rect">
             <a:avLst/>
@@ -8900,7 +8900,7 @@
               <a:buNone/>
             </a:pPr>
             <a:r>
-              <a:rPr lang="en-US" sz="1650" dirty="0">
+              <a:rPr lang="en-US" sz="1500" dirty="0">
                 <a:solidFill>
                   <a:srgbClr val="1A1A1A"/>
                 </a:solidFill>
@@ -8910,7 +8910,7 @@
               </a:rPr>
               <a:t>360 Reddit comments from r/buildapc, r/gardening, and r/relationship_advice, streamed live (analyze-only: counts and findings are published, the text and usernames never are). k-means gets no labels.</a:t>
             </a:r>
-            <a:endParaRPr lang="en-US" sz="1650" dirty="0"/>
+            <a:endParaRPr lang="en-US" sz="1500" dirty="0"/>
           </a:p>
         </p:txBody>
       </p:sp>
@@ -8922,7 +8922,7 @@
         </p:nvSpPr>
         <p:spPr>
           <a:xfrm>
-            <a:off x="640080" y="3348990"/>
+            <a:off x="640080" y="3145536"/>
             <a:ext cx="201168" cy="201168"/>
           </a:xfrm>
           <a:prstGeom prst="ellipse">
@@ -8942,8 +8942,8 @@
         </p:nvSpPr>
         <p:spPr>
           <a:xfrm>
-            <a:off x="1097280" y="3257550"/>
-            <a:ext cx="10607040" cy="1017270"/>
+            <a:off x="1097280" y="3054096"/>
+            <a:ext cx="10607040" cy="813816"/>
           </a:xfrm>
           <a:prstGeom prst="rect">
             <a:avLst/>
@@ -8964,7 +8964,7 @@
               <a:buNone/>
             </a:pPr>
             <a:r>
-              <a:rPr lang="en-US" sz="1650" dirty="0">
+              <a:rPr lang="en-US" sz="1500" dirty="0">
                 <a:solidFill>
                   <a:srgbClr val="1A1A1A"/>
                 </a:solidFill>
@@ -8974,7 +8974,7 @@
               </a:rPr>
               <a:t>Raw counts: one blob, the everywhere-words dominate. tf-idf: better, still smeared. tf-idf compressed to 60 dimensions: about six comments in seven land with their community.</a:t>
             </a:r>
-            <a:endParaRPr lang="en-US" sz="1650" dirty="0"/>
+            <a:endParaRPr lang="en-US" sz="1500" dirty="0"/>
           </a:p>
         </p:txBody>
       </p:sp>
@@ -8986,7 +8986,7 @@
         </p:nvSpPr>
         <p:spPr>
           <a:xfrm>
-            <a:off x="640080" y="4366260"/>
+            <a:off x="640080" y="3959352"/>
             <a:ext cx="201168" cy="201168"/>
           </a:xfrm>
           <a:prstGeom prst="ellipse">
@@ -9006,8 +9006,8 @@
         </p:nvSpPr>
         <p:spPr>
           <a:xfrm>
-            <a:off x="1097280" y="4274820"/>
-            <a:ext cx="10607040" cy="1017270"/>
+            <a:off x="1097280" y="3867912"/>
+            <a:ext cx="10607040" cy="813816"/>
           </a:xfrm>
           <a:prstGeom prst="rect">
             <a:avLst/>
@@ -9028,7 +9028,7 @@
               <a:buNone/>
             </a:pPr>
             <a:r>
-              <a:rPr lang="en-US" sz="1650" dirty="0">
+              <a:rPr lang="en-US" sz="1500" dirty="0">
                 <a:solidFill>
                   <a:srgbClr val="1A1A1A"/>
                 </a:solidFill>
@@ -9038,7 +9038,7 @@
               </a:rPr>
               <a:t>The algorithm never changed; the representation did. Same data, same k-means, three answers, which previews Week 5's whole move: replace word columns with learned dimensions.</a:t>
             </a:r>
-            <a:endParaRPr lang="en-US" sz="1650" dirty="0"/>
+            <a:endParaRPr lang="en-US" sz="1500" dirty="0"/>
           </a:p>
         </p:txBody>
       </p:sp>
@@ -9050,7 +9050,7 @@
         </p:nvSpPr>
         <p:spPr>
           <a:xfrm>
-            <a:off x="640080" y="5383530"/>
+            <a:off x="640080" y="4773168"/>
             <a:ext cx="201168" cy="201168"/>
           </a:xfrm>
           <a:prstGeom prst="ellipse">
@@ -9070,8 +9070,8 @@
         </p:nvSpPr>
         <p:spPr>
           <a:xfrm>
-            <a:off x="1097280" y="5292090"/>
-            <a:ext cx="10607040" cy="1017270"/>
+            <a:off x="1097280" y="4681728"/>
+            <a:ext cx="10607040" cy="813816"/>
           </a:xfrm>
           <a:prstGeom prst="rect">
             <a:avLst/>
@@ -9092,7 +9092,7 @@
               <a:buNone/>
             </a:pPr>
             <a:r>
-              <a:rPr lang="en-US" sz="1650" dirty="0">
+              <a:rPr lang="en-US" sz="1500" dirty="0">
                 <a:solidFill>
                   <a:srgbClr val="1A1A1A"/>
                 </a:solidFill>
@@ -9102,7 +9102,71 @@
               </a:rPr>
               <a:t>Read the stragglers: a gardening comment about a partner sorts with relationship_advice. The cluster found vocabulary; vocabulary mostly tracks community. Name what separated before you claim it.</a:t>
             </a:r>
-            <a:endParaRPr lang="en-US" sz="1650" dirty="0"/>
+            <a:endParaRPr lang="en-US" sz="1500" dirty="0"/>
+          </a:p>
+        </p:txBody>
+      </p:sp>
+      <p:sp>
+        <p:nvSpPr>
+          <p:cNvPr id="13" name="Shape 11"/>
+          <p:cNvSpPr/>
+          <p:nvPr/>
+        </p:nvSpPr>
+        <p:spPr>
+          <a:xfrm>
+            <a:off x="640080" y="5586984"/>
+            <a:ext cx="201168" cy="201168"/>
+          </a:xfrm>
+          <a:prstGeom prst="ellipse">
+            <a:avLst/>
+          </a:prstGeom>
+          <a:solidFill>
+            <a:srgbClr val="3F6F5F"/>
+          </a:solidFill>
+          <a:ln/>
+        </p:spPr>
+      </p:sp>
+      <p:sp>
+        <p:nvSpPr>
+          <p:cNvPr id="14" name="Text 12"/>
+          <p:cNvSpPr/>
+          <p:nvPr/>
+        </p:nvSpPr>
+        <p:spPr>
+          <a:xfrm>
+            <a:off x="1097280" y="5495544"/>
+            <a:ext cx="10607040" cy="813816"/>
+          </a:xfrm>
+          <a:prstGeom prst="rect">
+            <a:avLst/>
+          </a:prstGeom>
+          <a:noFill/>
+          <a:ln/>
+        </p:spPr>
+        <p:txBody>
+          <a:bodyPr wrap="square" rtlCol="0" anchor="t">
+            <a:spAutoFit/>
+          </a:bodyPr>
+          <a:lstStyle/>
+          <a:p>
+            <a:pPr indent="0" marL="0">
+              <a:lnSpc>
+                <a:spcPct val="112000"/>
+              </a:lnSpc>
+              <a:buNone/>
+            </a:pPr>
+            <a:r>
+              <a:rPr lang="en-US" sz="1500" dirty="0">
+                <a:solidFill>
+                  <a:srgbClr val="1A1A1A"/>
+                </a:solidFill>
+                <a:latin typeface="Calibri" pitchFamily="34" charset="0"/>
+                <a:ea typeface="Calibri" pitchFamily="34" charset="-122"/>
+                <a:cs typeface="Calibri" pitchFamily="34" charset="-120"/>
+              </a:rPr>
+              <a:t>The hard version, in the go-further: r/sandiego against r/SanDiegan, one city, two communities. Clustering barely beats a coin flip, and even Week 3's supervised classifier reaches only about 60 percent. Topic is easy; community-within-topic is hard.</a:t>
+            </a:r>
+            <a:endParaRPr lang="en-US" sz="1500" dirty="0"/>
           </a:p>
         </p:txBody>
       </p:sp>

</xml_diff>

<commit_message>
Week 2 art: cluster Met paintings by 27-bucket color counts (portraits vs landscapes), thumbnails shown per pile
</commit_message>
<xml_diff>
--- a/slides/pptx/week-02.pptx
+++ b/slides/pptx/week-02.pptx
@@ -4769,7 +4769,7 @@
                 <a:ea typeface="Calibri" pitchFamily="34" charset="-122"/>
                 <a:cs typeface="Calibri" pitchFamily="34" charset="-120"/>
               </a:rPr>
-              <a:t>N-grams and statistics, hands-on: bigrams across three corpora, distributions and mean-versus-median on real counts, rates per 1,000 words. Then tf-idf ("common here, rare overall") and k-means on 360 live Reddit comments from three subreddits: raw counts give a blob, tf-idf plus 60 dimensions sorts six in seven comments with their community. The representation, not the algorithm, does the work.</a:t>
+              <a:t>N-grams and statistics, hands-on: bigrams across three corpora, distributions and mean-versus-median on real counts, rates per 1,000 words. Then tf-idf ("common here, rare overall") and k-means on 360 live Reddit comments from three subreddits: raw counts give a blob, tf-idf plus 60 dimensions sorts six in seven comments with their community. The representation, not the algorithm, does the work. Closer: the same k-means on twenty Met paintings counted into 27 color buckets sorts portraits from landscapes, three in four.</a:t>
             </a:r>
             <a:endParaRPr lang="en-US" sz="1100" dirty="0"/>
           </a:p>
@@ -8879,7 +8879,7 @@
         <p:spPr>
           <a:xfrm>
             <a:off x="1097280" y="2240280"/>
-            <a:ext cx="10607040" cy="813816"/>
+            <a:ext cx="10607040" cy="678180"/>
           </a:xfrm>
           <a:prstGeom prst="rect">
             <a:avLst/>
@@ -8922,7 +8922,7 @@
         </p:nvSpPr>
         <p:spPr>
           <a:xfrm>
-            <a:off x="640080" y="3145536"/>
+            <a:off x="640080" y="3009900"/>
             <a:ext cx="201168" cy="201168"/>
           </a:xfrm>
           <a:prstGeom prst="ellipse">
@@ -8942,8 +8942,8 @@
         </p:nvSpPr>
         <p:spPr>
           <a:xfrm>
-            <a:off x="1097280" y="3054096"/>
-            <a:ext cx="10607040" cy="813816"/>
+            <a:off x="1097280" y="2918460"/>
+            <a:ext cx="10607040" cy="678180"/>
           </a:xfrm>
           <a:prstGeom prst="rect">
             <a:avLst/>
@@ -8986,7 +8986,7 @@
         </p:nvSpPr>
         <p:spPr>
           <a:xfrm>
-            <a:off x="640080" y="3959352"/>
+            <a:off x="640080" y="3688080"/>
             <a:ext cx="201168" cy="201168"/>
           </a:xfrm>
           <a:prstGeom prst="ellipse">
@@ -9006,8 +9006,8 @@
         </p:nvSpPr>
         <p:spPr>
           <a:xfrm>
-            <a:off x="1097280" y="3867912"/>
-            <a:ext cx="10607040" cy="813816"/>
+            <a:off x="1097280" y="3596640"/>
+            <a:ext cx="10607040" cy="678180"/>
           </a:xfrm>
           <a:prstGeom prst="rect">
             <a:avLst/>
@@ -9050,7 +9050,7 @@
         </p:nvSpPr>
         <p:spPr>
           <a:xfrm>
-            <a:off x="640080" y="4773168"/>
+            <a:off x="640080" y="4366260"/>
             <a:ext cx="201168" cy="201168"/>
           </a:xfrm>
           <a:prstGeom prst="ellipse">
@@ -9070,8 +9070,8 @@
         </p:nvSpPr>
         <p:spPr>
           <a:xfrm>
-            <a:off x="1097280" y="4681728"/>
-            <a:ext cx="10607040" cy="813816"/>
+            <a:off x="1097280" y="4274820"/>
+            <a:ext cx="10607040" cy="678180"/>
           </a:xfrm>
           <a:prstGeom prst="rect">
             <a:avLst/>
@@ -9114,7 +9114,7 @@
         </p:nvSpPr>
         <p:spPr>
           <a:xfrm>
-            <a:off x="640080" y="5586984"/>
+            <a:off x="640080" y="5044440"/>
             <a:ext cx="201168" cy="201168"/>
           </a:xfrm>
           <a:prstGeom prst="ellipse">
@@ -9134,8 +9134,8 @@
         </p:nvSpPr>
         <p:spPr>
           <a:xfrm>
-            <a:off x="1097280" y="5495544"/>
-            <a:ext cx="10607040" cy="813816"/>
+            <a:off x="1097280" y="4953000"/>
+            <a:ext cx="10607040" cy="678180"/>
           </a:xfrm>
           <a:prstGeom prst="rect">
             <a:avLst/>
@@ -9165,6 +9165,70 @@
                 <a:cs typeface="Calibri" pitchFamily="34" charset="-120"/>
               </a:rPr>
               <a:t>The hard version, in the go-further: r/sandiego against r/SanDiegan, one city, two communities. Clustering barely beats a coin flip, and even Week 3's supervised classifier reaches only about 60 percent. Topic is easy; community-within-topic is hard.</a:t>
+            </a:r>
+            <a:endParaRPr lang="en-US" sz="1500" dirty="0"/>
+          </a:p>
+        </p:txBody>
+      </p:sp>
+      <p:sp>
+        <p:nvSpPr>
+          <p:cNvPr id="15" name="Shape 13"/>
+          <p:cNvSpPr/>
+          <p:nvPr/>
+        </p:nvSpPr>
+        <p:spPr>
+          <a:xfrm>
+            <a:off x="640080" y="5722620"/>
+            <a:ext cx="201168" cy="201168"/>
+          </a:xfrm>
+          <a:prstGeom prst="ellipse">
+            <a:avLst/>
+          </a:prstGeom>
+          <a:solidFill>
+            <a:srgbClr val="B9852F"/>
+          </a:solidFill>
+          <a:ln/>
+        </p:spPr>
+      </p:sp>
+      <p:sp>
+        <p:nvSpPr>
+          <p:cNvPr id="16" name="Text 14"/>
+          <p:cNvSpPr/>
+          <p:nvPr/>
+        </p:nvSpPr>
+        <p:spPr>
+          <a:xfrm>
+            <a:off x="1097280" y="5631180"/>
+            <a:ext cx="10607040" cy="678180"/>
+          </a:xfrm>
+          <a:prstGeom prst="rect">
+            <a:avLst/>
+          </a:prstGeom>
+          <a:noFill/>
+          <a:ln/>
+        </p:spPr>
+        <p:txBody>
+          <a:bodyPr wrap="square" rtlCol="0" anchor="t">
+            <a:spAutoFit/>
+          </a:bodyPr>
+          <a:lstStyle/>
+          <a:p>
+            <a:pPr indent="0" marL="0">
+              <a:lnSpc>
+                <a:spcPct val="112000"/>
+              </a:lnSpc>
+              <a:buNone/>
+            </a:pPr>
+            <a:r>
+              <a:rPr lang="en-US" sz="1500" dirty="0">
+                <a:solidFill>
+                  <a:srgbClr val="1A1A1A"/>
+                </a:solidFill>
+                <a:latin typeface="Calibri" pitchFamily="34" charset="0"/>
+                <a:ea typeface="Calibri" pitchFamily="34" charset="-122"/>
+                <a:cs typeface="Calibri" pitchFamily="34" charset="-120"/>
+              </a:rPr>
+              <a:t>And the same move for pictures: twenty Met paintings counted into 27 color buckets, k-means, no labels. Portraits sort from landscapes three in four, and the stragglers (a brown winter landscape counts like a portrait) are the discussion.</a:t>
             </a:r>
             <a:endParaRPr lang="en-US" sz="1500" dirty="0"/>
           </a:p>

</xml_diff>

<commit_message>
Week 2 fully Reddit + image focused: three live communities replace sonnets/novels across tokenize, stop lists, stemming, Zipf, n-grams, stats, tf-idf, keyness, shuffle test, playground
</commit_message>
<xml_diff>
--- a/slides/pptx/week-02.pptx
+++ b/slides/pptx/week-02.pptx
@@ -4463,7 +4463,7 @@
                 <a:ea typeface="Calibri" pitchFamily="34" charset="-122"/>
                 <a:cs typeface="Calibri" pitchFamily="34" charset="-120"/>
               </a:rPr>
-              <a:t>Hand-built bag-of-words: two authors, highlighters, argue about merging run/running. Counting requires defining.</a:t>
+              <a:t>Hand-built bag-of-words: two communities, highlighters, argue about merging run/running. Counting requires defining.</a:t>
             </a:r>
             <a:endParaRPr lang="en-US" sz="1100" dirty="0"/>
           </a:p>
@@ -4769,7 +4769,7 @@
                 <a:ea typeface="Calibri" pitchFamily="34" charset="-122"/>
                 <a:cs typeface="Calibri" pitchFamily="34" charset="-120"/>
               </a:rPr>
-              <a:t>N-grams and statistics, hands-on: bigrams across three corpora, distributions and mean-versus-median on real counts, rates per 1,000 words. Then tf-idf at two scales, sonnets as documents and twelve whole subreddits as documents, each community sight-read from its distinctive words (cpu and coolers, roth and rates, puts and bears), and k-means on 360 live Reddit comments from three subreddits: raw counts give a blob, tf-idf plus 60 dimensions sorts six in seven comments with their community. The representation, not the algorithm, does the work. Closer: the same k-means on twenty Met paintings counted into 27 color buckets sorts portraits from landscapes, three in four.</a:t>
+              <a:t>N-grams and statistics, hands-on: bigrams across three corpora, distributions and mean-versus-median on real counts, rates per 1,000 words. Then tf-idf at two scales, single comments as documents and twelve whole subreddits as documents, each community sight-read from its distinctive words (cpu and coolers, roth and rates, puts and bears), and k-means on 360 live Reddit comments from three subreddits: raw counts give a blob, tf-idf plus 60 dimensions sorts six in seven comments with their community. The representation, not the algorithm, does the work. Closer: the same k-means on twenty Met paintings counted into 27 color buckets sorts portraits from landscapes, three in four.</a:t>
             </a:r>
             <a:endParaRPr lang="en-US" sz="1100" dirty="0"/>
           </a:p>
@@ -8132,7 +8132,7 @@
                 <a:ea typeface="Calibri" pitchFamily="34" charset="-122"/>
                 <a:cs typeface="Calibri" pitchFamily="34" charset="-120"/>
               </a:rPr>
-              <a:t>A bigram is two words in a row. Week 1 counted the sonnets' pairs; this week counts pairs across three corpora, and each book's top bigrams are already a fingerprint.</a:t>
+              <a:t>A bigram is two words in a row. Week 1 counted one corpus's pairs; this week counts pairs across three communities, and each subreddit's top bigrams are already a fingerprint.</a:t>
             </a:r>
             <a:endParaRPr lang="en-US" sz="1650" dirty="0"/>
           </a:p>
@@ -8520,7 +8520,7 @@
                 <a:ea typeface="Calibri" pitchFamily="34" charset="-122"/>
                 <a:cs typeface="Calibri" pitchFamily="34" charset="-120"/>
               </a:rPr>
-              <a:t>Habit one: look at the distribution before the mean. Count data is skewed: most paragraphs of Dracula contain "night" zero times, a few contain many. Mean and median disagree, and the mean alone misleads.</a:t>
+              <a:t>Habit one: look at the distribution before the mean. Count data is skewed: most r/gardening comments mention plants zero or one time, a few mention many. Mean and median disagree, and the mean alone misleads.</a:t>
             </a:r>
             <a:endParaRPr lang="en-US" sz="1650" dirty="0"/>
           </a:p>
@@ -8584,7 +8584,7 @@
                 <a:ea typeface="Calibri" pitchFamily="34" charset="-122"/>
                 <a:cs typeface="Calibri" pitchFamily="34" charset="-120"/>
               </a:rPr>
-              <a:t>Habit two: divide by a denominator. The novels outweigh all 154 sonnets combined, so raw totals always vote for the novels. Rates per 1,000 words: "love" is 10.8 in the sonnets, 0.7 in Frankenstein.</a:t>
+              <a:t>Habit two: divide by a denominator. Communities differ in how much they write, so raw totals mislead. Rates per 1,000 words: "water" is 3.9 in r/gardening and 0.1 elsewhere; "feel" is 1.8 in r/relationship_advice.</a:t>
             </a:r>
             <a:endParaRPr lang="en-US" sz="1650" dirty="0"/>
           </a:p>

</xml_diff>

<commit_message>
Week 2: standardization as fourth statistics habit (z-scores), variance-standardized keyness (Fightin' Words), lemmatization framed as standardization
</commit_message>
<xml_diff>
--- a/slides/pptx/week-02.pptx
+++ b/slides/pptx/week-02.pptx
@@ -2890,7 +2890,7 @@
         <p:spPr>
           <a:xfrm>
             <a:off x="1097280" y="2240280"/>
-            <a:ext cx="10607040" cy="1017270"/>
+            <a:ext cx="10607040" cy="813816"/>
           </a:xfrm>
           <a:prstGeom prst="rect">
             <a:avLst/>
@@ -2911,7 +2911,7 @@
               <a:buNone/>
             </a:pPr>
             <a:r>
-              <a:rPr lang="en-US" sz="1650" dirty="0">
+              <a:rPr lang="en-US" sz="1500" dirty="0">
                 <a:solidFill>
                   <a:srgbClr val="1A1A1A"/>
                 </a:solidFill>
@@ -2921,7 +2921,7 @@
               </a:rPr>
               <a:t>For every word: how much likelier is it in corpus A than corpus B? A log-odds ratio, smoothed so rare words don't explode.</a:t>
             </a:r>
-            <a:endParaRPr lang="en-US" sz="1650" dirty="0"/>
+            <a:endParaRPr lang="en-US" sz="1500" dirty="0"/>
           </a:p>
         </p:txBody>
       </p:sp>
@@ -2933,7 +2933,7 @@
         </p:nvSpPr>
         <p:spPr>
           <a:xfrm>
-            <a:off x="640080" y="3348990"/>
+            <a:off x="640080" y="3145536"/>
             <a:ext cx="201168" cy="201168"/>
           </a:xfrm>
           <a:prstGeom prst="ellipse">
@@ -2953,8 +2953,8 @@
         </p:nvSpPr>
         <p:spPr>
           <a:xfrm>
-            <a:off x="1097280" y="3257550"/>
-            <a:ext cx="10607040" cy="1017270"/>
+            <a:off x="1097280" y="3054096"/>
+            <a:ext cx="10607040" cy="813816"/>
           </a:xfrm>
           <a:prstGeom prst="rect">
             <a:avLst/>
@@ -2975,7 +2975,7 @@
               <a:buNone/>
             </a:pPr>
             <a:r>
-              <a:rPr lang="en-US" sz="1650" dirty="0">
+              <a:rPr lang="en-US" sz="1500" dirty="0">
                 <a:solidFill>
                   <a:srgbClr val="1A1A1A"/>
                 </a:solidFill>
@@ -2985,7 +2985,7 @@
               </a:rPr>
               <a:t>Strongly positive = distinctively A. Strongly negative = distinctively B. The middle is shared language.</a:t>
             </a:r>
-            <a:endParaRPr lang="en-US" sz="1650" dirty="0"/>
+            <a:endParaRPr lang="en-US" sz="1500" dirty="0"/>
           </a:p>
         </p:txBody>
       </p:sp>
@@ -2997,7 +2997,7 @@
         </p:nvSpPr>
         <p:spPr>
           <a:xfrm>
-            <a:off x="640080" y="4366260"/>
+            <a:off x="640080" y="3959352"/>
             <a:ext cx="201168" cy="201168"/>
           </a:xfrm>
           <a:prstGeom prst="ellipse">
@@ -3017,8 +3017,8 @@
         </p:nvSpPr>
         <p:spPr>
           <a:xfrm>
-            <a:off x="1097280" y="4274820"/>
-            <a:ext cx="10607040" cy="1017270"/>
+            <a:off x="1097280" y="3867912"/>
+            <a:ext cx="10607040" cy="813816"/>
           </a:xfrm>
           <a:prstGeom prst="rect">
             <a:avLst/>
@@ -3039,7 +3039,7 @@
               <a:buNone/>
             </a:pPr>
             <a:r>
-              <a:rPr lang="en-US" sz="1650" dirty="0">
+              <a:rPr lang="en-US" sz="1500" dirty="0">
                 <a:solidFill>
                   <a:srgbClr val="1A1A1A"/>
                 </a:solidFill>
@@ -3049,7 +3049,7 @@
               </a:rPr>
               <a:t>She Giggles, He Gallops is exactly this method: verbs after "she" vs. "he" in 2,000 screenplays. Women snuggle, giggle, squeal; men gallop, strap, shoot.</a:t>
             </a:r>
-            <a:endParaRPr lang="en-US" sz="1650" dirty="0"/>
+            <a:endParaRPr lang="en-US" sz="1500" dirty="0"/>
           </a:p>
         </p:txBody>
       </p:sp>
@@ -3061,7 +3061,7 @@
         </p:nvSpPr>
         <p:spPr>
           <a:xfrm>
-            <a:off x="640080" y="5383530"/>
+            <a:off x="640080" y="4773168"/>
             <a:ext cx="201168" cy="201168"/>
           </a:xfrm>
           <a:prstGeom prst="ellipse">
@@ -3081,8 +3081,8 @@
         </p:nvSpPr>
         <p:spPr>
           <a:xfrm>
-            <a:off x="1097280" y="5292090"/>
-            <a:ext cx="10607040" cy="1017270"/>
+            <a:off x="1097280" y="4681728"/>
+            <a:ext cx="10607040" cy="813816"/>
           </a:xfrm>
           <a:prstGeom prst="rect">
             <a:avLst/>
@@ -3103,7 +3103,7 @@
               <a:buNone/>
             </a:pPr>
             <a:r>
-              <a:rPr lang="en-US" sz="1650" dirty="0">
+              <a:rPr lang="en-US" sz="1500" dirty="0">
                 <a:solidFill>
                   <a:srgbClr val="1A1A1A"/>
                 </a:solidFill>
@@ -3111,9 +3111,73 @@
                 <a:ea typeface="Calibri" pitchFamily="34" charset="-122"/>
                 <a:cs typeface="Calibri" pitchFamily="34" charset="-120"/>
               </a:rPr>
+              <a:t>Standardize the log-odds by their variance (Monroe et al.'s Fightin' Words) and the lists change character: topic words sink, register surfaces. r/buildapc's strongest markers become you/your (an advice room), r/gardening's i/we/them (a stories room).</a:t>
+            </a:r>
+            <a:endParaRPr lang="en-US" sz="1500" dirty="0"/>
+          </a:p>
+        </p:txBody>
+      </p:sp>
+      <p:sp>
+        <p:nvSpPr>
+          <p:cNvPr id="13" name="Shape 11"/>
+          <p:cNvSpPr/>
+          <p:nvPr/>
+        </p:nvSpPr>
+        <p:spPr>
+          <a:xfrm>
+            <a:off x="640080" y="5586984"/>
+            <a:ext cx="201168" cy="201168"/>
+          </a:xfrm>
+          <a:prstGeom prst="ellipse">
+            <a:avLst/>
+          </a:prstGeom>
+          <a:solidFill>
+            <a:srgbClr val="3F6F5F"/>
+          </a:solidFill>
+          <a:ln/>
+        </p:spPr>
+      </p:sp>
+      <p:sp>
+        <p:nvSpPr>
+          <p:cNvPr id="14" name="Text 12"/>
+          <p:cNvSpPr/>
+          <p:nvPr/>
+        </p:nvSpPr>
+        <p:spPr>
+          <a:xfrm>
+            <a:off x="1097280" y="5495544"/>
+            <a:ext cx="10607040" cy="813816"/>
+          </a:xfrm>
+          <a:prstGeom prst="rect">
+            <a:avLst/>
+          </a:prstGeom>
+          <a:noFill/>
+          <a:ln/>
+        </p:spPr>
+        <p:txBody>
+          <a:bodyPr wrap="square" rtlCol="0" anchor="t">
+            <a:spAutoFit/>
+          </a:bodyPr>
+          <a:lstStyle/>
+          <a:p>
+            <a:pPr indent="0" marL="0">
+              <a:lnSpc>
+                <a:spcPct val="112000"/>
+              </a:lnSpc>
+              <a:buNone/>
+            </a:pPr>
+            <a:r>
+              <a:rPr lang="en-US" sz="1500" dirty="0">
+                <a:solidFill>
+                  <a:srgbClr val="1A1A1A"/>
+                </a:solidFill>
+                <a:latin typeface="Calibri" pitchFamily="34" charset="0"/>
+                <a:ea typeface="Calibri" pitchFamily="34" charset="-122"/>
+                <a:cs typeface="Calibri" pitchFamily="34" charset="-120"/>
+              </a:rPr>
               <a:t>The corpus pair is a choice: this artist against pop, this subreddit against a novel. Different pair, different "distinctive."</a:t>
             </a:r>
-            <a:endParaRPr lang="en-US" sz="1650" dirty="0"/>
+            <a:endParaRPr lang="en-US" sz="1500" dirty="0"/>
           </a:p>
         </p:txBody>
       </p:sp>
@@ -4769,7 +4833,7 @@
                 <a:ea typeface="Calibri" pitchFamily="34" charset="-122"/>
                 <a:cs typeface="Calibri" pitchFamily="34" charset="-120"/>
               </a:rPr>
-              <a:t>N-grams and statistics, hands-on: bigrams across three corpora, distributions and mean-versus-median on real counts, rates per 1,000 words. Then tf-idf at two scales, single comments as documents and twelve whole subreddits as documents, each community sight-read from its distinctive words (cpu and coolers, roth and rates, puts and bears), and k-means on 360 live Reddit comments from three subreddits: raw counts give a blob, tf-idf plus 60 dimensions sorts six in seven comments with their community. The representation, not the algorithm, does the work. Closer: the same k-means on twenty Met paintings counted into 27 color buckets sorts portraits from landscapes, three in four.</a:t>
+              <a:t>N-grams and statistics, hands-on: bigrams across three corpora, distributions and mean-versus-median on real counts, rates per 1,000 words, z-scores as the common scale. Then tf-idf at two scales, single comments as documents and twelve whole subreddits as documents, each community sight-read from its distinctive words (cpu and coolers, roth and rates, puts and bears), and k-means on 360 live Reddit comments from three subreddits: raw counts give a blob, tf-idf plus 60 dimensions sorts six in seven comments with their community. The representation, not the algorithm, does the work. Closer: the same k-means on twenty Met paintings counted into 27 color buckets sorts portraits from landscapes, three in four.</a:t>
             </a:r>
             <a:endParaRPr lang="en-US" sz="1100" dirty="0"/>
           </a:p>
@@ -8491,7 +8555,7 @@
         <p:spPr>
           <a:xfrm>
             <a:off x="1097280" y="2240280"/>
-            <a:ext cx="10607040" cy="1017270"/>
+            <a:ext cx="10607040" cy="813816"/>
           </a:xfrm>
           <a:prstGeom prst="rect">
             <a:avLst/>
@@ -8512,7 +8576,7 @@
               <a:buNone/>
             </a:pPr>
             <a:r>
-              <a:rPr lang="en-US" sz="1650" dirty="0">
+              <a:rPr lang="en-US" sz="1500" dirty="0">
                 <a:solidFill>
                   <a:srgbClr val="1A1A1A"/>
                 </a:solidFill>
@@ -8522,7 +8586,7 @@
               </a:rPr>
               <a:t>Habit one: look at the distribution before the mean. Count data is skewed: most r/gardening comments mention plants zero or one time, a few mention many. Mean and median disagree, and the mean alone misleads.</a:t>
             </a:r>
-            <a:endParaRPr lang="en-US" sz="1650" dirty="0"/>
+            <a:endParaRPr lang="en-US" sz="1500" dirty="0"/>
           </a:p>
         </p:txBody>
       </p:sp>
@@ -8534,7 +8598,7 @@
         </p:nvSpPr>
         <p:spPr>
           <a:xfrm>
-            <a:off x="640080" y="3348990"/>
+            <a:off x="640080" y="3145536"/>
             <a:ext cx="201168" cy="201168"/>
           </a:xfrm>
           <a:prstGeom prst="ellipse">
@@ -8554,8 +8618,8 @@
         </p:nvSpPr>
         <p:spPr>
           <a:xfrm>
-            <a:off x="1097280" y="3257550"/>
-            <a:ext cx="10607040" cy="1017270"/>
+            <a:off x="1097280" y="3054096"/>
+            <a:ext cx="10607040" cy="813816"/>
           </a:xfrm>
           <a:prstGeom prst="rect">
             <a:avLst/>
@@ -8576,7 +8640,7 @@
               <a:buNone/>
             </a:pPr>
             <a:r>
-              <a:rPr lang="en-US" sz="1650" dirty="0">
+              <a:rPr lang="en-US" sz="1500" dirty="0">
                 <a:solidFill>
                   <a:srgbClr val="1A1A1A"/>
                 </a:solidFill>
@@ -8586,7 +8650,7 @@
               </a:rPr>
               <a:t>Habit two: divide by a denominator. Communities differ in how much they write, so raw totals mislead. Rates per 1,000 words: "water" is 3.9 in r/gardening and 0.1 elsewhere; "feel" is 1.8 in r/relationship_advice.</a:t>
             </a:r>
-            <a:endParaRPr lang="en-US" sz="1650" dirty="0"/>
+            <a:endParaRPr lang="en-US" sz="1500" dirty="0"/>
           </a:p>
         </p:txBody>
       </p:sp>
@@ -8598,7 +8662,7 @@
         </p:nvSpPr>
         <p:spPr>
           <a:xfrm>
-            <a:off x="640080" y="4366260"/>
+            <a:off x="640080" y="3959352"/>
             <a:ext cx="201168" cy="201168"/>
           </a:xfrm>
           <a:prstGeom prst="ellipse">
@@ -8618,8 +8682,8 @@
         </p:nvSpPr>
         <p:spPr>
           <a:xfrm>
-            <a:off x="1097280" y="4274820"/>
-            <a:ext cx="10607040" cy="1017270"/>
+            <a:off x="1097280" y="3867912"/>
+            <a:ext cx="10607040" cy="813816"/>
           </a:xfrm>
           <a:prstGeom prst="rect">
             <a:avLst/>
@@ -8640,7 +8704,7 @@
               <a:buNone/>
             </a:pPr>
             <a:r>
-              <a:rPr lang="en-US" sz="1650" dirty="0">
+              <a:rPr lang="en-US" sz="1500" dirty="0">
                 <a:solidFill>
                   <a:srgbClr val="1A1A1A"/>
                 </a:solidFill>
@@ -8648,9 +8712,9 @@
                 <a:ea typeface="Calibri" pitchFamily="34" charset="-122"/>
                 <a:cs typeface="Calibri" pitchFamily="34" charset="-120"/>
               </a:rPr>
-              <a:t>Habit three: a gap between rates can still be luck. That is the shuffle test's question, and it closes the session.</a:t>
-            </a:r>
-            <a:endParaRPr lang="en-US" sz="1650" dirty="0"/>
+              <a:t>Habit three: standardize. A z-score rescales any number as distance from typical in units of spread: a comment with three plant mentions sits at z = +4.7, its 73-word length at +1.2. Unlike scales become comparable. Lemmatization is the same idea for word forms; the shuffle test is the same idea for gaps.</a:t>
+            </a:r>
+            <a:endParaRPr lang="en-US" sz="1500" dirty="0"/>
           </a:p>
         </p:txBody>
       </p:sp>
@@ -8662,7 +8726,7 @@
         </p:nvSpPr>
         <p:spPr>
           <a:xfrm>
-            <a:off x="640080" y="5383530"/>
+            <a:off x="640080" y="4773168"/>
             <a:ext cx="201168" cy="201168"/>
           </a:xfrm>
           <a:prstGeom prst="ellipse">
@@ -8682,8 +8746,8 @@
         </p:nvSpPr>
         <p:spPr>
           <a:xfrm>
-            <a:off x="1097280" y="5292090"/>
-            <a:ext cx="10607040" cy="1017270"/>
+            <a:off x="1097280" y="4681728"/>
+            <a:ext cx="10607040" cy="813816"/>
           </a:xfrm>
           <a:prstGeom prst="rect">
             <a:avLst/>
@@ -8704,7 +8768,7 @@
               <a:buNone/>
             </a:pPr>
             <a:r>
-              <a:rPr lang="en-US" sz="1650" dirty="0">
+              <a:rPr lang="en-US" sz="1500" dirty="0">
                 <a:solidFill>
                   <a:srgbClr val="1A1A1A"/>
                 </a:solidFill>
@@ -8712,9 +8776,73 @@
                 <a:ea typeface="Calibri" pitchFamily="34" charset="-122"/>
                 <a:cs typeface="Calibri" pitchFamily="34" charset="-120"/>
               </a:rPr>
+              <a:t>Habit four: a gap between rates can still be luck. That is the shuffle test's question, and it closes the session.</a:t>
+            </a:r>
+            <a:endParaRPr lang="en-US" sz="1500" dirty="0"/>
+          </a:p>
+        </p:txBody>
+      </p:sp>
+      <p:sp>
+        <p:nvSpPr>
+          <p:cNvPr id="13" name="Shape 11"/>
+          <p:cNvSpPr/>
+          <p:nvPr/>
+        </p:nvSpPr>
+        <p:spPr>
+          <a:xfrm>
+            <a:off x="640080" y="5586984"/>
+            <a:ext cx="201168" cy="201168"/>
+          </a:xfrm>
+          <a:prstGeom prst="ellipse">
+            <a:avLst/>
+          </a:prstGeom>
+          <a:solidFill>
+            <a:srgbClr val="3F6F5F"/>
+          </a:solidFill>
+          <a:ln/>
+        </p:spPr>
+      </p:sp>
+      <p:sp>
+        <p:nvSpPr>
+          <p:cNvPr id="14" name="Text 12"/>
+          <p:cNvSpPr/>
+          <p:nvPr/>
+        </p:nvSpPr>
+        <p:spPr>
+          <a:xfrm>
+            <a:off x="1097280" y="5495544"/>
+            <a:ext cx="10607040" cy="813816"/>
+          </a:xfrm>
+          <a:prstGeom prst="rect">
+            <a:avLst/>
+          </a:prstGeom>
+          <a:noFill/>
+          <a:ln/>
+        </p:spPr>
+        <p:txBody>
+          <a:bodyPr wrap="square" rtlCol="0" anchor="t">
+            <a:spAutoFit/>
+          </a:bodyPr>
+          <a:lstStyle/>
+          <a:p>
+            <a:pPr indent="0" marL="0">
+              <a:lnSpc>
+                <a:spcPct val="112000"/>
+              </a:lnSpc>
+              <a:buNone/>
+            </a:pPr>
+            <a:r>
+              <a:rPr lang="en-US" sz="1500" dirty="0">
+                <a:solidFill>
+                  <a:srgbClr val="1A1A1A"/>
+                </a:solidFill>
+                <a:latin typeface="Calibri" pitchFamily="34" charset="0"/>
+                <a:ea typeface="Calibri" pitchFamily="34" charset="-122"/>
+                <a:cs typeface="Calibri" pitchFamily="34" charset="-120"/>
+              </a:rPr>
               <a:t>A difference can be real and still small; a big difference can be an artifact of the denominator. Say which you have.</a:t>
             </a:r>
-            <a:endParaRPr lang="en-US" sz="1650" dirty="0"/>
+            <a:endParaRPr lang="en-US" sz="1500" dirty="0"/>
           </a:p>
         </p:txBody>
       </p:sp>

</xml_diff>

<commit_message>
Week 2 reading: Underwood's Textual Distances replaces Wolfram (builds the space-of-culture concept, preps Week 3 classification); Wolfram to supplement
</commit_message>
<xml_diff>
--- a/slides/pptx/week-02.pptx
+++ b/slides/pptx/week-02.pptx
@@ -6264,7 +6264,7 @@
                 <a:ea typeface="Calibri" pitchFamily="34" charset="-122"/>
                 <a:cs typeface="Calibri" pitchFamily="34" charset="-120"/>
               </a:rPr>
-              <a:t>Wolfram, What Is ChatGPT Doing (opening sections only)</a:t>
+              <a:t>Underwood, The Historical Significance of Textual Distances (2018): does near-in-count-space mean near-in-culture?</a:t>
             </a:r>
             <a:endParaRPr lang="en-US" sz="1400" dirty="0"/>
           </a:p>
@@ -6364,7 +6364,7 @@
                 <a:ea typeface="Calibri" pitchFamily="34" charset="-122"/>
                 <a:cs typeface="Calibri" pitchFamily="34" charset="-120"/>
               </a:rPr>
-              <a:t>Zipf's law, the straight line in every text</a:t>
+              <a:t>Wolfram, What Is ChatGPT Doing (opening sections only), where even generation turns out to be counting</a:t>
             </a:r>
             <a:endParaRPr lang="en-US" sz="1400" dirty="0"/>
           </a:p>

</xml_diff>

<commit_message>
Week 2 reading becomes a debate: Underwood vs Da, CI forum as supplement; Wolfram to Week 8; Da reread reframed at Week 8 deeper
</commit_message>
<xml_diff>
--- a/slides/pptx/week-02.pptx
+++ b/slides/pptx/week-02.pptx
@@ -6264,7 +6264,7 @@
                 <a:ea typeface="Calibri" pitchFamily="34" charset="-122"/>
                 <a:cs typeface="Calibri" pitchFamily="34" charset="-120"/>
               </a:rPr>
-              <a:t>Underwood, The Historical Significance of Textual Distances (2018): does near-in-count-space mean near-in-culture?</a:t>
+              <a:t>The debate: Underwood, The Historical Significance of Textual Distances (2018) against Da, The Computational Case Against Computational Literary Studies (2019), introduction and one case study</a:t>
             </a:r>
             <a:endParaRPr lang="en-US" sz="1400" dirty="0"/>
           </a:p>
@@ -6364,7 +6364,7 @@
                 <a:ea typeface="Calibri" pitchFamily="34" charset="-122"/>
                 <a:cs typeface="Calibri" pitchFamily="34" charset="-120"/>
               </a:rPr>
-              <a:t>Wolfram, What Is ChatGPT Doing (opening sections only), where even generation turns out to be counting</a:t>
+              <a:t>the Critical Inquiry online forum (free): the field answers Da, Underwood included, and Da answers back</a:t>
             </a:r>
             <a:endParaRPr lang="en-US" sz="1400" dirty="0"/>
           </a:p>

</xml_diff>

<commit_message>
Reading rebalance: fun-first mains (Hip Hop Vocabulary W2, Selfiecity W6, Pudding build guide W9), field debates demoted to supplement/deeper tiers, forum dupe removed
</commit_message>
<xml_diff>
--- a/slides/pptx/week-02.pptx
+++ b/slides/pptx/week-02.pptx
@@ -6264,7 +6264,7 @@
                 <a:ea typeface="Calibri" pitchFamily="34" charset="-122"/>
                 <a:cs typeface="Calibri" pitchFamily="34" charset="-120"/>
               </a:rPr>
-              <a:t>The debate: Underwood, The Historical Significance of Textual Distances (2018) against Da, The Computational Case Against Computational Literary Studies (2019), introduction and one case study</a:t>
+              <a:t>Matt Daniels, The Largest Vocabulary in Hip Hop (The Pudding): 150 rappers ranked by unique words, token analysis exactly as in today's session, caveats and all</a:t>
             </a:r>
             <a:endParaRPr lang="en-US" sz="1400" dirty="0"/>
           </a:p>
@@ -6364,7 +6364,7 @@
                 <a:ea typeface="Calibri" pitchFamily="34" charset="-122"/>
                 <a:cs typeface="Calibri" pitchFamily="34" charset="-120"/>
               </a:rPr>
-              <a:t>the Critical Inquiry online forum (free): the field answers Da, Underwood included, and Da answers back</a:t>
+              <a:t>For the curious, the field's own version of today's trial: Underwood, Textual Distances (2018) vs. Da, The Computational Case (2019), with the free forum where the field argues back</a:t>
             </a:r>
             <a:endParaRPr lang="en-US" sz="1400" dirty="0"/>
           </a:p>

</xml_diff>

<commit_message>
Week 2: participatory clustering round (propose, predict, one-call cluster_communities, score the room); fix stale 6-in-7 ratio
</commit_message>
<xml_diff>
--- a/slides/pptx/week-02.pptx
+++ b/slides/pptx/week-02.pptx
@@ -5787,7 +5787,7 @@
                 <a:ea typeface="Calibri" pitchFamily="34" charset="-122"/>
                 <a:cs typeface="Calibri" pitchFamily="34" charset="-120"/>
               </a:rPr>
-              <a:t>N-grams and statistics, hands-on: bigrams across three corpora, distributions and mean-versus-median on real counts, rates per 1,000 words, z-scores as the common scale. Then tf-idf at two scales, single comments as documents and twelve whole subreddits as documents, each community sight-read from its distinctive words (cpu and coolers, roth and rates, puts and bears), then the idea of a space made explicit (documents as points, one axis per word, a two-word space drawn), and k-means on the live comments: raw counts give a blob, tf-idf plus 60 dimensions sorts six in seven comments with their community. The representation, not the algorithm, does the work. Closer: the same k-means on twenty Met paintings counted into 27 color buckets sorts portraits from landscapes, three in four.</a:t>
+              <a:t>N-grams and statistics, hands-on: bigrams across three corpora, distributions and mean-versus-median on real counts, rates per 1,000 words, z-scores as the common scale. Then tf-idf at two scales, single comments as documents and twelve whole subreddits as documents, each community sight-read from its distinctive words (cpu and coolers, roth and rates, puts and bears), then the idea of a space made explicit (documents as points, one axis per word, a two-word space drawn), and k-means on the live comments: raw counts give a blob, tf-idf plus 60 dimensions sorts about four comments in five with their community. The representation, not the algorithm, does the work. Then the room drives: propose a question, pick three communities, everyone predicts which stands alone and which two blur, one call clusters them live, and the table scores the room. Closer: the same k-means on twenty Met paintings counted into 27 color buckets sorts portraits from landscapes, three in four.</a:t>
             </a:r>
             <a:endParaRPr lang="en-US" sz="1100" dirty="0"/>
           </a:p>
@@ -10442,7 +10442,7 @@
                 <a:ea typeface="Calibri" pitchFamily="34" charset="-122"/>
                 <a:cs typeface="Calibri" pitchFamily="34" charset="-120"/>
               </a:rPr>
-              <a:t>Raw counts: one blob, the everywhere-words dominate. tf-idf: better, still smeared. tf-idf compressed to 60 dimensions: about six comments in seven land with their community.</a:t>
+              <a:t>Raw counts: one blob, the everywhere-words dominate. tf-idf: better, still smeared. tf-idf compressed to 60 dimensions: about four comments in five land with their community.</a:t>
             </a:r>
             <a:endParaRPr lang="en-US" sz="1500" dirty="0"/>
           </a:p>

</xml_diff>